<commit_message>
Thêm trang Thử thách: trò chơi kéo thả đỉnh tứ giác, Neo4j chấm điểm và bảng xếp hạng
</commit_message>
<xml_diff>
--- a/docs/3_Thuyet_trinh.pptx
+++ b/docs/3_Thuyet_trinh.pptx
@@ -22,9 +22,10 @@
     <p:sldId id="270" r:id="rId16"/>
     <p:sldId id="271" r:id="rId17"/>
     <p:sldId id="272" r:id="rId18"/>
+    <p:sldId id="273" r:id="rId19"/>
   </p:sldIdLst>
   <p:notesMasterIdLst>
-    <p:notesMasterId r:id="rId19"/>
+    <p:notesMasterId r:id="rId20"/>
   </p:notesMasterIdLst>
   <p:sldSz cx="12192000" cy="6858000"/>
   <p:notesSz cx="6858000" cy="12192000"/>
@@ -1046,7 +1047,7 @@
           <a:p>
             <a:r>
               <a:rPr lang="en-US" dirty="0"/>
-              <a:t>Kết quả: hệ thống có 26 dấu hiệu nhận biết và 68 công thức. Toàn bộ 115 truy vấn mà ứng dụng gửi tới Neo4j đều cho kết quả khớp với kết quả tính độc lập, và 32 ca kiểm thử tự động đều đạt. Nhóm hoàn thành 4 nhóm chức năng như bên dưới.</a:t>
+              <a:t>Chức năng thứ ba là trò chơi Thử thách. Màn hình có một tứ giác trên lưới ô vuông, đề yêu cầu tạo một hình, ví dụ hình thang. Người chơi kéo các đỉnh; mỗi lần thả chuột, toạ độ được đổi thành các tính chất như song song, bằng nhau, góc vuông, rồi đưa vào đúng bộ suy luận Neo4j. Nếu Neo4j kết luận đúng hình yêu cầu thì cộng điểm và sang thử thách tiếp theo, từ hình thang tới hình vuông. Nếu tạo ra trường hợp đặc biệt, ví dụ đề là hình thang vuông mà kéo ra hình chữ nhật, hệ thống báo gần đúng. Điểm được lưu vào Neo4j thành nút LuotChoi để làm bảng xếp hạng.</a:t>
             </a:r>
             <a:endParaRPr lang="en-US" dirty="0"/>
           </a:p>
@@ -1134,7 +1135,7 @@
           <a:p>
             <a:r>
               <a:rPr lang="en-US" dirty="0"/>
-              <a:t>Hạn chế hiện tại: nhận dạng dựa trên tính chất định tính, chưa nhận toạ độ; lời giải chưa chi tiết tới từng cạnh; chỉ xét tứ giác lồi. Hướng phát triển: cho nhập toạ độ đỉnh, mở rộng sang tam giác, đa giác và gợi ý bài tập dựa trên lịch sử học.</a:t>
+              <a:t>Kết quả: hệ thống có 26 dấu hiệu nhận biết và 68 công thức. Toàn bộ 187 truy vấn mà ứng dụng gửi tới Neo4j, kể cả các truy vấn của trò chơi Thử thách, đều cho kết quả khớp với kết quả tính độc lập, và 45 ca kiểm thử tự động đều đạt. Nhóm hoàn thành 4 nhóm chức năng như bên dưới, trong đó có trò chơi Thử thách.</a:t>
             </a:r>
             <a:endParaRPr lang="en-US" dirty="0"/>
           </a:p>
@@ -1222,7 +1223,7 @@
           <a:p>
             <a:r>
               <a:rPr lang="en-US" dirty="0"/>
-              <a:t>Nhóm em xin cảm ơn thầy và các bạn đã lắng nghe. Nhóm sẵn sàng trả lời câu hỏi.</a:t>
+              <a:t>Hạn chế hiện tại: nhận dạng từ toạ độ mới có ở trò chơi và chỉ với toạ độ nguyên; lời giải chưa chi tiết tới từng cạnh; chỉ xét tứ giác lồi. Hướng phát triển: dùng toạ độ để tính diện tích, chu vi, mở rộng sang tam giác, đa giác và dùng dữ liệu lượt chơi để gợi ý bài tập.</a:t>
             </a:r>
             <a:endParaRPr lang="en-US" dirty="0"/>
           </a:p>
@@ -1246,6 +1247,94 @@
             <a:fld id="{F7021451-1387-4CA6-816F-3879F97B5CBC}" type="slidenum">
               <a:rPr lang="en-US"/>
               <a:t>17</a:t>
+            </a:fld>
+            <a:endParaRPr lang="en-US"/>
+          </a:p>
+        </p:txBody>
+      </p:sp>
+    </p:spTree>
+    <p:extLst>
+      <p:ext uri="{BB962C8B-B14F-4D97-AF65-F5344CB8AC3E}">
+        <p14:creationId xmlns:p14="http://schemas.microsoft.com/office/powerpoint/2010/main" val="1024086991"/>
+      </p:ext>
+    </p:extLst>
+  </p:cSld>
+  <p:clrMapOvr>
+    <a:masterClrMapping/>
+  </p:clrMapOvr>
+</p:notes>
+</file>
+
+<file path=ppt/notesSlides/notesSlide18.xml><?xml version="1.0" encoding="utf-8"?>
+<p:notes xmlns:a="http://schemas.openxmlformats.org/drawingml/2006/main" xmlns:r="http://schemas.openxmlformats.org/officeDocument/2006/relationships" xmlns:p="http://schemas.openxmlformats.org/presentationml/2006/main">
+  <p:cSld>
+    <p:spTree>
+      <p:nvGrpSpPr>
+        <p:cNvPr id="1" name=""/>
+        <p:cNvGrpSpPr/>
+        <p:nvPr/>
+      </p:nvGrpSpPr>
+      <p:grpSpPr>
+        <a:xfrm>
+          <a:off x="0" y="0"/>
+          <a:ext cx="0" cy="0"/>
+          <a:chOff x="0" y="0"/>
+          <a:chExt cx="0" cy="0"/>
+        </a:xfrm>
+      </p:grpSpPr>
+      <p:sp>
+        <p:nvSpPr>
+          <p:cNvPr id="2" name="Slide Image Placeholder 1"/>
+          <p:cNvSpPr>
+            <a:spLocks noGrp="1" noRot="1" noChangeAspect="1"/>
+          </p:cNvSpPr>
+          <p:nvPr>
+            <p:ph type="sldImg"/>
+          </p:nvPr>
+        </p:nvSpPr>
+        <p:spPr/>
+      </p:sp>
+      <p:sp>
+        <p:nvSpPr>
+          <p:cNvPr id="3" name="Notes Placeholder 2"/>
+          <p:cNvSpPr>
+            <a:spLocks noGrp="1"/>
+          </p:cNvSpPr>
+          <p:nvPr>
+            <p:ph type="body" idx="1"/>
+          </p:nvPr>
+        </p:nvSpPr>
+        <p:spPr/>
+        <p:txBody>
+          <a:bodyPr/>
+          <a:lstStyle/>
+          <a:p>
+            <a:r>
+              <a:rPr lang="en-US" dirty="0"/>
+              <a:t>Nhóm em xin cảm ơn thầy và các bạn đã lắng nghe. Nhóm sẵn sàng trả lời câu hỏi.</a:t>
+            </a:r>
+            <a:endParaRPr lang="en-US" dirty="0"/>
+          </a:p>
+        </p:txBody>
+      </p:sp>
+      <p:sp>
+        <p:nvSpPr>
+          <p:cNvPr id="4" name="Slide Number Placeholder 3"/>
+          <p:cNvSpPr>
+            <a:spLocks noGrp="1"/>
+          </p:cNvSpPr>
+          <p:nvPr>
+            <p:ph type="sldNum" sz="quarter" idx="10"/>
+          </p:nvPr>
+        </p:nvSpPr>
+        <p:spPr/>
+        <p:txBody>
+          <a:bodyPr/>
+          <a:lstStyle/>
+          <a:p>
+            <a:fld id="{F7021451-1387-4CA6-816F-3879F97B5CBC}" type="slidenum">
+              <a:rPr lang="en-US"/>
+              <a:t>18</a:t>
             </a:fld>
             <a:endParaRPr lang="en-US"/>
           </a:p>
@@ -4060,7 +4149,7 @@
                 <a:ea typeface="Calibri" pitchFamily="34" charset="-122"/>
                 <a:cs typeface="Calibri" pitchFamily="34" charset="-120"/>
               </a:rPr>
-              <a:t>32 ca kiểm thử</a:t>
+              <a:t>45 ca kiểm thử</a:t>
             </a:r>
             <a:endParaRPr lang="en-US" sz="1200" dirty="0"/>
           </a:p>
@@ -9284,7 +9373,7 @@
                 <a:ea typeface="Cambria" pitchFamily="34" charset="-122"/>
                 <a:cs typeface="Cambria" pitchFamily="34" charset="-120"/>
               </a:rPr>
-              <a:t>6</a:t>
+              <a:t>5</a:t>
             </a:r>
             <a:endParaRPr lang="en-US" sz="2000" dirty="0"/>
           </a:p>
@@ -9323,7 +9412,7 @@
                 <a:ea typeface="Cambria" pitchFamily="34" charset="-122"/>
                 <a:cs typeface="Cambria" pitchFamily="34" charset="-120"/>
               </a:rPr>
-              <a:t>Kết quả đạt được</a:t>
+              <a:t>Demo: trò chơi Thử thách</a:t>
             </a:r>
             <a:endParaRPr lang="en-US" sz="3200" dirty="0"/>
           </a:p>
@@ -9337,8 +9426,8 @@
         </p:nvSpPr>
         <p:spPr>
           <a:xfrm>
-            <a:off x="548640" y="6446520"/>
-            <a:ext cx="5486400" cy="274320"/>
+            <a:off x="1298448" y="960120"/>
+            <a:ext cx="10314432" cy="365760"/>
           </a:xfrm>
           <a:prstGeom prst="rect">
             <a:avLst/>
@@ -9354,17 +9443,17 @@
               <a:buNone/>
             </a:pPr>
             <a:r>
-              <a:rPr lang="en-US" sz="1000" dirty="0">
-                <a:solidFill>
-                  <a:srgbClr val="8A93A8"/>
+              <a:rPr lang="en-US" sz="1500" dirty="0">
+                <a:solidFill>
+                  <a:srgbClr val="5B6478"/>
                 </a:solidFill>
                 <a:latin typeface="Calibri" pitchFamily="34" charset="0"/>
                 <a:ea typeface="Calibri" pitchFamily="34" charset="-122"/>
                 <a:cs typeface="Calibri" pitchFamily="34" charset="-120"/>
               </a:rPr>
-              <a:t>Mô hình hoá tứ giác với Neo4j</a:t>
-            </a:r>
-            <a:endParaRPr lang="en-US" sz="1000" dirty="0"/>
+              <a:t>Kéo 4 đỉnh để tạo ra hình được yêu cầu — Neo4j nhận dạng và chấm điểm</a:t>
+            </a:r>
+            <a:endParaRPr lang="en-US" sz="1500" dirty="0"/>
           </a:p>
         </p:txBody>
       </p:sp>
@@ -9376,8 +9465,8 @@
         </p:nvSpPr>
         <p:spPr>
           <a:xfrm>
-            <a:off x="11155680" y="6446520"/>
-            <a:ext cx="502920" cy="274320"/>
+            <a:off x="548640" y="6446520"/>
+            <a:ext cx="5486400" cy="274320"/>
           </a:xfrm>
           <a:prstGeom prst="rect">
             <a:avLst/>
@@ -9389,7 +9478,7 @@
           <a:bodyPr wrap="square" lIns="0" tIns="0" rIns="0" bIns="0" rtlCol="0" anchor="t"/>
           <a:lstStyle/>
           <a:p>
-            <a:pPr algn="r" indent="0" marL="0">
+            <a:pPr indent="0" marL="0">
               <a:buNone/>
             </a:pPr>
             <a:r>
@@ -9401,119 +9490,212 @@
                 <a:ea typeface="Calibri" pitchFamily="34" charset="-122"/>
                 <a:cs typeface="Calibri" pitchFamily="34" charset="-120"/>
               </a:rPr>
+              <a:t>Mô hình hoá tứ giác với Neo4j</a:t>
+            </a:r>
+            <a:endParaRPr lang="en-US" sz="1000" dirty="0"/>
+          </a:p>
+        </p:txBody>
+      </p:sp>
+      <p:sp>
+        <p:nvSpPr>
+          <p:cNvPr id="7" name="Text 5"/>
+          <p:cNvSpPr txBox="1"/>
+          <p:nvPr/>
+        </p:nvSpPr>
+        <p:spPr>
+          <a:xfrm>
+            <a:off x="11155680" y="6446520"/>
+            <a:ext cx="502920" cy="274320"/>
+          </a:xfrm>
+          <a:prstGeom prst="rect">
+            <a:avLst/>
+          </a:prstGeom>
+          <a:noFill/>
+          <a:ln/>
+        </p:spPr>
+        <p:txBody>
+          <a:bodyPr wrap="square" lIns="0" tIns="0" rIns="0" bIns="0" rtlCol="0" anchor="t"/>
+          <a:lstStyle/>
+          <a:p>
+            <a:pPr algn="r" indent="0" marL="0">
+              <a:buNone/>
+            </a:pPr>
+            <a:r>
+              <a:rPr lang="en-US" sz="1000" dirty="0">
+                <a:solidFill>
+                  <a:srgbClr val="8A93A8"/>
+                </a:solidFill>
+                <a:latin typeface="Calibri" pitchFamily="34" charset="0"/>
+                <a:ea typeface="Calibri" pitchFamily="34" charset="-122"/>
+                <a:cs typeface="Calibri" pitchFamily="34" charset="-120"/>
+              </a:rPr>
               <a:t>15</a:t>
             </a:r>
             <a:endParaRPr lang="en-US" sz="1000" dirty="0"/>
           </a:p>
         </p:txBody>
       </p:sp>
-      <p:sp>
-        <p:nvSpPr>
-          <p:cNvPr id="7" name="Shape 5"/>
+      <p:pic>
+        <p:nvPicPr>
+          <p:cNvPr id="8" name="Image 0" descr="/tmp/claude-0/-home-claude/98539f31-3192-5884-a81c-346bec00204d/scratchpad/ppt/g_chinhxac.png">    </p:cNvPr>
+          <p:cNvPicPr>
+            <a:picLocks noChangeAspect="1"/>
+          </p:cNvPicPr>
+          <p:nvPr/>
+        </p:nvPicPr>
+        <p:blipFill>
+          <a:blip r:embed="rId1"/>
+          <a:stretch>
+            <a:fillRect/>
+          </a:stretch>
+        </p:blipFill>
+        <p:spPr>
+          <a:xfrm>
+            <a:off x="548640" y="1463040"/>
+            <a:ext cx="4774019" cy="4800600"/>
+          </a:xfrm>
+          <a:prstGeom prst="rect">
+            <a:avLst/>
+          </a:prstGeom>
+        </p:spPr>
+      </p:pic>
+      <p:sp>
+        <p:nvSpPr>
+          <p:cNvPr id="9" name="Shape 6"/>
           <p:cNvSpPr/>
           <p:nvPr/>
         </p:nvSpPr>
         <p:spPr>
           <a:xfrm>
-            <a:off x="548640" y="1417320"/>
-            <a:ext cx="2606040" cy="1737360"/>
-          </a:xfrm>
-          <a:prstGeom prst="roundRect">
-            <a:avLst>
-              <a:gd name="adj" fmla="val 6316"/>
-            </a:avLst>
+            <a:off x="5688419" y="1481328"/>
+            <a:ext cx="457200" cy="457200"/>
+          </a:xfrm>
+          <a:prstGeom prst="ellipse">
+            <a:avLst/>
           </a:prstGeom>
           <a:solidFill>
-            <a:srgbClr val="FFFFFF"/>
+            <a:srgbClr val="2F5BEA"/>
           </a:solidFill>
-          <a:ln w="9525">
+          <a:ln w="12700">
             <a:solidFill>
-              <a:srgbClr val="DDE3EE"/>
+              <a:srgbClr val="2F5BEA"/>
             </a:solidFill>
             <a:prstDash val="solid"/>
           </a:ln>
-          <a:effectLst>
-            <a:outerShdw sx="100000" sy="100000" kx="0" ky="0" algn="bl" rotWithShape="0" blurRad="101600" dist="25400" dir="5400000">
-              <a:srgbClr val="1B2540">
-                <a:alpha val="12000"/>
-              </a:srgbClr>
-            </a:outerShdw>
-          </a:effectLst>
-        </p:spPr>
-      </p:sp>
-      <p:sp>
-        <p:nvSpPr>
-          <p:cNvPr id="8" name="Text 6"/>
-          <p:cNvSpPr txBox="1"/>
-          <p:nvPr/>
-        </p:nvSpPr>
-        <p:spPr>
-          <a:xfrm>
-            <a:off x="548640" y="1554480"/>
-            <a:ext cx="2606040" cy="868680"/>
-          </a:xfrm>
-          <a:prstGeom prst="rect">
-            <a:avLst/>
-          </a:prstGeom>
-          <a:noFill/>
-          <a:ln/>
-        </p:spPr>
-        <p:txBody>
-          <a:bodyPr wrap="square" lIns="0" tIns="0" rIns="0" bIns="0" rtlCol="0" anchor="t"/>
+        </p:spPr>
+      </p:sp>
+      <p:sp>
+        <p:nvSpPr>
+          <p:cNvPr id="10" name="Text 7"/>
+          <p:cNvSpPr txBox="1"/>
+          <p:nvPr/>
+        </p:nvSpPr>
+        <p:spPr>
+          <a:xfrm>
+            <a:off x="5688419" y="1481328"/>
+            <a:ext cx="457200" cy="457200"/>
+          </a:xfrm>
+          <a:prstGeom prst="rect">
+            <a:avLst/>
+          </a:prstGeom>
+          <a:noFill/>
+          <a:ln/>
+        </p:spPr>
+        <p:txBody>
+          <a:bodyPr wrap="square" lIns="0" tIns="0" rIns="0" bIns="0" rtlCol="0" anchor="ctr"/>
           <a:lstStyle/>
           <a:p>
             <a:pPr algn="ctr" indent="0" marL="0">
               <a:buNone/>
             </a:pPr>
             <a:r>
-              <a:rPr lang="en-US" sz="4400" b="1" dirty="0">
-                <a:solidFill>
-                  <a:srgbClr val="2F5BEA"/>
-                </a:solidFill>
-                <a:latin typeface="Cambria" pitchFamily="34" charset="0"/>
-                <a:ea typeface="Cambria" pitchFamily="34" charset="-122"/>
-                <a:cs typeface="Cambria" pitchFamily="34" charset="-120"/>
-              </a:rPr>
-              <a:t>26</a:t>
-            </a:r>
-            <a:endParaRPr lang="en-US" sz="4400" dirty="0"/>
-          </a:p>
-        </p:txBody>
-      </p:sp>
-      <p:sp>
-        <p:nvSpPr>
-          <p:cNvPr id="9" name="Text 7"/>
-          <p:cNvSpPr txBox="1"/>
-          <p:nvPr/>
-        </p:nvSpPr>
-        <p:spPr>
-          <a:xfrm>
-            <a:off x="731520" y="2423160"/>
-            <a:ext cx="2240280" cy="640080"/>
-          </a:xfrm>
-          <a:prstGeom prst="rect">
-            <a:avLst/>
-          </a:prstGeom>
-          <a:noFill/>
-          <a:ln/>
-        </p:spPr>
-        <p:txBody>
-          <a:bodyPr wrap="square" lIns="0" tIns="0" rIns="0" bIns="0" rtlCol="0" anchor="t"/>
-          <a:lstStyle/>
-          <a:p>
-            <a:pPr algn="ctr" indent="0" marL="0">
-              <a:buNone/>
-            </a:pPr>
-            <a:r>
-              <a:rPr lang="en-US" sz="1350" dirty="0">
-                <a:solidFill>
-                  <a:srgbClr val="5B6478"/>
+              <a:rPr lang="en-US" sz="1600" b="1" dirty="0">
+                <a:solidFill>
+                  <a:srgbClr val="FFFFFF"/>
                 </a:solidFill>
                 <a:latin typeface="Calibri" pitchFamily="34" charset="0"/>
                 <a:ea typeface="Calibri" pitchFamily="34" charset="-122"/>
                 <a:cs typeface="Calibri" pitchFamily="34" charset="-120"/>
               </a:rPr>
-              <a:t>dấu hiệu nhận biết</a:t>
+              <a:t>1</a:t>
+            </a:r>
+            <a:endParaRPr lang="en-US" sz="1600" dirty="0"/>
+          </a:p>
+        </p:txBody>
+      </p:sp>
+      <p:sp>
+        <p:nvSpPr>
+          <p:cNvPr id="11" name="Text 8"/>
+          <p:cNvSpPr txBox="1"/>
+          <p:nvPr/>
+        </p:nvSpPr>
+        <p:spPr>
+          <a:xfrm>
+            <a:off x="6328499" y="1463040"/>
+            <a:ext cx="5375821" cy="347472"/>
+          </a:xfrm>
+          <a:prstGeom prst="rect">
+            <a:avLst/>
+          </a:prstGeom>
+          <a:noFill/>
+          <a:ln/>
+        </p:spPr>
+        <p:txBody>
+          <a:bodyPr wrap="square" lIns="0" tIns="0" rIns="0" bIns="0" rtlCol="0" anchor="t"/>
+          <a:lstStyle/>
+          <a:p>
+            <a:pPr indent="0" marL="0">
+              <a:buNone/>
+            </a:pPr>
+            <a:r>
+              <a:rPr lang="en-US" sz="1700" b="1" dirty="0">
+                <a:solidFill>
+                  <a:srgbClr val="1B2540"/>
+                </a:solidFill>
+                <a:latin typeface="Calibri" pitchFamily="34" charset="0"/>
+                <a:ea typeface="Calibri" pitchFamily="34" charset="-122"/>
+                <a:cs typeface="Calibri" pitchFamily="34" charset="-120"/>
+              </a:rPr>
+              <a:t>Kéo thả đỉnh</a:t>
+            </a:r>
+            <a:endParaRPr lang="en-US" sz="1700" dirty="0"/>
+          </a:p>
+        </p:txBody>
+      </p:sp>
+      <p:sp>
+        <p:nvSpPr>
+          <p:cNvPr id="12" name="Text 9"/>
+          <p:cNvSpPr txBox="1"/>
+          <p:nvPr/>
+        </p:nvSpPr>
+        <p:spPr>
+          <a:xfrm>
+            <a:off x="6328499" y="1847088"/>
+            <a:ext cx="5375821" cy="566928"/>
+          </a:xfrm>
+          <a:prstGeom prst="rect">
+            <a:avLst/>
+          </a:prstGeom>
+          <a:noFill/>
+          <a:ln/>
+        </p:spPr>
+        <p:txBody>
+          <a:bodyPr wrap="square" lIns="0" tIns="0" rIns="0" bIns="0" rtlCol="0" anchor="t"/>
+          <a:lstStyle/>
+          <a:p>
+            <a:pPr indent="0" marL="0">
+              <a:buNone/>
+            </a:pPr>
+            <a:r>
+              <a:rPr lang="en-US" sz="1350" dirty="0">
+                <a:solidFill>
+                  <a:srgbClr val="5B6478"/>
+                </a:solidFill>
+                <a:latin typeface="Calibri" pitchFamily="34" charset="0"/>
+                <a:ea typeface="Calibri" pitchFamily="34" charset="-122"/>
+                <a:cs typeface="Calibri" pitchFamily="34" charset="-120"/>
+              </a:rPr>
+              <a:t>Đỉnh dính vào lưới ô vuông ⇒ toạ độ nguyên</a:t>
             </a:r>
             <a:endParaRPr lang="en-US" sz="1350" dirty="0"/>
           </a:p>
@@ -9521,111 +9703,141 @@
       </p:sp>
       <p:sp>
         <p:nvSpPr>
-          <p:cNvPr id="10" name="Shape 8"/>
+          <p:cNvPr id="13" name="Shape 10"/>
           <p:cNvSpPr/>
           <p:nvPr/>
         </p:nvSpPr>
         <p:spPr>
           <a:xfrm>
-            <a:off x="3383280" y="1417320"/>
-            <a:ext cx="2606040" cy="1737360"/>
-          </a:xfrm>
-          <a:prstGeom prst="roundRect">
-            <a:avLst>
-              <a:gd name="adj" fmla="val 6316"/>
-            </a:avLst>
+            <a:off x="5688419" y="2459736"/>
+            <a:ext cx="457200" cy="457200"/>
+          </a:xfrm>
+          <a:prstGeom prst="ellipse">
+            <a:avLst/>
           </a:prstGeom>
           <a:solidFill>
-            <a:srgbClr val="FFFFFF"/>
+            <a:srgbClr val="2F5BEA"/>
           </a:solidFill>
-          <a:ln w="9525">
+          <a:ln w="12700">
             <a:solidFill>
-              <a:srgbClr val="DDE3EE"/>
+              <a:srgbClr val="2F5BEA"/>
             </a:solidFill>
             <a:prstDash val="solid"/>
           </a:ln>
-          <a:effectLst>
-            <a:outerShdw sx="100000" sy="100000" kx="0" ky="0" algn="bl" rotWithShape="0" blurRad="101600" dist="25400" dir="5400000">
-              <a:srgbClr val="1B2540">
-                <a:alpha val="12000"/>
-              </a:srgbClr>
-            </a:outerShdw>
-          </a:effectLst>
-        </p:spPr>
-      </p:sp>
-      <p:sp>
-        <p:nvSpPr>
-          <p:cNvPr id="11" name="Text 9"/>
-          <p:cNvSpPr txBox="1"/>
-          <p:nvPr/>
-        </p:nvSpPr>
-        <p:spPr>
-          <a:xfrm>
-            <a:off x="3383280" y="1554480"/>
-            <a:ext cx="2606040" cy="868680"/>
-          </a:xfrm>
-          <a:prstGeom prst="rect">
-            <a:avLst/>
-          </a:prstGeom>
-          <a:noFill/>
-          <a:ln/>
-        </p:spPr>
-        <p:txBody>
-          <a:bodyPr wrap="square" lIns="0" tIns="0" rIns="0" bIns="0" rtlCol="0" anchor="t"/>
+        </p:spPr>
+      </p:sp>
+      <p:sp>
+        <p:nvSpPr>
+          <p:cNvPr id="14" name="Text 11"/>
+          <p:cNvSpPr txBox="1"/>
+          <p:nvPr/>
+        </p:nvSpPr>
+        <p:spPr>
+          <a:xfrm>
+            <a:off x="5688419" y="2459736"/>
+            <a:ext cx="457200" cy="457200"/>
+          </a:xfrm>
+          <a:prstGeom prst="rect">
+            <a:avLst/>
+          </a:prstGeom>
+          <a:noFill/>
+          <a:ln/>
+        </p:spPr>
+        <p:txBody>
+          <a:bodyPr wrap="square" lIns="0" tIns="0" rIns="0" bIns="0" rtlCol="0" anchor="ctr"/>
           <a:lstStyle/>
           <a:p>
             <a:pPr algn="ctr" indent="0" marL="0">
               <a:buNone/>
             </a:pPr>
             <a:r>
-              <a:rPr lang="en-US" sz="4400" b="1" dirty="0">
-                <a:solidFill>
-                  <a:srgbClr val="2F5BEA"/>
-                </a:solidFill>
-                <a:latin typeface="Cambria" pitchFamily="34" charset="0"/>
-                <a:ea typeface="Cambria" pitchFamily="34" charset="-122"/>
-                <a:cs typeface="Cambria" pitchFamily="34" charset="-120"/>
-              </a:rPr>
-              <a:t>68</a:t>
-            </a:r>
-            <a:endParaRPr lang="en-US" sz="4400" dirty="0"/>
-          </a:p>
-        </p:txBody>
-      </p:sp>
-      <p:sp>
-        <p:nvSpPr>
-          <p:cNvPr id="12" name="Text 10"/>
-          <p:cNvSpPr txBox="1"/>
-          <p:nvPr/>
-        </p:nvSpPr>
-        <p:spPr>
-          <a:xfrm>
-            <a:off x="3566160" y="2423160"/>
-            <a:ext cx="2240280" cy="640080"/>
-          </a:xfrm>
-          <a:prstGeom prst="rect">
-            <a:avLst/>
-          </a:prstGeom>
-          <a:noFill/>
-          <a:ln/>
-        </p:spPr>
-        <p:txBody>
-          <a:bodyPr wrap="square" lIns="0" tIns="0" rIns="0" bIns="0" rtlCol="0" anchor="t"/>
-          <a:lstStyle/>
-          <a:p>
-            <a:pPr algn="ctr" indent="0" marL="0">
-              <a:buNone/>
-            </a:pPr>
-            <a:r>
-              <a:rPr lang="en-US" sz="1350" dirty="0">
-                <a:solidFill>
-                  <a:srgbClr val="5B6478"/>
+              <a:rPr lang="en-US" sz="1600" b="1" dirty="0">
+                <a:solidFill>
+                  <a:srgbClr val="FFFFFF"/>
                 </a:solidFill>
                 <a:latin typeface="Calibri" pitchFamily="34" charset="0"/>
                 <a:ea typeface="Calibri" pitchFamily="34" charset="-122"/>
                 <a:cs typeface="Calibri" pitchFamily="34" charset="-120"/>
               </a:rPr>
-              <a:t>công thức tính toán</a:t>
+              <a:t>2</a:t>
+            </a:r>
+            <a:endParaRPr lang="en-US" sz="1600" dirty="0"/>
+          </a:p>
+        </p:txBody>
+      </p:sp>
+      <p:sp>
+        <p:nvSpPr>
+          <p:cNvPr id="15" name="Text 12"/>
+          <p:cNvSpPr txBox="1"/>
+          <p:nvPr/>
+        </p:nvSpPr>
+        <p:spPr>
+          <a:xfrm>
+            <a:off x="6328499" y="2441448"/>
+            <a:ext cx="5375821" cy="347472"/>
+          </a:xfrm>
+          <a:prstGeom prst="rect">
+            <a:avLst/>
+          </a:prstGeom>
+          <a:noFill/>
+          <a:ln/>
+        </p:spPr>
+        <p:txBody>
+          <a:bodyPr wrap="square" lIns="0" tIns="0" rIns="0" bIns="0" rtlCol="0" anchor="t"/>
+          <a:lstStyle/>
+          <a:p>
+            <a:pPr indent="0" marL="0">
+              <a:buNone/>
+            </a:pPr>
+            <a:r>
+              <a:rPr lang="en-US" sz="1700" b="1" dirty="0">
+                <a:solidFill>
+                  <a:srgbClr val="1B2540"/>
+                </a:solidFill>
+                <a:latin typeface="Calibri" pitchFamily="34" charset="0"/>
+                <a:ea typeface="Calibri" pitchFamily="34" charset="-122"/>
+                <a:cs typeface="Calibri" pitchFamily="34" charset="-120"/>
+              </a:rPr>
+              <a:t>Toạ độ → tính chất</a:t>
+            </a:r>
+            <a:endParaRPr lang="en-US" sz="1700" dirty="0"/>
+          </a:p>
+        </p:txBody>
+      </p:sp>
+      <p:sp>
+        <p:nvSpPr>
+          <p:cNvPr id="16" name="Text 13"/>
+          <p:cNvSpPr txBox="1"/>
+          <p:nvPr/>
+        </p:nvSpPr>
+        <p:spPr>
+          <a:xfrm>
+            <a:off x="6328499" y="2825496"/>
+            <a:ext cx="5375821" cy="566928"/>
+          </a:xfrm>
+          <a:prstGeom prst="rect">
+            <a:avLst/>
+          </a:prstGeom>
+          <a:noFill/>
+          <a:ln/>
+        </p:spPr>
+        <p:txBody>
+          <a:bodyPr wrap="square" lIns="0" tIns="0" rIns="0" bIns="0" rtlCol="0" anchor="t"/>
+          <a:lstStyle/>
+          <a:p>
+            <a:pPr indent="0" marL="0">
+              <a:buNone/>
+            </a:pPr>
+            <a:r>
+              <a:rPr lang="en-US" sz="1350" dirty="0">
+                <a:solidFill>
+                  <a:srgbClr val="5B6478"/>
+                </a:solidFill>
+                <a:latin typeface="Calibri" pitchFamily="34" charset="0"/>
+                <a:ea typeface="Calibri" pitchFamily="34" charset="-122"/>
+                <a:cs typeface="Calibri" pitchFamily="34" charset="-120"/>
+              </a:rPr>
+              <a:t>Song song ⇔ tích có hướng = 0; vuông góc ⇔ tích vô hướng = 0; bằng nhau ⇔ bình phương độ dài bằng nhau</a:t>
             </a:r>
             <a:endParaRPr lang="en-US" sz="1350" dirty="0"/>
           </a:p>
@@ -9633,111 +9845,141 @@
       </p:sp>
       <p:sp>
         <p:nvSpPr>
-          <p:cNvPr id="13" name="Shape 11"/>
+          <p:cNvPr id="17" name="Shape 14"/>
           <p:cNvSpPr/>
           <p:nvPr/>
         </p:nvSpPr>
         <p:spPr>
           <a:xfrm>
-            <a:off x="6217920" y="1417320"/>
-            <a:ext cx="2606040" cy="1737360"/>
-          </a:xfrm>
-          <a:prstGeom prst="roundRect">
-            <a:avLst>
-              <a:gd name="adj" fmla="val 6316"/>
-            </a:avLst>
+            <a:off x="5688419" y="3438144"/>
+            <a:ext cx="457200" cy="457200"/>
+          </a:xfrm>
+          <a:prstGeom prst="ellipse">
+            <a:avLst/>
           </a:prstGeom>
           <a:solidFill>
-            <a:srgbClr val="FFFFFF"/>
+            <a:srgbClr val="2F5BEA"/>
           </a:solidFill>
-          <a:ln w="9525">
+          <a:ln w="12700">
             <a:solidFill>
-              <a:srgbClr val="DDE3EE"/>
+              <a:srgbClr val="2F5BEA"/>
             </a:solidFill>
             <a:prstDash val="solid"/>
           </a:ln>
-          <a:effectLst>
-            <a:outerShdw sx="100000" sy="100000" kx="0" ky="0" algn="bl" rotWithShape="0" blurRad="101600" dist="25400" dir="5400000">
-              <a:srgbClr val="1B2540">
-                <a:alpha val="12000"/>
-              </a:srgbClr>
-            </a:outerShdw>
-          </a:effectLst>
-        </p:spPr>
-      </p:sp>
-      <p:sp>
-        <p:nvSpPr>
-          <p:cNvPr id="14" name="Text 12"/>
-          <p:cNvSpPr txBox="1"/>
-          <p:nvPr/>
-        </p:nvSpPr>
-        <p:spPr>
-          <a:xfrm>
-            <a:off x="6217920" y="1554480"/>
-            <a:ext cx="2606040" cy="868680"/>
-          </a:xfrm>
-          <a:prstGeom prst="rect">
-            <a:avLst/>
-          </a:prstGeom>
-          <a:noFill/>
-          <a:ln/>
-        </p:spPr>
-        <p:txBody>
-          <a:bodyPr wrap="square" lIns="0" tIns="0" rIns="0" bIns="0" rtlCol="0" anchor="t"/>
+        </p:spPr>
+      </p:sp>
+      <p:sp>
+        <p:nvSpPr>
+          <p:cNvPr id="18" name="Text 15"/>
+          <p:cNvSpPr txBox="1"/>
+          <p:nvPr/>
+        </p:nvSpPr>
+        <p:spPr>
+          <a:xfrm>
+            <a:off x="5688419" y="3438144"/>
+            <a:ext cx="457200" cy="457200"/>
+          </a:xfrm>
+          <a:prstGeom prst="rect">
+            <a:avLst/>
+          </a:prstGeom>
+          <a:noFill/>
+          <a:ln/>
+        </p:spPr>
+        <p:txBody>
+          <a:bodyPr wrap="square" lIns="0" tIns="0" rIns="0" bIns="0" rtlCol="0" anchor="ctr"/>
           <a:lstStyle/>
           <a:p>
             <a:pPr algn="ctr" indent="0" marL="0">
               <a:buNone/>
             </a:pPr>
             <a:r>
-              <a:rPr lang="en-US" sz="4400" b="1" dirty="0">
-                <a:solidFill>
-                  <a:srgbClr val="0F8A5F"/>
-                </a:solidFill>
-                <a:latin typeface="Cambria" pitchFamily="34" charset="0"/>
-                <a:ea typeface="Cambria" pitchFamily="34" charset="-122"/>
-                <a:cs typeface="Cambria" pitchFamily="34" charset="-120"/>
-              </a:rPr>
-              <a:t>115</a:t>
-            </a:r>
-            <a:endParaRPr lang="en-US" sz="4400" dirty="0"/>
-          </a:p>
-        </p:txBody>
-      </p:sp>
-      <p:sp>
-        <p:nvSpPr>
-          <p:cNvPr id="15" name="Text 13"/>
-          <p:cNvSpPr txBox="1"/>
-          <p:nvPr/>
-        </p:nvSpPr>
-        <p:spPr>
-          <a:xfrm>
-            <a:off x="6400800" y="2423160"/>
-            <a:ext cx="2240280" cy="640080"/>
-          </a:xfrm>
-          <a:prstGeom prst="rect">
-            <a:avLst/>
-          </a:prstGeom>
-          <a:noFill/>
-          <a:ln/>
-        </p:spPr>
-        <p:txBody>
-          <a:bodyPr wrap="square" lIns="0" tIns="0" rIns="0" bIns="0" rtlCol="0" anchor="t"/>
-          <a:lstStyle/>
-          <a:p>
-            <a:pPr algn="ctr" indent="0" marL="0">
-              <a:buNone/>
-            </a:pPr>
-            <a:r>
-              <a:rPr lang="en-US" sz="1350" dirty="0">
-                <a:solidFill>
-                  <a:srgbClr val="5B6478"/>
+              <a:rPr lang="en-US" sz="1600" b="1" dirty="0">
+                <a:solidFill>
+                  <a:srgbClr val="FFFFFF"/>
                 </a:solidFill>
                 <a:latin typeface="Calibri" pitchFamily="34" charset="0"/>
                 <a:ea typeface="Calibri" pitchFamily="34" charset="-122"/>
                 <a:cs typeface="Calibri" pitchFamily="34" charset="-120"/>
               </a:rPr>
-              <a:t>truy vấn khớp kết quả trên Neo4j thật</a:t>
+              <a:t>3</a:t>
+            </a:r>
+            <a:endParaRPr lang="en-US" sz="1600" dirty="0"/>
+          </a:p>
+        </p:txBody>
+      </p:sp>
+      <p:sp>
+        <p:nvSpPr>
+          <p:cNvPr id="19" name="Text 16"/>
+          <p:cNvSpPr txBox="1"/>
+          <p:nvPr/>
+        </p:nvSpPr>
+        <p:spPr>
+          <a:xfrm>
+            <a:off x="6328499" y="3419856"/>
+            <a:ext cx="5375821" cy="347472"/>
+          </a:xfrm>
+          <a:prstGeom prst="rect">
+            <a:avLst/>
+          </a:prstGeom>
+          <a:noFill/>
+          <a:ln/>
+        </p:spPr>
+        <p:txBody>
+          <a:bodyPr wrap="square" lIns="0" tIns="0" rIns="0" bIns="0" rtlCol="0" anchor="t"/>
+          <a:lstStyle/>
+          <a:p>
+            <a:pPr indent="0" marL="0">
+              <a:buNone/>
+            </a:pPr>
+            <a:r>
+              <a:rPr lang="en-US" sz="1700" b="1" dirty="0">
+                <a:solidFill>
+                  <a:srgbClr val="1B2540"/>
+                </a:solidFill>
+                <a:latin typeface="Calibri" pitchFamily="34" charset="0"/>
+                <a:ea typeface="Calibri" pitchFamily="34" charset="-122"/>
+                <a:cs typeface="Calibri" pitchFamily="34" charset="-120"/>
+              </a:rPr>
+              <a:t>Neo4j suy luận</a:t>
+            </a:r>
+            <a:endParaRPr lang="en-US" sz="1700" dirty="0"/>
+          </a:p>
+        </p:txBody>
+      </p:sp>
+      <p:sp>
+        <p:nvSpPr>
+          <p:cNvPr id="20" name="Text 17"/>
+          <p:cNvSpPr txBox="1"/>
+          <p:nvPr/>
+        </p:nvSpPr>
+        <p:spPr>
+          <a:xfrm>
+            <a:off x="6328499" y="3803904"/>
+            <a:ext cx="5375821" cy="566928"/>
+          </a:xfrm>
+          <a:prstGeom prst="rect">
+            <a:avLst/>
+          </a:prstGeom>
+          <a:noFill/>
+          <a:ln/>
+        </p:spPr>
+        <p:txBody>
+          <a:bodyPr wrap="square" lIns="0" tIns="0" rIns="0" bIns="0" rtlCol="0" anchor="t"/>
+          <a:lstStyle/>
+          <a:p>
+            <a:pPr indent="0" marL="0">
+              <a:buNone/>
+            </a:pPr>
+            <a:r>
+              <a:rPr lang="en-US" sz="1350" dirty="0">
+                <a:solidFill>
+                  <a:srgbClr val="5B6478"/>
+                </a:solidFill>
+                <a:latin typeface="Calibri" pitchFamily="34" charset="0"/>
+                <a:ea typeface="Calibri" pitchFamily="34" charset="-122"/>
+                <a:cs typeface="Calibri" pitchFamily="34" charset="-120"/>
+              </a:rPr>
+              <a:t>Dùng chung bộ suy luận với trang Nhận dạng</a:t>
             </a:r>
             <a:endParaRPr lang="en-US" sz="1350" dirty="0"/>
           </a:p>
@@ -9745,111 +9987,141 @@
       </p:sp>
       <p:sp>
         <p:nvSpPr>
-          <p:cNvPr id="16" name="Shape 14"/>
+          <p:cNvPr id="21" name="Shape 18"/>
           <p:cNvSpPr/>
           <p:nvPr/>
         </p:nvSpPr>
         <p:spPr>
           <a:xfrm>
-            <a:off x="9052560" y="1417320"/>
-            <a:ext cx="2606040" cy="1737360"/>
-          </a:xfrm>
-          <a:prstGeom prst="roundRect">
-            <a:avLst>
-              <a:gd name="adj" fmla="val 6316"/>
-            </a:avLst>
+            <a:off x="5688419" y="4416552"/>
+            <a:ext cx="457200" cy="457200"/>
+          </a:xfrm>
+          <a:prstGeom prst="ellipse">
+            <a:avLst/>
           </a:prstGeom>
           <a:solidFill>
-            <a:srgbClr val="FFFFFF"/>
+            <a:srgbClr val="2F5BEA"/>
           </a:solidFill>
-          <a:ln w="9525">
+          <a:ln w="12700">
             <a:solidFill>
-              <a:srgbClr val="DDE3EE"/>
+              <a:srgbClr val="2F5BEA"/>
             </a:solidFill>
             <a:prstDash val="solid"/>
           </a:ln>
-          <a:effectLst>
-            <a:outerShdw sx="100000" sy="100000" kx="0" ky="0" algn="bl" rotWithShape="0" blurRad="101600" dist="25400" dir="5400000">
-              <a:srgbClr val="1B2540">
-                <a:alpha val="12000"/>
-              </a:srgbClr>
-            </a:outerShdw>
-          </a:effectLst>
-        </p:spPr>
-      </p:sp>
-      <p:sp>
-        <p:nvSpPr>
-          <p:cNvPr id="17" name="Text 15"/>
-          <p:cNvSpPr txBox="1"/>
-          <p:nvPr/>
-        </p:nvSpPr>
-        <p:spPr>
-          <a:xfrm>
-            <a:off x="9052560" y="1554480"/>
-            <a:ext cx="2606040" cy="868680"/>
-          </a:xfrm>
-          <a:prstGeom prst="rect">
-            <a:avLst/>
-          </a:prstGeom>
-          <a:noFill/>
-          <a:ln/>
-        </p:spPr>
-        <p:txBody>
-          <a:bodyPr wrap="square" lIns="0" tIns="0" rIns="0" bIns="0" rtlCol="0" anchor="t"/>
+        </p:spPr>
+      </p:sp>
+      <p:sp>
+        <p:nvSpPr>
+          <p:cNvPr id="22" name="Text 19"/>
+          <p:cNvSpPr txBox="1"/>
+          <p:nvPr/>
+        </p:nvSpPr>
+        <p:spPr>
+          <a:xfrm>
+            <a:off x="5688419" y="4416552"/>
+            <a:ext cx="457200" cy="457200"/>
+          </a:xfrm>
+          <a:prstGeom prst="rect">
+            <a:avLst/>
+          </a:prstGeom>
+          <a:noFill/>
+          <a:ln/>
+        </p:spPr>
+        <p:txBody>
+          <a:bodyPr wrap="square" lIns="0" tIns="0" rIns="0" bIns="0" rtlCol="0" anchor="ctr"/>
           <a:lstStyle/>
           <a:p>
             <a:pPr algn="ctr" indent="0" marL="0">
               <a:buNone/>
             </a:pPr>
             <a:r>
-              <a:rPr lang="en-US" sz="4400" b="1" dirty="0">
-                <a:solidFill>
-                  <a:srgbClr val="0F8A5F"/>
-                </a:solidFill>
-                <a:latin typeface="Cambria" pitchFamily="34" charset="0"/>
-                <a:ea typeface="Cambria" pitchFamily="34" charset="-122"/>
-                <a:cs typeface="Cambria" pitchFamily="34" charset="-120"/>
-              </a:rPr>
-              <a:t>32/32</a:t>
-            </a:r>
-            <a:endParaRPr lang="en-US" sz="4400" dirty="0"/>
-          </a:p>
-        </p:txBody>
-      </p:sp>
-      <p:sp>
-        <p:nvSpPr>
-          <p:cNvPr id="18" name="Text 16"/>
-          <p:cNvSpPr txBox="1"/>
-          <p:nvPr/>
-        </p:nvSpPr>
-        <p:spPr>
-          <a:xfrm>
-            <a:off x="9235440" y="2423160"/>
-            <a:ext cx="2240280" cy="640080"/>
-          </a:xfrm>
-          <a:prstGeom prst="rect">
-            <a:avLst/>
-          </a:prstGeom>
-          <a:noFill/>
-          <a:ln/>
-        </p:spPr>
-        <p:txBody>
-          <a:bodyPr wrap="square" lIns="0" tIns="0" rIns="0" bIns="0" rtlCol="0" anchor="t"/>
-          <a:lstStyle/>
-          <a:p>
-            <a:pPr algn="ctr" indent="0" marL="0">
-              <a:buNone/>
-            </a:pPr>
-            <a:r>
-              <a:rPr lang="en-US" sz="1350" dirty="0">
-                <a:solidFill>
-                  <a:srgbClr val="5B6478"/>
+              <a:rPr lang="en-US" sz="1600" b="1" dirty="0">
+                <a:solidFill>
+                  <a:srgbClr val="FFFFFF"/>
                 </a:solidFill>
                 <a:latin typeface="Calibri" pitchFamily="34" charset="0"/>
                 <a:ea typeface="Calibri" pitchFamily="34" charset="-122"/>
                 <a:cs typeface="Calibri" pitchFamily="34" charset="-120"/>
               </a:rPr>
-              <a:t>ca kiểm thử tự động đạt</a:t>
+              <a:t>4</a:t>
+            </a:r>
+            <a:endParaRPr lang="en-US" sz="1600" dirty="0"/>
+          </a:p>
+        </p:txBody>
+      </p:sp>
+      <p:sp>
+        <p:nvSpPr>
+          <p:cNvPr id="23" name="Text 20"/>
+          <p:cNvSpPr txBox="1"/>
+          <p:nvPr/>
+        </p:nvSpPr>
+        <p:spPr>
+          <a:xfrm>
+            <a:off x="6328499" y="4398264"/>
+            <a:ext cx="5375821" cy="347472"/>
+          </a:xfrm>
+          <a:prstGeom prst="rect">
+            <a:avLst/>
+          </a:prstGeom>
+          <a:noFill/>
+          <a:ln/>
+        </p:spPr>
+        <p:txBody>
+          <a:bodyPr wrap="square" lIns="0" tIns="0" rIns="0" bIns="0" rtlCol="0" anchor="t"/>
+          <a:lstStyle/>
+          <a:p>
+            <a:pPr indent="0" marL="0">
+              <a:buNone/>
+            </a:pPr>
+            <a:r>
+              <a:rPr lang="en-US" sz="1700" b="1" dirty="0">
+                <a:solidFill>
+                  <a:srgbClr val="1B2540"/>
+                </a:solidFill>
+                <a:latin typeface="Calibri" pitchFamily="34" charset="0"/>
+                <a:ea typeface="Calibri" pitchFamily="34" charset="-122"/>
+                <a:cs typeface="Calibri" pitchFamily="34" charset="-120"/>
+              </a:rPr>
+              <a:t>Chấm điểm</a:t>
+            </a:r>
+            <a:endParaRPr lang="en-US" sz="1700" dirty="0"/>
+          </a:p>
+        </p:txBody>
+      </p:sp>
+      <p:sp>
+        <p:nvSpPr>
+          <p:cNvPr id="24" name="Text 21"/>
+          <p:cNvSpPr txBox="1"/>
+          <p:nvPr/>
+        </p:nvSpPr>
+        <p:spPr>
+          <a:xfrm>
+            <a:off x="6328499" y="4782312"/>
+            <a:ext cx="5375821" cy="566928"/>
+          </a:xfrm>
+          <a:prstGeom prst="rect">
+            <a:avLst/>
+          </a:prstGeom>
+          <a:noFill/>
+          <a:ln/>
+        </p:spPr>
+        <p:txBody>
+          <a:bodyPr wrap="square" lIns="0" tIns="0" rIns="0" bIns="0" rtlCol="0" anchor="t"/>
+          <a:lstStyle/>
+          <a:p>
+            <a:pPr indent="0" marL="0">
+              <a:buNone/>
+            </a:pPr>
+            <a:r>
+              <a:rPr lang="en-US" sz="1350" dirty="0">
+                <a:solidFill>
+                  <a:srgbClr val="5B6478"/>
+                </a:solidFill>
+                <a:latin typeface="Calibri" pitchFamily="34" charset="0"/>
+                <a:ea typeface="Calibri" pitchFamily="34" charset="-122"/>
+                <a:cs typeface="Calibri" pitchFamily="34" charset="-120"/>
+              </a:rPr>
+              <a:t>Đúng hình ⇒ +100 điểm + tốc độ + chuỗi; trường hợp đặc biệt (LA_MOT) ⇒ “Gần đúng”</a:t>
             </a:r>
             <a:endParaRPr lang="en-US" sz="1350" dirty="0"/>
           </a:p>
@@ -9857,48 +10129,14 @@
       </p:sp>
       <p:sp>
         <p:nvSpPr>
-          <p:cNvPr id="19" name="Shape 17"/>
+          <p:cNvPr id="25" name="Shape 22"/>
           <p:cNvSpPr/>
           <p:nvPr/>
         </p:nvSpPr>
         <p:spPr>
           <a:xfrm>
-            <a:off x="548640" y="3520440"/>
-            <a:ext cx="5440680" cy="1188720"/>
-          </a:xfrm>
-          <a:prstGeom prst="roundRect">
-            <a:avLst>
-              <a:gd name="adj" fmla="val 9231"/>
-            </a:avLst>
-          </a:prstGeom>
-          <a:solidFill>
-            <a:srgbClr val="FFFFFF"/>
-          </a:solidFill>
-          <a:ln w="9525">
-            <a:solidFill>
-              <a:srgbClr val="DDE3EE"/>
-            </a:solidFill>
-            <a:prstDash val="solid"/>
-          </a:ln>
-          <a:effectLst>
-            <a:outerShdw sx="100000" sy="100000" kx="0" ky="0" algn="bl" rotWithShape="0" blurRad="101600" dist="25400" dir="5400000">
-              <a:srgbClr val="1B2540">
-                <a:alpha val="12000"/>
-              </a:srgbClr>
-            </a:outerShdw>
-          </a:effectLst>
-        </p:spPr>
-      </p:sp>
-      <p:sp>
-        <p:nvSpPr>
-          <p:cNvPr id="20" name="Shape 18"/>
-          <p:cNvSpPr/>
-          <p:nvPr/>
-        </p:nvSpPr>
-        <p:spPr>
-          <a:xfrm>
-            <a:off x="777240" y="3867912"/>
-            <a:ext cx="502920" cy="502920"/>
+            <a:off x="5688419" y="5394960"/>
+            <a:ext cx="457200" cy="457200"/>
           </a:xfrm>
           <a:prstGeom prst="ellipse">
             <a:avLst/>
@@ -9916,14 +10154,14 @@
       </p:sp>
       <p:sp>
         <p:nvSpPr>
-          <p:cNvPr id="21" name="Text 19"/>
-          <p:cNvSpPr txBox="1"/>
-          <p:nvPr/>
-        </p:nvSpPr>
-        <p:spPr>
-          <a:xfrm>
-            <a:off x="777240" y="3867912"/>
-            <a:ext cx="502920" cy="502920"/>
+          <p:cNvPr id="26" name="Text 23"/>
+          <p:cNvSpPr txBox="1"/>
+          <p:nvPr/>
+        </p:nvSpPr>
+        <p:spPr>
+          <a:xfrm>
+            <a:off x="5688419" y="5394960"/>
+            <a:ext cx="457200" cy="457200"/>
           </a:xfrm>
           <a:prstGeom prst="rect">
             <a:avLst/>
@@ -9947,7 +10185,7 @@
                 <a:ea typeface="Calibri" pitchFamily="34" charset="-122"/>
                 <a:cs typeface="Calibri" pitchFamily="34" charset="-120"/>
               </a:rPr>
-              <a:t>✓</a:t>
+              <a:t>5</a:t>
             </a:r>
             <a:endParaRPr lang="en-US" sz="1600" dirty="0"/>
           </a:p>
@@ -9955,14 +10193,14 @@
       </p:sp>
       <p:sp>
         <p:nvSpPr>
-          <p:cNvPr id="22" name="Text 20"/>
-          <p:cNvSpPr txBox="1"/>
-          <p:nvPr/>
-        </p:nvSpPr>
-        <p:spPr>
-          <a:xfrm>
-            <a:off x="1463040" y="3703320"/>
-            <a:ext cx="4389120" cy="411480"/>
+          <p:cNvPr id="27" name="Text 24"/>
+          <p:cNvSpPr txBox="1"/>
+          <p:nvPr/>
+        </p:nvSpPr>
+        <p:spPr>
+          <a:xfrm>
+            <a:off x="6328499" y="5376672"/>
+            <a:ext cx="5375821" cy="347472"/>
           </a:xfrm>
           <a:prstGeom prst="rect">
             <a:avLst/>
@@ -9986,7 +10224,7 @@
                 <a:ea typeface="Calibri" pitchFamily="34" charset="-122"/>
                 <a:cs typeface="Calibri" pitchFamily="34" charset="-120"/>
               </a:rPr>
-              <a:t>Nhận dạng tứ giác</a:t>
+              <a:t>Bảng xếp hạng</a:t>
             </a:r>
             <a:endParaRPr lang="en-US" sz="1700" dirty="0"/>
           </a:p>
@@ -9994,14 +10232,14 @@
       </p:sp>
       <p:sp>
         <p:nvSpPr>
-          <p:cNvPr id="23" name="Text 21"/>
-          <p:cNvSpPr txBox="1"/>
-          <p:nvPr/>
-        </p:nvSpPr>
-        <p:spPr>
-          <a:xfrm>
-            <a:off x="1463040" y="4114800"/>
-            <a:ext cx="4389120" cy="502920"/>
+          <p:cNvPr id="28" name="Text 25"/>
+          <p:cNvSpPr txBox="1"/>
+          <p:nvPr/>
+        </p:nvSpPr>
+        <p:spPr>
+          <a:xfrm>
+            <a:off x="6328499" y="5760720"/>
+            <a:ext cx="5375821" cy="566928"/>
           </a:xfrm>
           <a:prstGeom prst="rect">
             <a:avLst/>
@@ -10025,535 +10263,7 @@
                 <a:ea typeface="Calibri" pitchFamily="34" charset="-122"/>
                 <a:cs typeface="Calibri" pitchFamily="34" charset="-120"/>
               </a:rPr>
-              <a:t>Lời giải từng bước, phát hiện thiếu dữ kiện và mâu thuẫn</a:t>
-            </a:r>
-            <a:endParaRPr lang="en-US" sz="1350" dirty="0"/>
-          </a:p>
-        </p:txBody>
-      </p:sp>
-      <p:sp>
-        <p:nvSpPr>
-          <p:cNvPr id="24" name="Shape 22"/>
-          <p:cNvSpPr/>
-          <p:nvPr/>
-        </p:nvSpPr>
-        <p:spPr>
-          <a:xfrm>
-            <a:off x="6172200" y="3520440"/>
-            <a:ext cx="5440680" cy="1188720"/>
-          </a:xfrm>
-          <a:prstGeom prst="roundRect">
-            <a:avLst>
-              <a:gd name="adj" fmla="val 9231"/>
-            </a:avLst>
-          </a:prstGeom>
-          <a:solidFill>
-            <a:srgbClr val="FFFFFF"/>
-          </a:solidFill>
-          <a:ln w="9525">
-            <a:solidFill>
-              <a:srgbClr val="DDE3EE"/>
-            </a:solidFill>
-            <a:prstDash val="solid"/>
-          </a:ln>
-          <a:effectLst>
-            <a:outerShdw sx="100000" sy="100000" kx="0" ky="0" algn="bl" rotWithShape="0" blurRad="101600" dist="25400" dir="5400000">
-              <a:srgbClr val="1B2540">
-                <a:alpha val="12000"/>
-              </a:srgbClr>
-            </a:outerShdw>
-          </a:effectLst>
-        </p:spPr>
-      </p:sp>
-      <p:sp>
-        <p:nvSpPr>
-          <p:cNvPr id="25" name="Shape 23"/>
-          <p:cNvSpPr/>
-          <p:nvPr/>
-        </p:nvSpPr>
-        <p:spPr>
-          <a:xfrm>
-            <a:off x="6400800" y="3867912"/>
-            <a:ext cx="502920" cy="502920"/>
-          </a:xfrm>
-          <a:prstGeom prst="ellipse">
-            <a:avLst/>
-          </a:prstGeom>
-          <a:solidFill>
-            <a:srgbClr val="0F8A5F"/>
-          </a:solidFill>
-          <a:ln w="12700">
-            <a:solidFill>
-              <a:srgbClr val="0F8A5F"/>
-            </a:solidFill>
-            <a:prstDash val="solid"/>
-          </a:ln>
-        </p:spPr>
-      </p:sp>
-      <p:sp>
-        <p:nvSpPr>
-          <p:cNvPr id="26" name="Text 24"/>
-          <p:cNvSpPr txBox="1"/>
-          <p:nvPr/>
-        </p:nvSpPr>
-        <p:spPr>
-          <a:xfrm>
-            <a:off x="6400800" y="3867912"/>
-            <a:ext cx="502920" cy="502920"/>
-          </a:xfrm>
-          <a:prstGeom prst="rect">
-            <a:avLst/>
-          </a:prstGeom>
-          <a:noFill/>
-          <a:ln/>
-        </p:spPr>
-        <p:txBody>
-          <a:bodyPr wrap="square" lIns="0" tIns="0" rIns="0" bIns="0" rtlCol="0" anchor="ctr"/>
-          <a:lstStyle/>
-          <a:p>
-            <a:pPr algn="ctr" indent="0" marL="0">
-              <a:buNone/>
-            </a:pPr>
-            <a:r>
-              <a:rPr lang="en-US" sz="1600" b="1" dirty="0">
-                <a:solidFill>
-                  <a:srgbClr val="FFFFFF"/>
-                </a:solidFill>
-                <a:latin typeface="Calibri" pitchFamily="34" charset="0"/>
-                <a:ea typeface="Calibri" pitchFamily="34" charset="-122"/>
-                <a:cs typeface="Calibri" pitchFamily="34" charset="-120"/>
-              </a:rPr>
-              <a:t>✓</a:t>
-            </a:r>
-            <a:endParaRPr lang="en-US" sz="1600" dirty="0"/>
-          </a:p>
-        </p:txBody>
-      </p:sp>
-      <p:sp>
-        <p:nvSpPr>
-          <p:cNvPr id="27" name="Text 25"/>
-          <p:cNvSpPr txBox="1"/>
-          <p:nvPr/>
-        </p:nvSpPr>
-        <p:spPr>
-          <a:xfrm>
-            <a:off x="7086600" y="3703320"/>
-            <a:ext cx="4389120" cy="411480"/>
-          </a:xfrm>
-          <a:prstGeom prst="rect">
-            <a:avLst/>
-          </a:prstGeom>
-          <a:noFill/>
-          <a:ln/>
-        </p:spPr>
-        <p:txBody>
-          <a:bodyPr wrap="square" lIns="0" tIns="0" rIns="0" bIns="0" rtlCol="0" anchor="t"/>
-          <a:lstStyle/>
-          <a:p>
-            <a:pPr indent="0" marL="0">
-              <a:buNone/>
-            </a:pPr>
-            <a:r>
-              <a:rPr lang="en-US" sz="1700" b="1" dirty="0">
-                <a:solidFill>
-                  <a:srgbClr val="1B2540"/>
-                </a:solidFill>
-                <a:latin typeface="Calibri" pitchFamily="34" charset="0"/>
-                <a:ea typeface="Calibri" pitchFamily="34" charset="-122"/>
-                <a:cs typeface="Calibri" pitchFamily="34" charset="-120"/>
-              </a:rPr>
-              <a:t>Tính diện tích, chu vi</a:t>
-            </a:r>
-            <a:endParaRPr lang="en-US" sz="1700" dirty="0"/>
-          </a:p>
-        </p:txBody>
-      </p:sp>
-      <p:sp>
-        <p:nvSpPr>
-          <p:cNvPr id="28" name="Text 26"/>
-          <p:cNvSpPr txBox="1"/>
-          <p:nvPr/>
-        </p:nvSpPr>
-        <p:spPr>
-          <a:xfrm>
-            <a:off x="7086600" y="4114800"/>
-            <a:ext cx="4389120" cy="502920"/>
-          </a:xfrm>
-          <a:prstGeom prst="rect">
-            <a:avLst/>
-          </a:prstGeom>
-          <a:noFill/>
-          <a:ln/>
-        </p:spPr>
-        <p:txBody>
-          <a:bodyPr wrap="square" lIns="0" tIns="0" rIns="0" bIns="0" rtlCol="0" anchor="t"/>
-          <a:lstStyle/>
-          <a:p>
-            <a:pPr indent="0" marL="0">
-              <a:buNone/>
-            </a:pPr>
-            <a:r>
-              <a:rPr lang="en-US" sz="1350" dirty="0">
-                <a:solidFill>
-                  <a:srgbClr val="5B6478"/>
-                </a:solidFill>
-                <a:latin typeface="Calibri" pitchFamily="34" charset="0"/>
-                <a:ea typeface="Calibri" pitchFamily="34" charset="-122"/>
-                <a:cs typeface="Calibri" pitchFamily="34" charset="-120"/>
-              </a:rPr>
-              <a:t>Nhập số liệu bất kỳ, tính mọi đại lượng liên quan</a:t>
-            </a:r>
-            <a:endParaRPr lang="en-US" sz="1350" dirty="0"/>
-          </a:p>
-        </p:txBody>
-      </p:sp>
-      <p:sp>
-        <p:nvSpPr>
-          <p:cNvPr id="29" name="Shape 27"/>
-          <p:cNvSpPr/>
-          <p:nvPr/>
-        </p:nvSpPr>
-        <p:spPr>
-          <a:xfrm>
-            <a:off x="548640" y="4892040"/>
-            <a:ext cx="5440680" cy="1188720"/>
-          </a:xfrm>
-          <a:prstGeom prst="roundRect">
-            <a:avLst>
-              <a:gd name="adj" fmla="val 9231"/>
-            </a:avLst>
-          </a:prstGeom>
-          <a:solidFill>
-            <a:srgbClr val="FFFFFF"/>
-          </a:solidFill>
-          <a:ln w="9525">
-            <a:solidFill>
-              <a:srgbClr val="DDE3EE"/>
-            </a:solidFill>
-            <a:prstDash val="solid"/>
-          </a:ln>
-          <a:effectLst>
-            <a:outerShdw sx="100000" sy="100000" kx="0" ky="0" algn="bl" rotWithShape="0" blurRad="101600" dist="25400" dir="5400000">
-              <a:srgbClr val="1B2540">
-                <a:alpha val="12000"/>
-              </a:srgbClr>
-            </a:outerShdw>
-          </a:effectLst>
-        </p:spPr>
-      </p:sp>
-      <p:sp>
-        <p:nvSpPr>
-          <p:cNvPr id="30" name="Shape 28"/>
-          <p:cNvSpPr/>
-          <p:nvPr/>
-        </p:nvSpPr>
-        <p:spPr>
-          <a:xfrm>
-            <a:off x="777240" y="5239512"/>
-            <a:ext cx="502920" cy="502920"/>
-          </a:xfrm>
-          <a:prstGeom prst="ellipse">
-            <a:avLst/>
-          </a:prstGeom>
-          <a:solidFill>
-            <a:srgbClr val="0F8A5F"/>
-          </a:solidFill>
-          <a:ln w="12700">
-            <a:solidFill>
-              <a:srgbClr val="0F8A5F"/>
-            </a:solidFill>
-            <a:prstDash val="solid"/>
-          </a:ln>
-        </p:spPr>
-      </p:sp>
-      <p:sp>
-        <p:nvSpPr>
-          <p:cNvPr id="31" name="Text 29"/>
-          <p:cNvSpPr txBox="1"/>
-          <p:nvPr/>
-        </p:nvSpPr>
-        <p:spPr>
-          <a:xfrm>
-            <a:off x="777240" y="5239512"/>
-            <a:ext cx="502920" cy="502920"/>
-          </a:xfrm>
-          <a:prstGeom prst="rect">
-            <a:avLst/>
-          </a:prstGeom>
-          <a:noFill/>
-          <a:ln/>
-        </p:spPr>
-        <p:txBody>
-          <a:bodyPr wrap="square" lIns="0" tIns="0" rIns="0" bIns="0" rtlCol="0" anchor="ctr"/>
-          <a:lstStyle/>
-          <a:p>
-            <a:pPr algn="ctr" indent="0" marL="0">
-              <a:buNone/>
-            </a:pPr>
-            <a:r>
-              <a:rPr lang="en-US" sz="1600" b="1" dirty="0">
-                <a:solidFill>
-                  <a:srgbClr val="FFFFFF"/>
-                </a:solidFill>
-                <a:latin typeface="Calibri" pitchFamily="34" charset="0"/>
-                <a:ea typeface="Calibri" pitchFamily="34" charset="-122"/>
-                <a:cs typeface="Calibri" pitchFamily="34" charset="-120"/>
-              </a:rPr>
-              <a:t>✓</a:t>
-            </a:r>
-            <a:endParaRPr lang="en-US" sz="1600" dirty="0"/>
-          </a:p>
-        </p:txBody>
-      </p:sp>
-      <p:sp>
-        <p:nvSpPr>
-          <p:cNvPr id="32" name="Text 30"/>
-          <p:cNvSpPr txBox="1"/>
-          <p:nvPr/>
-        </p:nvSpPr>
-        <p:spPr>
-          <a:xfrm>
-            <a:off x="1463040" y="5074920"/>
-            <a:ext cx="4389120" cy="411480"/>
-          </a:xfrm>
-          <a:prstGeom prst="rect">
-            <a:avLst/>
-          </a:prstGeom>
-          <a:noFill/>
-          <a:ln/>
-        </p:spPr>
-        <p:txBody>
-          <a:bodyPr wrap="square" lIns="0" tIns="0" rIns="0" bIns="0" rtlCol="0" anchor="t"/>
-          <a:lstStyle/>
-          <a:p>
-            <a:pPr indent="0" marL="0">
-              <a:buNone/>
-            </a:pPr>
-            <a:r>
-              <a:rPr lang="en-US" sz="1700" b="1" dirty="0">
-                <a:solidFill>
-                  <a:srgbClr val="1B2540"/>
-                </a:solidFill>
-                <a:latin typeface="Calibri" pitchFamily="34" charset="0"/>
-                <a:ea typeface="Calibri" pitchFamily="34" charset="-122"/>
-                <a:cs typeface="Calibri" pitchFamily="34" charset="-120"/>
-              </a:rPr>
-              <a:t>Tra cứu &amp; đồ thị tri thức</a:t>
-            </a:r>
-            <a:endParaRPr lang="en-US" sz="1700" dirty="0"/>
-          </a:p>
-        </p:txBody>
-      </p:sp>
-      <p:sp>
-        <p:nvSpPr>
-          <p:cNvPr id="33" name="Text 31"/>
-          <p:cNvSpPr txBox="1"/>
-          <p:nvPr/>
-        </p:nvSpPr>
-        <p:spPr>
-          <a:xfrm>
-            <a:off x="1463040" y="5486400"/>
-            <a:ext cx="4389120" cy="502920"/>
-          </a:xfrm>
-          <a:prstGeom prst="rect">
-            <a:avLst/>
-          </a:prstGeom>
-          <a:noFill/>
-          <a:ln/>
-        </p:spPr>
-        <p:txBody>
-          <a:bodyPr wrap="square" lIns="0" tIns="0" rIns="0" bIns="0" rtlCol="0" anchor="t"/>
-          <a:lstStyle/>
-          <a:p>
-            <a:pPr indent="0" marL="0">
-              <a:buNone/>
-            </a:pPr>
-            <a:r>
-              <a:rPr lang="en-US" sz="1350" dirty="0">
-                <a:solidFill>
-                  <a:srgbClr val="5B6478"/>
-                </a:solidFill>
-                <a:latin typeface="Calibri" pitchFamily="34" charset="0"/>
-                <a:ea typeface="Calibri" pitchFamily="34" charset="-122"/>
-                <a:cs typeface="Calibri" pitchFamily="34" charset="-120"/>
-              </a:rPr>
-              <a:t>Định nghĩa, tính chất kế thừa, dấu hiệu, công thức của từng hình</a:t>
-            </a:r>
-            <a:endParaRPr lang="en-US" sz="1350" dirty="0"/>
-          </a:p>
-        </p:txBody>
-      </p:sp>
-      <p:sp>
-        <p:nvSpPr>
-          <p:cNvPr id="34" name="Shape 32"/>
-          <p:cNvSpPr/>
-          <p:nvPr/>
-        </p:nvSpPr>
-        <p:spPr>
-          <a:xfrm>
-            <a:off x="6172200" y="4892040"/>
-            <a:ext cx="5440680" cy="1188720"/>
-          </a:xfrm>
-          <a:prstGeom prst="roundRect">
-            <a:avLst>
-              <a:gd name="adj" fmla="val 9231"/>
-            </a:avLst>
-          </a:prstGeom>
-          <a:solidFill>
-            <a:srgbClr val="FFFFFF"/>
-          </a:solidFill>
-          <a:ln w="9525">
-            <a:solidFill>
-              <a:srgbClr val="DDE3EE"/>
-            </a:solidFill>
-            <a:prstDash val="solid"/>
-          </a:ln>
-          <a:effectLst>
-            <a:outerShdw sx="100000" sy="100000" kx="0" ky="0" algn="bl" rotWithShape="0" blurRad="101600" dist="25400" dir="5400000">
-              <a:srgbClr val="1B2540">
-                <a:alpha val="12000"/>
-              </a:srgbClr>
-            </a:outerShdw>
-          </a:effectLst>
-        </p:spPr>
-      </p:sp>
-      <p:sp>
-        <p:nvSpPr>
-          <p:cNvPr id="35" name="Shape 33"/>
-          <p:cNvSpPr/>
-          <p:nvPr/>
-        </p:nvSpPr>
-        <p:spPr>
-          <a:xfrm>
-            <a:off x="6400800" y="5239512"/>
-            <a:ext cx="502920" cy="502920"/>
-          </a:xfrm>
-          <a:prstGeom prst="ellipse">
-            <a:avLst/>
-          </a:prstGeom>
-          <a:solidFill>
-            <a:srgbClr val="0F8A5F"/>
-          </a:solidFill>
-          <a:ln w="12700">
-            <a:solidFill>
-              <a:srgbClr val="0F8A5F"/>
-            </a:solidFill>
-            <a:prstDash val="solid"/>
-          </a:ln>
-        </p:spPr>
-      </p:sp>
-      <p:sp>
-        <p:nvSpPr>
-          <p:cNvPr id="36" name="Text 34"/>
-          <p:cNvSpPr txBox="1"/>
-          <p:nvPr/>
-        </p:nvSpPr>
-        <p:spPr>
-          <a:xfrm>
-            <a:off x="6400800" y="5239512"/>
-            <a:ext cx="502920" cy="502920"/>
-          </a:xfrm>
-          <a:prstGeom prst="rect">
-            <a:avLst/>
-          </a:prstGeom>
-          <a:noFill/>
-          <a:ln/>
-        </p:spPr>
-        <p:txBody>
-          <a:bodyPr wrap="square" lIns="0" tIns="0" rIns="0" bIns="0" rtlCol="0" anchor="ctr"/>
-          <a:lstStyle/>
-          <a:p>
-            <a:pPr algn="ctr" indent="0" marL="0">
-              <a:buNone/>
-            </a:pPr>
-            <a:r>
-              <a:rPr lang="en-US" sz="1600" b="1" dirty="0">
-                <a:solidFill>
-                  <a:srgbClr val="FFFFFF"/>
-                </a:solidFill>
-                <a:latin typeface="Calibri" pitchFamily="34" charset="0"/>
-                <a:ea typeface="Calibri" pitchFamily="34" charset="-122"/>
-                <a:cs typeface="Calibri" pitchFamily="34" charset="-120"/>
-              </a:rPr>
-              <a:t>✓</a:t>
-            </a:r>
-            <a:endParaRPr lang="en-US" sz="1600" dirty="0"/>
-          </a:p>
-        </p:txBody>
-      </p:sp>
-      <p:sp>
-        <p:nvSpPr>
-          <p:cNvPr id="37" name="Text 35"/>
-          <p:cNvSpPr txBox="1"/>
-          <p:nvPr/>
-        </p:nvSpPr>
-        <p:spPr>
-          <a:xfrm>
-            <a:off x="7086600" y="5074920"/>
-            <a:ext cx="4389120" cy="411480"/>
-          </a:xfrm>
-          <a:prstGeom prst="rect">
-            <a:avLst/>
-          </a:prstGeom>
-          <a:noFill/>
-          <a:ln/>
-        </p:spPr>
-        <p:txBody>
-          <a:bodyPr wrap="square" lIns="0" tIns="0" rIns="0" bIns="0" rtlCol="0" anchor="t"/>
-          <a:lstStyle/>
-          <a:p>
-            <a:pPr indent="0" marL="0">
-              <a:buNone/>
-            </a:pPr>
-            <a:r>
-              <a:rPr lang="en-US" sz="1700" b="1" dirty="0">
-                <a:solidFill>
-                  <a:srgbClr val="1B2540"/>
-                </a:solidFill>
-                <a:latin typeface="Calibri" pitchFamily="34" charset="0"/>
-                <a:ea typeface="Calibri" pitchFamily="34" charset="-122"/>
-                <a:cs typeface="Calibri" pitchFamily="34" charset="-120"/>
-              </a:rPr>
-              <a:t>Tài liệu &amp; mã nguồn</a:t>
-            </a:r>
-            <a:endParaRPr lang="en-US" sz="1700" dirty="0"/>
-          </a:p>
-        </p:txBody>
-      </p:sp>
-      <p:sp>
-        <p:nvSpPr>
-          <p:cNvPr id="38" name="Text 36"/>
-          <p:cNvSpPr txBox="1"/>
-          <p:nvPr/>
-        </p:nvSpPr>
-        <p:spPr>
-          <a:xfrm>
-            <a:off x="7086600" y="5486400"/>
-            <a:ext cx="4389120" cy="502920"/>
-          </a:xfrm>
-          <a:prstGeom prst="rect">
-            <a:avLst/>
-          </a:prstGeom>
-          <a:noFill/>
-          <a:ln/>
-        </p:spPr>
-        <p:txBody>
-          <a:bodyPr wrap="square" lIns="0" tIns="0" rIns="0" bIns="0" rtlCol="0" anchor="t"/>
-          <a:lstStyle/>
-          <a:p>
-            <a:pPr indent="0" marL="0">
-              <a:buNone/>
-            </a:pPr>
-            <a:r>
-              <a:rPr lang="en-US" sz="1350" dirty="0">
-                <a:solidFill>
-                  <a:srgbClr val="5B6478"/>
-                </a:solidFill>
-                <a:latin typeface="Calibri" pitchFamily="34" charset="0"/>
-                <a:ea typeface="Calibri" pitchFamily="34" charset="-122"/>
-                <a:cs typeface="Calibri" pitchFamily="34" charset="-120"/>
-              </a:rPr>
-              <a:t>Báo cáo tổng quan, hướng dẫn sử dụng, mã nguồn trên GitHub, API JSON</a:t>
+              <a:t>(:LuotChoi)-[:HOAN_THANH]-&gt;(:Hinh) lưu trong Neo4j</a:t>
             </a:r>
             <a:endParaRPr lang="en-US" sz="1350" dirty="0"/>
           </a:p>
@@ -10690,7 +10400,7 @@
                 <a:ea typeface="Cambria" pitchFamily="34" charset="-122"/>
                 <a:cs typeface="Cambria" pitchFamily="34" charset="-120"/>
               </a:rPr>
-              <a:t>Hạn chế &amp; hướng phát triển</a:t>
+              <a:t>Kết quả đạt được</a:t>
             </a:r>
             <a:endParaRPr lang="en-US" sz="3200" dirty="0"/>
           </a:p>
@@ -10783,22 +10493,29 @@
         <p:spPr>
           <a:xfrm>
             <a:off x="548640" y="1417320"/>
-            <a:ext cx="5440680" cy="4846320"/>
+            <a:ext cx="2606040" cy="1737360"/>
           </a:xfrm>
           <a:prstGeom prst="roundRect">
             <a:avLst>
-              <a:gd name="adj" fmla="val 2264"/>
+              <a:gd name="adj" fmla="val 6316"/>
             </a:avLst>
           </a:prstGeom>
           <a:solidFill>
-            <a:srgbClr val="F1F3F7"/>
+            <a:srgbClr val="FFFFFF"/>
           </a:solidFill>
           <a:ln w="9525">
             <a:solidFill>
-              <a:srgbClr val="F1F3F7"/>
+              <a:srgbClr val="DDE3EE"/>
             </a:solidFill>
             <a:prstDash val="solid"/>
           </a:ln>
+          <a:effectLst>
+            <a:outerShdw sx="100000" sy="100000" kx="0" ky="0" algn="bl" rotWithShape="0" blurRad="101600" dist="25400" dir="5400000">
+              <a:srgbClr val="1B2540">
+                <a:alpha val="12000"/>
+              </a:srgbClr>
+            </a:outerShdw>
+          </a:effectLst>
         </p:spPr>
       </p:sp>
       <p:sp>
@@ -10809,8 +10526,8 @@
         </p:nvSpPr>
         <p:spPr>
           <a:xfrm>
-            <a:off x="822960" y="1645920"/>
-            <a:ext cx="4846320" cy="457200"/>
+            <a:off x="548640" y="1554480"/>
+            <a:ext cx="2606040" cy="868680"/>
           </a:xfrm>
           <a:prstGeom prst="rect">
             <a:avLst/>
@@ -10822,21 +10539,21 @@
           <a:bodyPr wrap="square" lIns="0" tIns="0" rIns="0" bIns="0" rtlCol="0" anchor="t"/>
           <a:lstStyle/>
           <a:p>
-            <a:pPr indent="0" marL="0">
-              <a:buNone/>
-            </a:pPr>
-            <a:r>
-              <a:rPr lang="en-US" sz="2200" b="1" dirty="0">
-                <a:solidFill>
-                  <a:srgbClr val="5B6478"/>
+            <a:pPr algn="ctr" indent="0" marL="0">
+              <a:buNone/>
+            </a:pPr>
+            <a:r>
+              <a:rPr lang="en-US" sz="4400" b="1" dirty="0">
+                <a:solidFill>
+                  <a:srgbClr val="2F5BEA"/>
                 </a:solidFill>
                 <a:latin typeface="Cambria" pitchFamily="34" charset="0"/>
                 <a:ea typeface="Cambria" pitchFamily="34" charset="-122"/>
                 <a:cs typeface="Cambria" pitchFamily="34" charset="-120"/>
               </a:rPr>
-              <a:t>Hạn chế</a:t>
-            </a:r>
-            <a:endParaRPr lang="en-US" sz="2200" dirty="0"/>
+              <a:t>26</a:t>
+            </a:r>
+            <a:endParaRPr lang="en-US" sz="4400" dirty="0"/>
           </a:p>
         </p:txBody>
       </p:sp>
@@ -10848,8 +10565,8 @@
         </p:nvSpPr>
         <p:spPr>
           <a:xfrm>
-            <a:off x="822960" y="2240280"/>
-            <a:ext cx="4937760" cy="3840480"/>
+            <a:off x="731520" y="2423160"/>
+            <a:ext cx="2240280" cy="640080"/>
           </a:xfrm>
           <a:prstGeom prst="rect">
             <a:avLst/>
@@ -10861,107 +10578,292 @@
           <a:bodyPr wrap="square" lIns="0" tIns="0" rIns="0" bIns="0" rtlCol="0" anchor="t"/>
           <a:lstStyle/>
           <a:p>
-            <a:pPr marL="342900" indent="-342900">
-              <a:spcAft>
-                <a:spcPts val="1000"/>
-              </a:spcAft>
-              <a:buSzPct val="100000"/>
-              <a:buChar char="•"/>
-            </a:pPr>
-            <a:r>
-              <a:rPr lang="en-US" sz="1600" dirty="0">
-                <a:solidFill>
-                  <a:srgbClr val="1D2433"/>
+            <a:pPr algn="ctr" indent="0" marL="0">
+              <a:buNone/>
+            </a:pPr>
+            <a:r>
+              <a:rPr lang="en-US" sz="1350" dirty="0">
+                <a:solidFill>
+                  <a:srgbClr val="5B6478"/>
                 </a:solidFill>
                 <a:latin typeface="Calibri" pitchFamily="34" charset="0"/>
                 <a:ea typeface="Calibri" pitchFamily="34" charset="-122"/>
                 <a:cs typeface="Calibri" pitchFamily="34" charset="-120"/>
               </a:rPr>
-              <a:t>Nhận dạng dựa trên tính chất định tính (song song, bằng nhau, vuông góc), chưa nhận toạ độ đỉnh.</a:t>
-            </a:r>
-            <a:endParaRPr lang="en-US" sz="1600" dirty="0"/>
-          </a:p>
-          <a:p>
-            <a:pPr marL="342900" indent="-342900">
-              <a:spcAft>
-                <a:spcPts val="1000"/>
-              </a:spcAft>
-              <a:buSzPct val="100000"/>
-              <a:buChar char="•"/>
-            </a:pPr>
-            <a:r>
-              <a:rPr lang="en-US" sz="1600" dirty="0">
-                <a:solidFill>
-                  <a:srgbClr val="1D2433"/>
+              <a:t>dấu hiệu nhận biết</a:t>
+            </a:r>
+            <a:endParaRPr lang="en-US" sz="1350" dirty="0"/>
+          </a:p>
+        </p:txBody>
+      </p:sp>
+      <p:sp>
+        <p:nvSpPr>
+          <p:cNvPr id="10" name="Shape 8"/>
+          <p:cNvSpPr/>
+          <p:nvPr/>
+        </p:nvSpPr>
+        <p:spPr>
+          <a:xfrm>
+            <a:off x="3383280" y="1417320"/>
+            <a:ext cx="2606040" cy="1737360"/>
+          </a:xfrm>
+          <a:prstGeom prst="roundRect">
+            <a:avLst>
+              <a:gd name="adj" fmla="val 6316"/>
+            </a:avLst>
+          </a:prstGeom>
+          <a:solidFill>
+            <a:srgbClr val="FFFFFF"/>
+          </a:solidFill>
+          <a:ln w="9525">
+            <a:solidFill>
+              <a:srgbClr val="DDE3EE"/>
+            </a:solidFill>
+            <a:prstDash val="solid"/>
+          </a:ln>
+          <a:effectLst>
+            <a:outerShdw sx="100000" sy="100000" kx="0" ky="0" algn="bl" rotWithShape="0" blurRad="101600" dist="25400" dir="5400000">
+              <a:srgbClr val="1B2540">
+                <a:alpha val="12000"/>
+              </a:srgbClr>
+            </a:outerShdw>
+          </a:effectLst>
+        </p:spPr>
+      </p:sp>
+      <p:sp>
+        <p:nvSpPr>
+          <p:cNvPr id="11" name="Text 9"/>
+          <p:cNvSpPr txBox="1"/>
+          <p:nvPr/>
+        </p:nvSpPr>
+        <p:spPr>
+          <a:xfrm>
+            <a:off x="3383280" y="1554480"/>
+            <a:ext cx="2606040" cy="868680"/>
+          </a:xfrm>
+          <a:prstGeom prst="rect">
+            <a:avLst/>
+          </a:prstGeom>
+          <a:noFill/>
+          <a:ln/>
+        </p:spPr>
+        <p:txBody>
+          <a:bodyPr wrap="square" lIns="0" tIns="0" rIns="0" bIns="0" rtlCol="0" anchor="t"/>
+          <a:lstStyle/>
+          <a:p>
+            <a:pPr algn="ctr" indent="0" marL="0">
+              <a:buNone/>
+            </a:pPr>
+            <a:r>
+              <a:rPr lang="en-US" sz="4400" b="1" dirty="0">
+                <a:solidFill>
+                  <a:srgbClr val="2F5BEA"/>
+                </a:solidFill>
+                <a:latin typeface="Cambria" pitchFamily="34" charset="0"/>
+                <a:ea typeface="Cambria" pitchFamily="34" charset="-122"/>
+                <a:cs typeface="Cambria" pitchFamily="34" charset="-120"/>
+              </a:rPr>
+              <a:t>68</a:t>
+            </a:r>
+            <a:endParaRPr lang="en-US" sz="4400" dirty="0"/>
+          </a:p>
+        </p:txBody>
+      </p:sp>
+      <p:sp>
+        <p:nvSpPr>
+          <p:cNvPr id="12" name="Text 10"/>
+          <p:cNvSpPr txBox="1"/>
+          <p:nvPr/>
+        </p:nvSpPr>
+        <p:spPr>
+          <a:xfrm>
+            <a:off x="3566160" y="2423160"/>
+            <a:ext cx="2240280" cy="640080"/>
+          </a:xfrm>
+          <a:prstGeom prst="rect">
+            <a:avLst/>
+          </a:prstGeom>
+          <a:noFill/>
+          <a:ln/>
+        </p:spPr>
+        <p:txBody>
+          <a:bodyPr wrap="square" lIns="0" tIns="0" rIns="0" bIns="0" rtlCol="0" anchor="t"/>
+          <a:lstStyle/>
+          <a:p>
+            <a:pPr algn="ctr" indent="0" marL="0">
+              <a:buNone/>
+            </a:pPr>
+            <a:r>
+              <a:rPr lang="en-US" sz="1350" dirty="0">
+                <a:solidFill>
+                  <a:srgbClr val="5B6478"/>
                 </a:solidFill>
                 <a:latin typeface="Calibri" pitchFamily="34" charset="0"/>
                 <a:ea typeface="Calibri" pitchFamily="34" charset="-122"/>
                 <a:cs typeface="Calibri" pitchFamily="34" charset="-120"/>
               </a:rPr>
-              <a:t>Chưa phân biệt từng cạnh cụ thể (AB, CD…) trong lời giải.</a:t>
-            </a:r>
-            <a:endParaRPr lang="en-US" sz="1600" dirty="0"/>
-          </a:p>
-          <a:p>
-            <a:pPr marL="342900" indent="-342900">
-              <a:spcAft>
-                <a:spcPts val="1000"/>
-              </a:spcAft>
-              <a:buSzPct val="100000"/>
-              <a:buChar char="•"/>
-            </a:pPr>
-            <a:r>
-              <a:rPr lang="en-US" sz="1600" dirty="0">
-                <a:solidFill>
-                  <a:srgbClr val="1D2433"/>
+              <a:t>công thức tính toán</a:t>
+            </a:r>
+            <a:endParaRPr lang="en-US" sz="1350" dirty="0"/>
+          </a:p>
+        </p:txBody>
+      </p:sp>
+      <p:sp>
+        <p:nvSpPr>
+          <p:cNvPr id="13" name="Shape 11"/>
+          <p:cNvSpPr/>
+          <p:nvPr/>
+        </p:nvSpPr>
+        <p:spPr>
+          <a:xfrm>
+            <a:off x="6217920" y="1417320"/>
+            <a:ext cx="2606040" cy="1737360"/>
+          </a:xfrm>
+          <a:prstGeom prst="roundRect">
+            <a:avLst>
+              <a:gd name="adj" fmla="val 6316"/>
+            </a:avLst>
+          </a:prstGeom>
+          <a:solidFill>
+            <a:srgbClr val="FFFFFF"/>
+          </a:solidFill>
+          <a:ln w="9525">
+            <a:solidFill>
+              <a:srgbClr val="DDE3EE"/>
+            </a:solidFill>
+            <a:prstDash val="solid"/>
+          </a:ln>
+          <a:effectLst>
+            <a:outerShdw sx="100000" sy="100000" kx="0" ky="0" algn="bl" rotWithShape="0" blurRad="101600" dist="25400" dir="5400000">
+              <a:srgbClr val="1B2540">
+                <a:alpha val="12000"/>
+              </a:srgbClr>
+            </a:outerShdw>
+          </a:effectLst>
+        </p:spPr>
+      </p:sp>
+      <p:sp>
+        <p:nvSpPr>
+          <p:cNvPr id="14" name="Text 12"/>
+          <p:cNvSpPr txBox="1"/>
+          <p:nvPr/>
+        </p:nvSpPr>
+        <p:spPr>
+          <a:xfrm>
+            <a:off x="6217920" y="1554480"/>
+            <a:ext cx="2606040" cy="868680"/>
+          </a:xfrm>
+          <a:prstGeom prst="rect">
+            <a:avLst/>
+          </a:prstGeom>
+          <a:noFill/>
+          <a:ln/>
+        </p:spPr>
+        <p:txBody>
+          <a:bodyPr wrap="square" lIns="0" tIns="0" rIns="0" bIns="0" rtlCol="0" anchor="t"/>
+          <a:lstStyle/>
+          <a:p>
+            <a:pPr algn="ctr" indent="0" marL="0">
+              <a:buNone/>
+            </a:pPr>
+            <a:r>
+              <a:rPr lang="en-US" sz="4400" b="1" dirty="0">
+                <a:solidFill>
+                  <a:srgbClr val="0F8A5F"/>
+                </a:solidFill>
+                <a:latin typeface="Cambria" pitchFamily="34" charset="0"/>
+                <a:ea typeface="Cambria" pitchFamily="34" charset="-122"/>
+                <a:cs typeface="Cambria" pitchFamily="34" charset="-120"/>
+              </a:rPr>
+              <a:t>187</a:t>
+            </a:r>
+            <a:endParaRPr lang="en-US" sz="4400" dirty="0"/>
+          </a:p>
+        </p:txBody>
+      </p:sp>
+      <p:sp>
+        <p:nvSpPr>
+          <p:cNvPr id="15" name="Text 13"/>
+          <p:cNvSpPr txBox="1"/>
+          <p:nvPr/>
+        </p:nvSpPr>
+        <p:spPr>
+          <a:xfrm>
+            <a:off x="6400800" y="2423160"/>
+            <a:ext cx="2240280" cy="640080"/>
+          </a:xfrm>
+          <a:prstGeom prst="rect">
+            <a:avLst/>
+          </a:prstGeom>
+          <a:noFill/>
+          <a:ln/>
+        </p:spPr>
+        <p:txBody>
+          <a:bodyPr wrap="square" lIns="0" tIns="0" rIns="0" bIns="0" rtlCol="0" anchor="t"/>
+          <a:lstStyle/>
+          <a:p>
+            <a:pPr algn="ctr" indent="0" marL="0">
+              <a:buNone/>
+            </a:pPr>
+            <a:r>
+              <a:rPr lang="en-US" sz="1350" dirty="0">
+                <a:solidFill>
+                  <a:srgbClr val="5B6478"/>
                 </a:solidFill>
                 <a:latin typeface="Calibri" pitchFamily="34" charset="0"/>
                 <a:ea typeface="Calibri" pitchFamily="34" charset="-122"/>
                 <a:cs typeface="Calibri" pitchFamily="34" charset="-120"/>
               </a:rPr>
-              <a:t>Chỉ xét tứ giác lồi.</a:t>
-            </a:r>
-            <a:endParaRPr lang="en-US" sz="1600" dirty="0"/>
-          </a:p>
-        </p:txBody>
-      </p:sp>
-      <p:sp>
-        <p:nvSpPr>
-          <p:cNvPr id="10" name="Shape 8"/>
+              <a:t>truy vấn khớp kết quả trên Neo4j thật</a:t>
+            </a:r>
+            <a:endParaRPr lang="en-US" sz="1350" dirty="0"/>
+          </a:p>
+        </p:txBody>
+      </p:sp>
+      <p:sp>
+        <p:nvSpPr>
+          <p:cNvPr id="16" name="Shape 14"/>
           <p:cNvSpPr/>
           <p:nvPr/>
         </p:nvSpPr>
         <p:spPr>
           <a:xfrm>
-            <a:off x="6217920" y="1417320"/>
-            <a:ext cx="5440680" cy="4846320"/>
+            <a:off x="9052560" y="1417320"/>
+            <a:ext cx="2606040" cy="1737360"/>
           </a:xfrm>
           <a:prstGeom prst="roundRect">
             <a:avLst>
-              <a:gd name="adj" fmla="val 2264"/>
+              <a:gd name="adj" fmla="val 6316"/>
             </a:avLst>
           </a:prstGeom>
           <a:solidFill>
-            <a:srgbClr val="E8EEFF"/>
+            <a:srgbClr val="FFFFFF"/>
           </a:solidFill>
           <a:ln w="9525">
             <a:solidFill>
-              <a:srgbClr val="E8EEFF"/>
+              <a:srgbClr val="DDE3EE"/>
             </a:solidFill>
             <a:prstDash val="solid"/>
           </a:ln>
-        </p:spPr>
-      </p:sp>
-      <p:sp>
-        <p:nvSpPr>
-          <p:cNvPr id="11" name="Text 9"/>
-          <p:cNvSpPr txBox="1"/>
-          <p:nvPr/>
-        </p:nvSpPr>
-        <p:spPr>
-          <a:xfrm>
-            <a:off x="6492240" y="1645920"/>
-            <a:ext cx="4846320" cy="457200"/>
+          <a:effectLst>
+            <a:outerShdw sx="100000" sy="100000" kx="0" ky="0" algn="bl" rotWithShape="0" blurRad="101600" dist="25400" dir="5400000">
+              <a:srgbClr val="1B2540">
+                <a:alpha val="12000"/>
+              </a:srgbClr>
+            </a:outerShdw>
+          </a:effectLst>
+        </p:spPr>
+      </p:sp>
+      <p:sp>
+        <p:nvSpPr>
+          <p:cNvPr id="17" name="Text 15"/>
+          <p:cNvSpPr txBox="1"/>
+          <p:nvPr/>
+        </p:nvSpPr>
+        <p:spPr>
+          <a:xfrm>
+            <a:off x="9052560" y="1554480"/>
+            <a:ext cx="2606040" cy="868680"/>
           </a:xfrm>
           <a:prstGeom prst="rect">
             <a:avLst/>
@@ -10973,34 +10875,34 @@
           <a:bodyPr wrap="square" lIns="0" tIns="0" rIns="0" bIns="0" rtlCol="0" anchor="t"/>
           <a:lstStyle/>
           <a:p>
-            <a:pPr indent="0" marL="0">
-              <a:buNone/>
-            </a:pPr>
-            <a:r>
-              <a:rPr lang="en-US" sz="2200" b="1" dirty="0">
-                <a:solidFill>
-                  <a:srgbClr val="2F5BEA"/>
+            <a:pPr algn="ctr" indent="0" marL="0">
+              <a:buNone/>
+            </a:pPr>
+            <a:r>
+              <a:rPr lang="en-US" sz="4400" b="1" dirty="0">
+                <a:solidFill>
+                  <a:srgbClr val="0F8A5F"/>
                 </a:solidFill>
                 <a:latin typeface="Cambria" pitchFamily="34" charset="0"/>
                 <a:ea typeface="Cambria" pitchFamily="34" charset="-122"/>
                 <a:cs typeface="Cambria" pitchFamily="34" charset="-120"/>
               </a:rPr>
-              <a:t>Hướng phát triển</a:t>
-            </a:r>
-            <a:endParaRPr lang="en-US" sz="2200" dirty="0"/>
-          </a:p>
-        </p:txBody>
-      </p:sp>
-      <p:sp>
-        <p:nvSpPr>
-          <p:cNvPr id="12" name="Text 10"/>
-          <p:cNvSpPr txBox="1"/>
-          <p:nvPr/>
-        </p:nvSpPr>
-        <p:spPr>
-          <a:xfrm>
-            <a:off x="6492240" y="2240280"/>
-            <a:ext cx="4937760" cy="3840480"/>
+              <a:t>45/45</a:t>
+            </a:r>
+            <a:endParaRPr lang="en-US" sz="4400" dirty="0"/>
+          </a:p>
+        </p:txBody>
+      </p:sp>
+      <p:sp>
+        <p:nvSpPr>
+          <p:cNvPr id="18" name="Text 16"/>
+          <p:cNvSpPr txBox="1"/>
+          <p:nvPr/>
+        </p:nvSpPr>
+        <p:spPr>
+          <a:xfrm>
+            <a:off x="9235440" y="2423160"/>
+            <a:ext cx="2240280" cy="640080"/>
           </a:xfrm>
           <a:prstGeom prst="rect">
             <a:avLst/>
@@ -11012,88 +10914,725 @@
           <a:bodyPr wrap="square" lIns="0" tIns="0" rIns="0" bIns="0" rtlCol="0" anchor="t"/>
           <a:lstStyle/>
           <a:p>
-            <a:pPr marL="342900" indent="-342900">
-              <a:spcAft>
-                <a:spcPts val="1000"/>
-              </a:spcAft>
-              <a:buSzPct val="100000"/>
-              <a:buChar char="•"/>
-            </a:pPr>
-            <a:r>
-              <a:rPr lang="en-US" sz="1600" dirty="0">
-                <a:solidFill>
-                  <a:srgbClr val="1D2433"/>
+            <a:pPr algn="ctr" indent="0" marL="0">
+              <a:buNone/>
+            </a:pPr>
+            <a:r>
+              <a:rPr lang="en-US" sz="1350" dirty="0">
+                <a:solidFill>
+                  <a:srgbClr val="5B6478"/>
                 </a:solidFill>
                 <a:latin typeface="Calibri" pitchFamily="34" charset="0"/>
                 <a:ea typeface="Calibri" pitchFamily="34" charset="-122"/>
                 <a:cs typeface="Calibri" pitchFamily="34" charset="-120"/>
               </a:rPr>
-              <a:t>Nhập toạ độ 4 đỉnh ⇒ tự tính số đo, tính chất rồi đưa vào bộ suy luận.</a:t>
-            </a:r>
-            <a:endParaRPr lang="en-US" sz="1600" dirty="0"/>
-          </a:p>
-          <a:p>
-            <a:pPr marL="342900" indent="-342900">
-              <a:spcAft>
-                <a:spcPts val="1000"/>
-              </a:spcAft>
-              <a:buSzPct val="100000"/>
-              <a:buChar char="•"/>
-            </a:pPr>
-            <a:r>
-              <a:rPr lang="en-US" sz="1600" dirty="0">
-                <a:solidFill>
-                  <a:srgbClr val="1D2433"/>
+              <a:t>ca kiểm thử tự động đạt</a:t>
+            </a:r>
+            <a:endParaRPr lang="en-US" sz="1350" dirty="0"/>
+          </a:p>
+        </p:txBody>
+      </p:sp>
+      <p:sp>
+        <p:nvSpPr>
+          <p:cNvPr id="19" name="Shape 17"/>
+          <p:cNvSpPr/>
+          <p:nvPr/>
+        </p:nvSpPr>
+        <p:spPr>
+          <a:xfrm>
+            <a:off x="548640" y="3520440"/>
+            <a:ext cx="5440680" cy="1188720"/>
+          </a:xfrm>
+          <a:prstGeom prst="roundRect">
+            <a:avLst>
+              <a:gd name="adj" fmla="val 9231"/>
+            </a:avLst>
+          </a:prstGeom>
+          <a:solidFill>
+            <a:srgbClr val="FFFFFF"/>
+          </a:solidFill>
+          <a:ln w="9525">
+            <a:solidFill>
+              <a:srgbClr val="DDE3EE"/>
+            </a:solidFill>
+            <a:prstDash val="solid"/>
+          </a:ln>
+          <a:effectLst>
+            <a:outerShdw sx="100000" sy="100000" kx="0" ky="0" algn="bl" rotWithShape="0" blurRad="101600" dist="25400" dir="5400000">
+              <a:srgbClr val="1B2540">
+                <a:alpha val="12000"/>
+              </a:srgbClr>
+            </a:outerShdw>
+          </a:effectLst>
+        </p:spPr>
+      </p:sp>
+      <p:sp>
+        <p:nvSpPr>
+          <p:cNvPr id="20" name="Shape 18"/>
+          <p:cNvSpPr/>
+          <p:nvPr/>
+        </p:nvSpPr>
+        <p:spPr>
+          <a:xfrm>
+            <a:off x="777240" y="3867912"/>
+            <a:ext cx="502920" cy="502920"/>
+          </a:xfrm>
+          <a:prstGeom prst="ellipse">
+            <a:avLst/>
+          </a:prstGeom>
+          <a:solidFill>
+            <a:srgbClr val="0F8A5F"/>
+          </a:solidFill>
+          <a:ln w="12700">
+            <a:solidFill>
+              <a:srgbClr val="0F8A5F"/>
+            </a:solidFill>
+            <a:prstDash val="solid"/>
+          </a:ln>
+        </p:spPr>
+      </p:sp>
+      <p:sp>
+        <p:nvSpPr>
+          <p:cNvPr id="21" name="Text 19"/>
+          <p:cNvSpPr txBox="1"/>
+          <p:nvPr/>
+        </p:nvSpPr>
+        <p:spPr>
+          <a:xfrm>
+            <a:off x="777240" y="3867912"/>
+            <a:ext cx="502920" cy="502920"/>
+          </a:xfrm>
+          <a:prstGeom prst="rect">
+            <a:avLst/>
+          </a:prstGeom>
+          <a:noFill/>
+          <a:ln/>
+        </p:spPr>
+        <p:txBody>
+          <a:bodyPr wrap="square" lIns="0" tIns="0" rIns="0" bIns="0" rtlCol="0" anchor="ctr"/>
+          <a:lstStyle/>
+          <a:p>
+            <a:pPr algn="ctr" indent="0" marL="0">
+              <a:buNone/>
+            </a:pPr>
+            <a:r>
+              <a:rPr lang="en-US" sz="1600" b="1" dirty="0">
+                <a:solidFill>
+                  <a:srgbClr val="FFFFFF"/>
                 </a:solidFill>
                 <a:latin typeface="Calibri" pitchFamily="34" charset="0"/>
                 <a:ea typeface="Calibri" pitchFamily="34" charset="-122"/>
                 <a:cs typeface="Calibri" pitchFamily="34" charset="-120"/>
               </a:rPr>
-              <a:t>Thêm nút :Canh, :Goc, :DuongCheo để lời giải chi tiết như bài làm của học sinh.</a:t>
+              <a:t>✓</a:t>
             </a:r>
             <a:endParaRPr lang="en-US" sz="1600" dirty="0"/>
           </a:p>
-          <a:p>
-            <a:pPr marL="342900" indent="-342900">
-              <a:spcAft>
-                <a:spcPts val="1000"/>
-              </a:spcAft>
-              <a:buSzPct val="100000"/>
-              <a:buChar char="•"/>
-            </a:pPr>
-            <a:r>
-              <a:rPr lang="en-US" sz="1600" dirty="0">
-                <a:solidFill>
-                  <a:srgbClr val="1D2433"/>
+        </p:txBody>
+      </p:sp>
+      <p:sp>
+        <p:nvSpPr>
+          <p:cNvPr id="22" name="Text 20"/>
+          <p:cNvSpPr txBox="1"/>
+          <p:nvPr/>
+        </p:nvSpPr>
+        <p:spPr>
+          <a:xfrm>
+            <a:off x="1463040" y="3703320"/>
+            <a:ext cx="4389120" cy="411480"/>
+          </a:xfrm>
+          <a:prstGeom prst="rect">
+            <a:avLst/>
+          </a:prstGeom>
+          <a:noFill/>
+          <a:ln/>
+        </p:spPr>
+        <p:txBody>
+          <a:bodyPr wrap="square" lIns="0" tIns="0" rIns="0" bIns="0" rtlCol="0" anchor="t"/>
+          <a:lstStyle/>
+          <a:p>
+            <a:pPr indent="0" marL="0">
+              <a:buNone/>
+            </a:pPr>
+            <a:r>
+              <a:rPr lang="en-US" sz="1700" b="1" dirty="0">
+                <a:solidFill>
+                  <a:srgbClr val="1B2540"/>
                 </a:solidFill>
                 <a:latin typeface="Calibri" pitchFamily="34" charset="0"/>
                 <a:ea typeface="Calibri" pitchFamily="34" charset="-122"/>
                 <a:cs typeface="Calibri" pitchFamily="34" charset="-120"/>
               </a:rPr>
-              <a:t>Mở rộng sang tam giác, đa giác.</a:t>
-            </a:r>
-            <a:endParaRPr lang="en-US" sz="1600" dirty="0"/>
-          </a:p>
-          <a:p>
-            <a:pPr marL="342900" indent="-342900">
-              <a:spcAft>
-                <a:spcPts val="1000"/>
-              </a:spcAft>
-              <a:buSzPct val="100000"/>
-              <a:buChar char="•"/>
-            </a:pPr>
-            <a:r>
-              <a:rPr lang="en-US" sz="1600" dirty="0">
-                <a:solidFill>
-                  <a:srgbClr val="1D2433"/>
+              <a:t>Nhận dạng tứ giác</a:t>
+            </a:r>
+            <a:endParaRPr lang="en-US" sz="1700" dirty="0"/>
+          </a:p>
+        </p:txBody>
+      </p:sp>
+      <p:sp>
+        <p:nvSpPr>
+          <p:cNvPr id="23" name="Text 21"/>
+          <p:cNvSpPr txBox="1"/>
+          <p:nvPr/>
+        </p:nvSpPr>
+        <p:spPr>
+          <a:xfrm>
+            <a:off x="1463040" y="4114800"/>
+            <a:ext cx="4389120" cy="502920"/>
+          </a:xfrm>
+          <a:prstGeom prst="rect">
+            <a:avLst/>
+          </a:prstGeom>
+          <a:noFill/>
+          <a:ln/>
+        </p:spPr>
+        <p:txBody>
+          <a:bodyPr wrap="square" lIns="0" tIns="0" rIns="0" bIns="0" rtlCol="0" anchor="t"/>
+          <a:lstStyle/>
+          <a:p>
+            <a:pPr indent="0" marL="0">
+              <a:buNone/>
+            </a:pPr>
+            <a:r>
+              <a:rPr lang="en-US" sz="1350" dirty="0">
+                <a:solidFill>
+                  <a:srgbClr val="5B6478"/>
                 </a:solidFill>
                 <a:latin typeface="Calibri" pitchFamily="34" charset="0"/>
                 <a:ea typeface="Calibri" pitchFamily="34" charset="-122"/>
                 <a:cs typeface="Calibri" pitchFamily="34" charset="-120"/>
               </a:rPr>
-              <a:t>Lưu lịch sử bài làm của người học thành đồ thị để gợi ý bài tập.</a:t>
+              <a:t>Lời giải từng bước, phát hiện thiếu dữ kiện và mâu thuẫn</a:t>
+            </a:r>
+            <a:endParaRPr lang="en-US" sz="1350" dirty="0"/>
+          </a:p>
+        </p:txBody>
+      </p:sp>
+      <p:sp>
+        <p:nvSpPr>
+          <p:cNvPr id="24" name="Shape 22"/>
+          <p:cNvSpPr/>
+          <p:nvPr/>
+        </p:nvSpPr>
+        <p:spPr>
+          <a:xfrm>
+            <a:off x="6172200" y="3520440"/>
+            <a:ext cx="5440680" cy="1188720"/>
+          </a:xfrm>
+          <a:prstGeom prst="roundRect">
+            <a:avLst>
+              <a:gd name="adj" fmla="val 9231"/>
+            </a:avLst>
+          </a:prstGeom>
+          <a:solidFill>
+            <a:srgbClr val="FFFFFF"/>
+          </a:solidFill>
+          <a:ln w="9525">
+            <a:solidFill>
+              <a:srgbClr val="DDE3EE"/>
+            </a:solidFill>
+            <a:prstDash val="solid"/>
+          </a:ln>
+          <a:effectLst>
+            <a:outerShdw sx="100000" sy="100000" kx="0" ky="0" algn="bl" rotWithShape="0" blurRad="101600" dist="25400" dir="5400000">
+              <a:srgbClr val="1B2540">
+                <a:alpha val="12000"/>
+              </a:srgbClr>
+            </a:outerShdw>
+          </a:effectLst>
+        </p:spPr>
+      </p:sp>
+      <p:sp>
+        <p:nvSpPr>
+          <p:cNvPr id="25" name="Shape 23"/>
+          <p:cNvSpPr/>
+          <p:nvPr/>
+        </p:nvSpPr>
+        <p:spPr>
+          <a:xfrm>
+            <a:off x="6400800" y="3867912"/>
+            <a:ext cx="502920" cy="502920"/>
+          </a:xfrm>
+          <a:prstGeom prst="ellipse">
+            <a:avLst/>
+          </a:prstGeom>
+          <a:solidFill>
+            <a:srgbClr val="0F8A5F"/>
+          </a:solidFill>
+          <a:ln w="12700">
+            <a:solidFill>
+              <a:srgbClr val="0F8A5F"/>
+            </a:solidFill>
+            <a:prstDash val="solid"/>
+          </a:ln>
+        </p:spPr>
+      </p:sp>
+      <p:sp>
+        <p:nvSpPr>
+          <p:cNvPr id="26" name="Text 24"/>
+          <p:cNvSpPr txBox="1"/>
+          <p:nvPr/>
+        </p:nvSpPr>
+        <p:spPr>
+          <a:xfrm>
+            <a:off x="6400800" y="3867912"/>
+            <a:ext cx="502920" cy="502920"/>
+          </a:xfrm>
+          <a:prstGeom prst="rect">
+            <a:avLst/>
+          </a:prstGeom>
+          <a:noFill/>
+          <a:ln/>
+        </p:spPr>
+        <p:txBody>
+          <a:bodyPr wrap="square" lIns="0" tIns="0" rIns="0" bIns="0" rtlCol="0" anchor="ctr"/>
+          <a:lstStyle/>
+          <a:p>
+            <a:pPr algn="ctr" indent="0" marL="0">
+              <a:buNone/>
+            </a:pPr>
+            <a:r>
+              <a:rPr lang="en-US" sz="1600" b="1" dirty="0">
+                <a:solidFill>
+                  <a:srgbClr val="FFFFFF"/>
+                </a:solidFill>
+                <a:latin typeface="Calibri" pitchFamily="34" charset="0"/>
+                <a:ea typeface="Calibri" pitchFamily="34" charset="-122"/>
+                <a:cs typeface="Calibri" pitchFamily="34" charset="-120"/>
+              </a:rPr>
+              <a:t>✓</a:t>
             </a:r>
             <a:endParaRPr lang="en-US" sz="1600" dirty="0"/>
+          </a:p>
+        </p:txBody>
+      </p:sp>
+      <p:sp>
+        <p:nvSpPr>
+          <p:cNvPr id="27" name="Text 25"/>
+          <p:cNvSpPr txBox="1"/>
+          <p:nvPr/>
+        </p:nvSpPr>
+        <p:spPr>
+          <a:xfrm>
+            <a:off x="7086600" y="3703320"/>
+            <a:ext cx="4389120" cy="411480"/>
+          </a:xfrm>
+          <a:prstGeom prst="rect">
+            <a:avLst/>
+          </a:prstGeom>
+          <a:noFill/>
+          <a:ln/>
+        </p:spPr>
+        <p:txBody>
+          <a:bodyPr wrap="square" lIns="0" tIns="0" rIns="0" bIns="0" rtlCol="0" anchor="t"/>
+          <a:lstStyle/>
+          <a:p>
+            <a:pPr indent="0" marL="0">
+              <a:buNone/>
+            </a:pPr>
+            <a:r>
+              <a:rPr lang="en-US" sz="1700" b="1" dirty="0">
+                <a:solidFill>
+                  <a:srgbClr val="1B2540"/>
+                </a:solidFill>
+                <a:latin typeface="Calibri" pitchFamily="34" charset="0"/>
+                <a:ea typeface="Calibri" pitchFamily="34" charset="-122"/>
+                <a:cs typeface="Calibri" pitchFamily="34" charset="-120"/>
+              </a:rPr>
+              <a:t>Tính diện tích, chu vi</a:t>
+            </a:r>
+            <a:endParaRPr lang="en-US" sz="1700" dirty="0"/>
+          </a:p>
+        </p:txBody>
+      </p:sp>
+      <p:sp>
+        <p:nvSpPr>
+          <p:cNvPr id="28" name="Text 26"/>
+          <p:cNvSpPr txBox="1"/>
+          <p:nvPr/>
+        </p:nvSpPr>
+        <p:spPr>
+          <a:xfrm>
+            <a:off x="7086600" y="4114800"/>
+            <a:ext cx="4389120" cy="502920"/>
+          </a:xfrm>
+          <a:prstGeom prst="rect">
+            <a:avLst/>
+          </a:prstGeom>
+          <a:noFill/>
+          <a:ln/>
+        </p:spPr>
+        <p:txBody>
+          <a:bodyPr wrap="square" lIns="0" tIns="0" rIns="0" bIns="0" rtlCol="0" anchor="t"/>
+          <a:lstStyle/>
+          <a:p>
+            <a:pPr indent="0" marL="0">
+              <a:buNone/>
+            </a:pPr>
+            <a:r>
+              <a:rPr lang="en-US" sz="1350" dirty="0">
+                <a:solidFill>
+                  <a:srgbClr val="5B6478"/>
+                </a:solidFill>
+                <a:latin typeface="Calibri" pitchFamily="34" charset="0"/>
+                <a:ea typeface="Calibri" pitchFamily="34" charset="-122"/>
+                <a:cs typeface="Calibri" pitchFamily="34" charset="-120"/>
+              </a:rPr>
+              <a:t>Nhập số liệu bất kỳ, tính mọi đại lượng liên quan</a:t>
+            </a:r>
+            <a:endParaRPr lang="en-US" sz="1350" dirty="0"/>
+          </a:p>
+        </p:txBody>
+      </p:sp>
+      <p:sp>
+        <p:nvSpPr>
+          <p:cNvPr id="29" name="Shape 27"/>
+          <p:cNvSpPr/>
+          <p:nvPr/>
+        </p:nvSpPr>
+        <p:spPr>
+          <a:xfrm>
+            <a:off x="548640" y="4892040"/>
+            <a:ext cx="5440680" cy="1188720"/>
+          </a:xfrm>
+          <a:prstGeom prst="roundRect">
+            <a:avLst>
+              <a:gd name="adj" fmla="val 9231"/>
+            </a:avLst>
+          </a:prstGeom>
+          <a:solidFill>
+            <a:srgbClr val="FFFFFF"/>
+          </a:solidFill>
+          <a:ln w="9525">
+            <a:solidFill>
+              <a:srgbClr val="DDE3EE"/>
+            </a:solidFill>
+            <a:prstDash val="solid"/>
+          </a:ln>
+          <a:effectLst>
+            <a:outerShdw sx="100000" sy="100000" kx="0" ky="0" algn="bl" rotWithShape="0" blurRad="101600" dist="25400" dir="5400000">
+              <a:srgbClr val="1B2540">
+                <a:alpha val="12000"/>
+              </a:srgbClr>
+            </a:outerShdw>
+          </a:effectLst>
+        </p:spPr>
+      </p:sp>
+      <p:sp>
+        <p:nvSpPr>
+          <p:cNvPr id="30" name="Shape 28"/>
+          <p:cNvSpPr/>
+          <p:nvPr/>
+        </p:nvSpPr>
+        <p:spPr>
+          <a:xfrm>
+            <a:off x="777240" y="5239512"/>
+            <a:ext cx="502920" cy="502920"/>
+          </a:xfrm>
+          <a:prstGeom prst="ellipse">
+            <a:avLst/>
+          </a:prstGeom>
+          <a:solidFill>
+            <a:srgbClr val="0F8A5F"/>
+          </a:solidFill>
+          <a:ln w="12700">
+            <a:solidFill>
+              <a:srgbClr val="0F8A5F"/>
+            </a:solidFill>
+            <a:prstDash val="solid"/>
+          </a:ln>
+        </p:spPr>
+      </p:sp>
+      <p:sp>
+        <p:nvSpPr>
+          <p:cNvPr id="31" name="Text 29"/>
+          <p:cNvSpPr txBox="1"/>
+          <p:nvPr/>
+        </p:nvSpPr>
+        <p:spPr>
+          <a:xfrm>
+            <a:off x="777240" y="5239512"/>
+            <a:ext cx="502920" cy="502920"/>
+          </a:xfrm>
+          <a:prstGeom prst="rect">
+            <a:avLst/>
+          </a:prstGeom>
+          <a:noFill/>
+          <a:ln/>
+        </p:spPr>
+        <p:txBody>
+          <a:bodyPr wrap="square" lIns="0" tIns="0" rIns="0" bIns="0" rtlCol="0" anchor="ctr"/>
+          <a:lstStyle/>
+          <a:p>
+            <a:pPr algn="ctr" indent="0" marL="0">
+              <a:buNone/>
+            </a:pPr>
+            <a:r>
+              <a:rPr lang="en-US" sz="1600" b="1" dirty="0">
+                <a:solidFill>
+                  <a:srgbClr val="FFFFFF"/>
+                </a:solidFill>
+                <a:latin typeface="Calibri" pitchFamily="34" charset="0"/>
+                <a:ea typeface="Calibri" pitchFamily="34" charset="-122"/>
+                <a:cs typeface="Calibri" pitchFamily="34" charset="-120"/>
+              </a:rPr>
+              <a:t>✓</a:t>
+            </a:r>
+            <a:endParaRPr lang="en-US" sz="1600" dirty="0"/>
+          </a:p>
+        </p:txBody>
+      </p:sp>
+      <p:sp>
+        <p:nvSpPr>
+          <p:cNvPr id="32" name="Text 30"/>
+          <p:cNvSpPr txBox="1"/>
+          <p:nvPr/>
+        </p:nvSpPr>
+        <p:spPr>
+          <a:xfrm>
+            <a:off x="1463040" y="5074920"/>
+            <a:ext cx="4389120" cy="411480"/>
+          </a:xfrm>
+          <a:prstGeom prst="rect">
+            <a:avLst/>
+          </a:prstGeom>
+          <a:noFill/>
+          <a:ln/>
+        </p:spPr>
+        <p:txBody>
+          <a:bodyPr wrap="square" lIns="0" tIns="0" rIns="0" bIns="0" rtlCol="0" anchor="t"/>
+          <a:lstStyle/>
+          <a:p>
+            <a:pPr indent="0" marL="0">
+              <a:buNone/>
+            </a:pPr>
+            <a:r>
+              <a:rPr lang="en-US" sz="1700" b="1" dirty="0">
+                <a:solidFill>
+                  <a:srgbClr val="1B2540"/>
+                </a:solidFill>
+                <a:latin typeface="Calibri" pitchFamily="34" charset="0"/>
+                <a:ea typeface="Calibri" pitchFamily="34" charset="-122"/>
+                <a:cs typeface="Calibri" pitchFamily="34" charset="-120"/>
+              </a:rPr>
+              <a:t>Trò chơi Thử thách</a:t>
+            </a:r>
+            <a:endParaRPr lang="en-US" sz="1700" dirty="0"/>
+          </a:p>
+        </p:txBody>
+      </p:sp>
+      <p:sp>
+        <p:nvSpPr>
+          <p:cNvPr id="33" name="Text 31"/>
+          <p:cNvSpPr txBox="1"/>
+          <p:nvPr/>
+        </p:nvSpPr>
+        <p:spPr>
+          <a:xfrm>
+            <a:off x="1463040" y="5486400"/>
+            <a:ext cx="4389120" cy="502920"/>
+          </a:xfrm>
+          <a:prstGeom prst="rect">
+            <a:avLst/>
+          </a:prstGeom>
+          <a:noFill/>
+          <a:ln/>
+        </p:spPr>
+        <p:txBody>
+          <a:bodyPr wrap="square" lIns="0" tIns="0" rIns="0" bIns="0" rtlCol="0" anchor="t"/>
+          <a:lstStyle/>
+          <a:p>
+            <a:pPr indent="0" marL="0">
+              <a:buNone/>
+            </a:pPr>
+            <a:r>
+              <a:rPr lang="en-US" sz="1350" dirty="0">
+                <a:solidFill>
+                  <a:srgbClr val="5B6478"/>
+                </a:solidFill>
+                <a:latin typeface="Calibri" pitchFamily="34" charset="0"/>
+                <a:ea typeface="Calibri" pitchFamily="34" charset="-122"/>
+                <a:cs typeface="Calibri" pitchFamily="34" charset="-120"/>
+              </a:rPr>
+              <a:t>Kéo thả 4 đỉnh, Neo4j chấm điểm, bảng xếp hạng lưu trong Neo4j</a:t>
+            </a:r>
+            <a:endParaRPr lang="en-US" sz="1350" dirty="0"/>
+          </a:p>
+        </p:txBody>
+      </p:sp>
+      <p:sp>
+        <p:nvSpPr>
+          <p:cNvPr id="34" name="Shape 32"/>
+          <p:cNvSpPr/>
+          <p:nvPr/>
+        </p:nvSpPr>
+        <p:spPr>
+          <a:xfrm>
+            <a:off x="6172200" y="4892040"/>
+            <a:ext cx="5440680" cy="1188720"/>
+          </a:xfrm>
+          <a:prstGeom prst="roundRect">
+            <a:avLst>
+              <a:gd name="adj" fmla="val 9231"/>
+            </a:avLst>
+          </a:prstGeom>
+          <a:solidFill>
+            <a:srgbClr val="FFFFFF"/>
+          </a:solidFill>
+          <a:ln w="9525">
+            <a:solidFill>
+              <a:srgbClr val="DDE3EE"/>
+            </a:solidFill>
+            <a:prstDash val="solid"/>
+          </a:ln>
+          <a:effectLst>
+            <a:outerShdw sx="100000" sy="100000" kx="0" ky="0" algn="bl" rotWithShape="0" blurRad="101600" dist="25400" dir="5400000">
+              <a:srgbClr val="1B2540">
+                <a:alpha val="12000"/>
+              </a:srgbClr>
+            </a:outerShdw>
+          </a:effectLst>
+        </p:spPr>
+      </p:sp>
+      <p:sp>
+        <p:nvSpPr>
+          <p:cNvPr id="35" name="Shape 33"/>
+          <p:cNvSpPr/>
+          <p:nvPr/>
+        </p:nvSpPr>
+        <p:spPr>
+          <a:xfrm>
+            <a:off x="6400800" y="5239512"/>
+            <a:ext cx="502920" cy="502920"/>
+          </a:xfrm>
+          <a:prstGeom prst="ellipse">
+            <a:avLst/>
+          </a:prstGeom>
+          <a:solidFill>
+            <a:srgbClr val="0F8A5F"/>
+          </a:solidFill>
+          <a:ln w="12700">
+            <a:solidFill>
+              <a:srgbClr val="0F8A5F"/>
+            </a:solidFill>
+            <a:prstDash val="solid"/>
+          </a:ln>
+        </p:spPr>
+      </p:sp>
+      <p:sp>
+        <p:nvSpPr>
+          <p:cNvPr id="36" name="Text 34"/>
+          <p:cNvSpPr txBox="1"/>
+          <p:nvPr/>
+        </p:nvSpPr>
+        <p:spPr>
+          <a:xfrm>
+            <a:off x="6400800" y="5239512"/>
+            <a:ext cx="502920" cy="502920"/>
+          </a:xfrm>
+          <a:prstGeom prst="rect">
+            <a:avLst/>
+          </a:prstGeom>
+          <a:noFill/>
+          <a:ln/>
+        </p:spPr>
+        <p:txBody>
+          <a:bodyPr wrap="square" lIns="0" tIns="0" rIns="0" bIns="0" rtlCol="0" anchor="ctr"/>
+          <a:lstStyle/>
+          <a:p>
+            <a:pPr algn="ctr" indent="0" marL="0">
+              <a:buNone/>
+            </a:pPr>
+            <a:r>
+              <a:rPr lang="en-US" sz="1600" b="1" dirty="0">
+                <a:solidFill>
+                  <a:srgbClr val="FFFFFF"/>
+                </a:solidFill>
+                <a:latin typeface="Calibri" pitchFamily="34" charset="0"/>
+                <a:ea typeface="Calibri" pitchFamily="34" charset="-122"/>
+                <a:cs typeface="Calibri" pitchFamily="34" charset="-120"/>
+              </a:rPr>
+              <a:t>✓</a:t>
+            </a:r>
+            <a:endParaRPr lang="en-US" sz="1600" dirty="0"/>
+          </a:p>
+        </p:txBody>
+      </p:sp>
+      <p:sp>
+        <p:nvSpPr>
+          <p:cNvPr id="37" name="Text 35"/>
+          <p:cNvSpPr txBox="1"/>
+          <p:nvPr/>
+        </p:nvSpPr>
+        <p:spPr>
+          <a:xfrm>
+            <a:off x="7086600" y="5074920"/>
+            <a:ext cx="4389120" cy="411480"/>
+          </a:xfrm>
+          <a:prstGeom prst="rect">
+            <a:avLst/>
+          </a:prstGeom>
+          <a:noFill/>
+          <a:ln/>
+        </p:spPr>
+        <p:txBody>
+          <a:bodyPr wrap="square" lIns="0" tIns="0" rIns="0" bIns="0" rtlCol="0" anchor="t"/>
+          <a:lstStyle/>
+          <a:p>
+            <a:pPr indent="0" marL="0">
+              <a:buNone/>
+            </a:pPr>
+            <a:r>
+              <a:rPr lang="en-US" sz="1700" b="1" dirty="0">
+                <a:solidFill>
+                  <a:srgbClr val="1B2540"/>
+                </a:solidFill>
+                <a:latin typeface="Calibri" pitchFamily="34" charset="0"/>
+                <a:ea typeface="Calibri" pitchFamily="34" charset="-122"/>
+                <a:cs typeface="Calibri" pitchFamily="34" charset="-120"/>
+              </a:rPr>
+              <a:t>Tra cứu, tài liệu &amp; mã nguồn</a:t>
+            </a:r>
+            <a:endParaRPr lang="en-US" sz="1700" dirty="0"/>
+          </a:p>
+        </p:txBody>
+      </p:sp>
+      <p:sp>
+        <p:nvSpPr>
+          <p:cNvPr id="38" name="Text 36"/>
+          <p:cNvSpPr txBox="1"/>
+          <p:nvPr/>
+        </p:nvSpPr>
+        <p:spPr>
+          <a:xfrm>
+            <a:off x="7086600" y="5486400"/>
+            <a:ext cx="4389120" cy="502920"/>
+          </a:xfrm>
+          <a:prstGeom prst="rect">
+            <a:avLst/>
+          </a:prstGeom>
+          <a:noFill/>
+          <a:ln/>
+        </p:spPr>
+        <p:txBody>
+          <a:bodyPr wrap="square" lIns="0" tIns="0" rIns="0" bIns="0" rtlCol="0" anchor="t"/>
+          <a:lstStyle/>
+          <a:p>
+            <a:pPr indent="0" marL="0">
+              <a:buNone/>
+            </a:pPr>
+            <a:r>
+              <a:rPr lang="en-US" sz="1350" dirty="0">
+                <a:solidFill>
+                  <a:srgbClr val="5B6478"/>
+                </a:solidFill>
+                <a:latin typeface="Calibri" pitchFamily="34" charset="0"/>
+                <a:ea typeface="Calibri" pitchFamily="34" charset="-122"/>
+                <a:cs typeface="Calibri" pitchFamily="34" charset="-120"/>
+              </a:rPr>
+              <a:t>Đồ thị tri thức, báo cáo, hướng dẫn sử dụng, GitHub, API JSON</a:t>
+            </a:r>
+            <a:endParaRPr lang="en-US" sz="1350" dirty="0"/>
           </a:p>
         </p:txBody>
       </p:sp>
@@ -11108,6 +11647,544 @@
 <file path=ppt/slides/slide17.xml><?xml version="1.0" encoding="utf-8"?>
 <p:sld xmlns:a="http://schemas.openxmlformats.org/drawingml/2006/main" xmlns:r="http://schemas.openxmlformats.org/officeDocument/2006/relationships" xmlns:p="http://schemas.openxmlformats.org/presentationml/2006/main">
   <p:cSld name="Slide 17">
+    <p:bg>
+      <p:bgPr>
+        <a:solidFill>
+          <a:srgbClr val="F4F6FA"/>
+        </a:solidFill>
+      </p:bgPr>
+    </p:bg>
+    <p:spTree>
+      <p:nvGrpSpPr>
+        <p:cNvPr id="1" name=""/>
+        <p:cNvGrpSpPr/>
+        <p:nvPr/>
+      </p:nvGrpSpPr>
+      <p:grpSpPr>
+        <a:xfrm>
+          <a:off x="0" y="0"/>
+          <a:ext cx="0" cy="0"/>
+          <a:chOff x="0" y="0"/>
+          <a:chExt cx="0" cy="0"/>
+        </a:xfrm>
+      </p:grpSpPr>
+      <p:sp>
+        <p:nvSpPr>
+          <p:cNvPr id="2" name="Shape 0"/>
+          <p:cNvSpPr/>
+          <p:nvPr/>
+        </p:nvSpPr>
+        <p:spPr>
+          <a:xfrm>
+            <a:off x="548640" y="411480"/>
+            <a:ext cx="566928" cy="566928"/>
+          </a:xfrm>
+          <a:prstGeom prst="roundRect">
+            <a:avLst>
+              <a:gd name="adj" fmla="val 16129"/>
+            </a:avLst>
+          </a:prstGeom>
+          <a:solidFill>
+            <a:srgbClr val="2F5BEA"/>
+          </a:solidFill>
+          <a:ln w="12700">
+            <a:solidFill>
+              <a:srgbClr val="2F5BEA"/>
+            </a:solidFill>
+            <a:prstDash val="solid"/>
+          </a:ln>
+        </p:spPr>
+      </p:sp>
+      <p:sp>
+        <p:nvSpPr>
+          <p:cNvPr id="3" name="Text 1"/>
+          <p:cNvSpPr txBox="1"/>
+          <p:nvPr/>
+        </p:nvSpPr>
+        <p:spPr>
+          <a:xfrm>
+            <a:off x="548640" y="411480"/>
+            <a:ext cx="566928" cy="566928"/>
+          </a:xfrm>
+          <a:prstGeom prst="rect">
+            <a:avLst/>
+          </a:prstGeom>
+          <a:noFill/>
+          <a:ln/>
+        </p:spPr>
+        <p:txBody>
+          <a:bodyPr wrap="square" lIns="0" tIns="0" rIns="0" bIns="0" rtlCol="0" anchor="ctr"/>
+          <a:lstStyle/>
+          <a:p>
+            <a:pPr algn="ctr" indent="0" marL="0">
+              <a:buNone/>
+            </a:pPr>
+            <a:r>
+              <a:rPr lang="en-US" sz="2000" b="1" dirty="0">
+                <a:solidFill>
+                  <a:srgbClr val="FFFFFF"/>
+                </a:solidFill>
+                <a:latin typeface="Cambria" pitchFamily="34" charset="0"/>
+                <a:ea typeface="Cambria" pitchFamily="34" charset="-122"/>
+                <a:cs typeface="Cambria" pitchFamily="34" charset="-120"/>
+              </a:rPr>
+              <a:t>6</a:t>
+            </a:r>
+            <a:endParaRPr lang="en-US" sz="2000" dirty="0"/>
+          </a:p>
+        </p:txBody>
+      </p:sp>
+      <p:sp>
+        <p:nvSpPr>
+          <p:cNvPr id="4" name="Text 2"/>
+          <p:cNvSpPr txBox="1"/>
+          <p:nvPr/>
+        </p:nvSpPr>
+        <p:spPr>
+          <a:xfrm>
+            <a:off x="1298448" y="347472"/>
+            <a:ext cx="10314432" cy="640080"/>
+          </a:xfrm>
+          <a:prstGeom prst="rect">
+            <a:avLst/>
+          </a:prstGeom>
+          <a:noFill/>
+          <a:ln/>
+        </p:spPr>
+        <p:txBody>
+          <a:bodyPr wrap="square" lIns="0" tIns="0" rIns="0" bIns="0" rtlCol="0" anchor="ctr"/>
+          <a:lstStyle/>
+          <a:p>
+            <a:pPr indent="0" marL="0">
+              <a:buNone/>
+            </a:pPr>
+            <a:r>
+              <a:rPr lang="en-US" sz="3200" b="1" dirty="0">
+                <a:solidFill>
+                  <a:srgbClr val="1B2540"/>
+                </a:solidFill>
+                <a:latin typeface="Cambria" pitchFamily="34" charset="0"/>
+                <a:ea typeface="Cambria" pitchFamily="34" charset="-122"/>
+                <a:cs typeface="Cambria" pitchFamily="34" charset="-120"/>
+              </a:rPr>
+              <a:t>Hạn chế &amp; hướng phát triển</a:t>
+            </a:r>
+            <a:endParaRPr lang="en-US" sz="3200" dirty="0"/>
+          </a:p>
+        </p:txBody>
+      </p:sp>
+      <p:sp>
+        <p:nvSpPr>
+          <p:cNvPr id="5" name="Text 3"/>
+          <p:cNvSpPr txBox="1"/>
+          <p:nvPr/>
+        </p:nvSpPr>
+        <p:spPr>
+          <a:xfrm>
+            <a:off x="548640" y="6446520"/>
+            <a:ext cx="5486400" cy="274320"/>
+          </a:xfrm>
+          <a:prstGeom prst="rect">
+            <a:avLst/>
+          </a:prstGeom>
+          <a:noFill/>
+          <a:ln/>
+        </p:spPr>
+        <p:txBody>
+          <a:bodyPr wrap="square" lIns="0" tIns="0" rIns="0" bIns="0" rtlCol="0" anchor="t"/>
+          <a:lstStyle/>
+          <a:p>
+            <a:pPr indent="0" marL="0">
+              <a:buNone/>
+            </a:pPr>
+            <a:r>
+              <a:rPr lang="en-US" sz="1000" dirty="0">
+                <a:solidFill>
+                  <a:srgbClr val="8A93A8"/>
+                </a:solidFill>
+                <a:latin typeface="Calibri" pitchFamily="34" charset="0"/>
+                <a:ea typeface="Calibri" pitchFamily="34" charset="-122"/>
+                <a:cs typeface="Calibri" pitchFamily="34" charset="-120"/>
+              </a:rPr>
+              <a:t>Mô hình hoá tứ giác với Neo4j</a:t>
+            </a:r>
+            <a:endParaRPr lang="en-US" sz="1000" dirty="0"/>
+          </a:p>
+        </p:txBody>
+      </p:sp>
+      <p:sp>
+        <p:nvSpPr>
+          <p:cNvPr id="6" name="Text 4"/>
+          <p:cNvSpPr txBox="1"/>
+          <p:nvPr/>
+        </p:nvSpPr>
+        <p:spPr>
+          <a:xfrm>
+            <a:off x="11155680" y="6446520"/>
+            <a:ext cx="502920" cy="274320"/>
+          </a:xfrm>
+          <a:prstGeom prst="rect">
+            <a:avLst/>
+          </a:prstGeom>
+          <a:noFill/>
+          <a:ln/>
+        </p:spPr>
+        <p:txBody>
+          <a:bodyPr wrap="square" lIns="0" tIns="0" rIns="0" bIns="0" rtlCol="0" anchor="t"/>
+          <a:lstStyle/>
+          <a:p>
+            <a:pPr algn="r" indent="0" marL="0">
+              <a:buNone/>
+            </a:pPr>
+            <a:r>
+              <a:rPr lang="en-US" sz="1000" dirty="0">
+                <a:solidFill>
+                  <a:srgbClr val="8A93A8"/>
+                </a:solidFill>
+                <a:latin typeface="Calibri" pitchFamily="34" charset="0"/>
+                <a:ea typeface="Calibri" pitchFamily="34" charset="-122"/>
+                <a:cs typeface="Calibri" pitchFamily="34" charset="-120"/>
+              </a:rPr>
+              <a:t>17</a:t>
+            </a:r>
+            <a:endParaRPr lang="en-US" sz="1000" dirty="0"/>
+          </a:p>
+        </p:txBody>
+      </p:sp>
+      <p:sp>
+        <p:nvSpPr>
+          <p:cNvPr id="7" name="Shape 5"/>
+          <p:cNvSpPr/>
+          <p:nvPr/>
+        </p:nvSpPr>
+        <p:spPr>
+          <a:xfrm>
+            <a:off x="548640" y="1417320"/>
+            <a:ext cx="5440680" cy="4846320"/>
+          </a:xfrm>
+          <a:prstGeom prst="roundRect">
+            <a:avLst>
+              <a:gd name="adj" fmla="val 2264"/>
+            </a:avLst>
+          </a:prstGeom>
+          <a:solidFill>
+            <a:srgbClr val="F1F3F7"/>
+          </a:solidFill>
+          <a:ln w="9525">
+            <a:solidFill>
+              <a:srgbClr val="F1F3F7"/>
+            </a:solidFill>
+            <a:prstDash val="solid"/>
+          </a:ln>
+        </p:spPr>
+      </p:sp>
+      <p:sp>
+        <p:nvSpPr>
+          <p:cNvPr id="8" name="Text 6"/>
+          <p:cNvSpPr txBox="1"/>
+          <p:nvPr/>
+        </p:nvSpPr>
+        <p:spPr>
+          <a:xfrm>
+            <a:off x="822960" y="1645920"/>
+            <a:ext cx="4846320" cy="457200"/>
+          </a:xfrm>
+          <a:prstGeom prst="rect">
+            <a:avLst/>
+          </a:prstGeom>
+          <a:noFill/>
+          <a:ln/>
+        </p:spPr>
+        <p:txBody>
+          <a:bodyPr wrap="square" lIns="0" tIns="0" rIns="0" bIns="0" rtlCol="0" anchor="t"/>
+          <a:lstStyle/>
+          <a:p>
+            <a:pPr indent="0" marL="0">
+              <a:buNone/>
+            </a:pPr>
+            <a:r>
+              <a:rPr lang="en-US" sz="2200" b="1" dirty="0">
+                <a:solidFill>
+                  <a:srgbClr val="5B6478"/>
+                </a:solidFill>
+                <a:latin typeface="Cambria" pitchFamily="34" charset="0"/>
+                <a:ea typeface="Cambria" pitchFamily="34" charset="-122"/>
+                <a:cs typeface="Cambria" pitchFamily="34" charset="-120"/>
+              </a:rPr>
+              <a:t>Hạn chế</a:t>
+            </a:r>
+            <a:endParaRPr lang="en-US" sz="2200" dirty="0"/>
+          </a:p>
+        </p:txBody>
+      </p:sp>
+      <p:sp>
+        <p:nvSpPr>
+          <p:cNvPr id="9" name="Text 7"/>
+          <p:cNvSpPr txBox="1"/>
+          <p:nvPr/>
+        </p:nvSpPr>
+        <p:spPr>
+          <a:xfrm>
+            <a:off x="822960" y="2240280"/>
+            <a:ext cx="4937760" cy="3840480"/>
+          </a:xfrm>
+          <a:prstGeom prst="rect">
+            <a:avLst/>
+          </a:prstGeom>
+          <a:noFill/>
+          <a:ln/>
+        </p:spPr>
+        <p:txBody>
+          <a:bodyPr wrap="square" lIns="0" tIns="0" rIns="0" bIns="0" rtlCol="0" anchor="t"/>
+          <a:lstStyle/>
+          <a:p>
+            <a:pPr marL="342900" indent="-342900">
+              <a:spcAft>
+                <a:spcPts val="1000"/>
+              </a:spcAft>
+              <a:buSzPct val="100000"/>
+              <a:buChar char="•"/>
+            </a:pPr>
+            <a:r>
+              <a:rPr lang="en-US" sz="1600" dirty="0">
+                <a:solidFill>
+                  <a:srgbClr val="1D2433"/>
+                </a:solidFill>
+                <a:latin typeface="Calibri" pitchFamily="34" charset="0"/>
+                <a:ea typeface="Calibri" pitchFamily="34" charset="-122"/>
+                <a:cs typeface="Calibri" pitchFamily="34" charset="-120"/>
+              </a:rPr>
+              <a:t>Nhận dạng từ toạ độ mới có ở trò chơi Thử thách và chỉ với toạ độ nguyên trên lưới.</a:t>
+            </a:r>
+            <a:endParaRPr lang="en-US" sz="1600" dirty="0"/>
+          </a:p>
+          <a:p>
+            <a:pPr marL="342900" indent="-342900">
+              <a:spcAft>
+                <a:spcPts val="1000"/>
+              </a:spcAft>
+              <a:buSzPct val="100000"/>
+              <a:buChar char="•"/>
+            </a:pPr>
+            <a:r>
+              <a:rPr lang="en-US" sz="1600" dirty="0">
+                <a:solidFill>
+                  <a:srgbClr val="1D2433"/>
+                </a:solidFill>
+                <a:latin typeface="Calibri" pitchFamily="34" charset="0"/>
+                <a:ea typeface="Calibri" pitchFamily="34" charset="-122"/>
+                <a:cs typeface="Calibri" pitchFamily="34" charset="-120"/>
+              </a:rPr>
+              <a:t>Chưa phân biệt từng cạnh cụ thể (AB, CD…) trong lời giải.</a:t>
+            </a:r>
+            <a:endParaRPr lang="en-US" sz="1600" dirty="0"/>
+          </a:p>
+          <a:p>
+            <a:pPr marL="342900" indent="-342900">
+              <a:spcAft>
+                <a:spcPts val="1000"/>
+              </a:spcAft>
+              <a:buSzPct val="100000"/>
+              <a:buChar char="•"/>
+            </a:pPr>
+            <a:r>
+              <a:rPr lang="en-US" sz="1600" dirty="0">
+                <a:solidFill>
+                  <a:srgbClr val="1D2433"/>
+                </a:solidFill>
+                <a:latin typeface="Calibri" pitchFamily="34" charset="0"/>
+                <a:ea typeface="Calibri" pitchFamily="34" charset="-122"/>
+                <a:cs typeface="Calibri" pitchFamily="34" charset="-120"/>
+              </a:rPr>
+              <a:t>Chỉ xét tứ giác lồi.</a:t>
+            </a:r>
+            <a:endParaRPr lang="en-US" sz="1600" dirty="0"/>
+          </a:p>
+        </p:txBody>
+      </p:sp>
+      <p:sp>
+        <p:nvSpPr>
+          <p:cNvPr id="10" name="Shape 8"/>
+          <p:cNvSpPr/>
+          <p:nvPr/>
+        </p:nvSpPr>
+        <p:spPr>
+          <a:xfrm>
+            <a:off x="6217920" y="1417320"/>
+            <a:ext cx="5440680" cy="4846320"/>
+          </a:xfrm>
+          <a:prstGeom prst="roundRect">
+            <a:avLst>
+              <a:gd name="adj" fmla="val 2264"/>
+            </a:avLst>
+          </a:prstGeom>
+          <a:solidFill>
+            <a:srgbClr val="E8EEFF"/>
+          </a:solidFill>
+          <a:ln w="9525">
+            <a:solidFill>
+              <a:srgbClr val="E8EEFF"/>
+            </a:solidFill>
+            <a:prstDash val="solid"/>
+          </a:ln>
+        </p:spPr>
+      </p:sp>
+      <p:sp>
+        <p:nvSpPr>
+          <p:cNvPr id="11" name="Text 9"/>
+          <p:cNvSpPr txBox="1"/>
+          <p:nvPr/>
+        </p:nvSpPr>
+        <p:spPr>
+          <a:xfrm>
+            <a:off x="6492240" y="1645920"/>
+            <a:ext cx="4846320" cy="457200"/>
+          </a:xfrm>
+          <a:prstGeom prst="rect">
+            <a:avLst/>
+          </a:prstGeom>
+          <a:noFill/>
+          <a:ln/>
+        </p:spPr>
+        <p:txBody>
+          <a:bodyPr wrap="square" lIns="0" tIns="0" rIns="0" bIns="0" rtlCol="0" anchor="t"/>
+          <a:lstStyle/>
+          <a:p>
+            <a:pPr indent="0" marL="0">
+              <a:buNone/>
+            </a:pPr>
+            <a:r>
+              <a:rPr lang="en-US" sz="2200" b="1" dirty="0">
+                <a:solidFill>
+                  <a:srgbClr val="2F5BEA"/>
+                </a:solidFill>
+                <a:latin typeface="Cambria" pitchFamily="34" charset="0"/>
+                <a:ea typeface="Cambria" pitchFamily="34" charset="-122"/>
+                <a:cs typeface="Cambria" pitchFamily="34" charset="-120"/>
+              </a:rPr>
+              <a:t>Hướng phát triển</a:t>
+            </a:r>
+            <a:endParaRPr lang="en-US" sz="2200" dirty="0"/>
+          </a:p>
+        </p:txBody>
+      </p:sp>
+      <p:sp>
+        <p:nvSpPr>
+          <p:cNvPr id="12" name="Text 10"/>
+          <p:cNvSpPr txBox="1"/>
+          <p:nvPr/>
+        </p:nvSpPr>
+        <p:spPr>
+          <a:xfrm>
+            <a:off x="6492240" y="2240280"/>
+            <a:ext cx="4937760" cy="3840480"/>
+          </a:xfrm>
+          <a:prstGeom prst="rect">
+            <a:avLst/>
+          </a:prstGeom>
+          <a:noFill/>
+          <a:ln/>
+        </p:spPr>
+        <p:txBody>
+          <a:bodyPr wrap="square" lIns="0" tIns="0" rIns="0" bIns="0" rtlCol="0" anchor="t"/>
+          <a:lstStyle/>
+          <a:p>
+            <a:pPr marL="342900" indent="-342900">
+              <a:spcAft>
+                <a:spcPts val="1000"/>
+              </a:spcAft>
+              <a:buSzPct val="100000"/>
+              <a:buChar char="•"/>
+            </a:pPr>
+            <a:r>
+              <a:rPr lang="en-US" sz="1600" dirty="0">
+                <a:solidFill>
+                  <a:srgbClr val="1D2433"/>
+                </a:solidFill>
+                <a:latin typeface="Calibri" pitchFamily="34" charset="0"/>
+                <a:ea typeface="Calibri" pitchFamily="34" charset="-122"/>
+                <a:cs typeface="Calibri" pitchFamily="34" charset="-120"/>
+              </a:rPr>
+              <a:t>Dùng toạ độ 4 đỉnh để tính luôn diện tích, chu vi; cho nhập toạ độ số thực.</a:t>
+            </a:r>
+            <a:endParaRPr lang="en-US" sz="1600" dirty="0"/>
+          </a:p>
+          <a:p>
+            <a:pPr marL="342900" indent="-342900">
+              <a:spcAft>
+                <a:spcPts val="1000"/>
+              </a:spcAft>
+              <a:buSzPct val="100000"/>
+              <a:buChar char="•"/>
+            </a:pPr>
+            <a:r>
+              <a:rPr lang="en-US" sz="1600" dirty="0">
+                <a:solidFill>
+                  <a:srgbClr val="1D2433"/>
+                </a:solidFill>
+                <a:latin typeface="Calibri" pitchFamily="34" charset="0"/>
+                <a:ea typeface="Calibri" pitchFamily="34" charset="-122"/>
+                <a:cs typeface="Calibri" pitchFamily="34" charset="-120"/>
+              </a:rPr>
+              <a:t>Thêm nút :Canh, :Goc, :DuongCheo để lời giải chi tiết như bài làm của học sinh.</a:t>
+            </a:r>
+            <a:endParaRPr lang="en-US" sz="1600" dirty="0"/>
+          </a:p>
+          <a:p>
+            <a:pPr marL="342900" indent="-342900">
+              <a:spcAft>
+                <a:spcPts val="1000"/>
+              </a:spcAft>
+              <a:buSzPct val="100000"/>
+              <a:buChar char="•"/>
+            </a:pPr>
+            <a:r>
+              <a:rPr lang="en-US" sz="1600" dirty="0">
+                <a:solidFill>
+                  <a:srgbClr val="1D2433"/>
+                </a:solidFill>
+                <a:latin typeface="Calibri" pitchFamily="34" charset="0"/>
+                <a:ea typeface="Calibri" pitchFamily="34" charset="-122"/>
+                <a:cs typeface="Calibri" pitchFamily="34" charset="-120"/>
+              </a:rPr>
+              <a:t>Mở rộng sang tam giác, đa giác.</a:t>
+            </a:r>
+            <a:endParaRPr lang="en-US" sz="1600" dirty="0"/>
+          </a:p>
+          <a:p>
+            <a:pPr marL="342900" indent="-342900">
+              <a:spcAft>
+                <a:spcPts val="1000"/>
+              </a:spcAft>
+              <a:buSzPct val="100000"/>
+              <a:buChar char="•"/>
+            </a:pPr>
+            <a:r>
+              <a:rPr lang="en-US" sz="1600" dirty="0">
+                <a:solidFill>
+                  <a:srgbClr val="1D2433"/>
+                </a:solidFill>
+                <a:latin typeface="Calibri" pitchFamily="34" charset="0"/>
+                <a:ea typeface="Calibri" pitchFamily="34" charset="-122"/>
+                <a:cs typeface="Calibri" pitchFamily="34" charset="-120"/>
+              </a:rPr>
+              <a:t>Mở rộng lượt chơi (:LuotChoi) thành hồ sơ người học để gợi ý thử thách, bài tập.</a:t>
+            </a:r>
+            <a:endParaRPr lang="en-US" sz="1600" dirty="0"/>
+          </a:p>
+        </p:txBody>
+      </p:sp>
+    </p:spTree>
+  </p:cSld>
+  <p:clrMapOvr>
+    <a:masterClrMapping/>
+  </p:clrMapOvr>
+</p:sld>
+</file>
+
+<file path=ppt/slides/slide18.xml><?xml version="1.0" encoding="utf-8"?>
+<p:sld xmlns:a="http://schemas.openxmlformats.org/drawingml/2006/main" xmlns:r="http://schemas.openxmlformats.org/officeDocument/2006/relationships" xmlns:p="http://schemas.openxmlformats.org/presentationml/2006/main">
+  <p:cSld name="Slide 18">
     <p:bg>
       <p:bgPr>
         <a:solidFill>
@@ -11240,7 +12317,7 @@
                 <a:ea typeface="Consolas" pitchFamily="34" charset="-122"/>
                 <a:cs typeface="Consolas" pitchFamily="34" charset="-120"/>
               </a:rPr>
-              <a:t>Mã nguồn: github.com/&lt;tên-tài-khoản&gt;/tu-giac-neo4j</a:t>
+              <a:t>Mã nguồn: github.com/LocHegNguyen76/Nhom9_Neo4j</a:t>
             </a:r>
             <a:endParaRPr lang="en-US" sz="1500" dirty="0"/>
           </a:p>
@@ -12308,7 +13385,7 @@
                 <a:ea typeface="Calibri" pitchFamily="34" charset="-122"/>
                 <a:cs typeface="Calibri" pitchFamily="34" charset="-120"/>
               </a:rPr>
-              <a:t>Nhận dạng, tính diện tích – chu vi, tra cứu</a:t>
+              <a:t>Nhận dạng, tính toán, trò chơi Thử thách</a:t>
             </a:r>
             <a:endParaRPr lang="en-US" sz="1300" dirty="0"/>
           </a:p>

</xml_diff>

<commit_message>
Do thi tri thuc bang hinh, thu thach tu chon de
</commit_message>
<xml_diff>
--- a/docs/3_Thuyet_trinh.pptx
+++ b/docs/3_Thuyet_trinh.pptx
@@ -23,9 +23,10 @@
     <p:sldId id="271" r:id="rId17"/>
     <p:sldId id="272" r:id="rId18"/>
     <p:sldId id="273" r:id="rId19"/>
+    <p:sldId id="274" r:id="rId20"/>
   </p:sldIdLst>
   <p:notesMasterIdLst>
-    <p:notesMasterId r:id="rId20"/>
+    <p:notesMasterId r:id="rId21"/>
   </p:notesMasterIdLst>
   <p:sldSz cx="12192000" cy="6858000"/>
   <p:notesSz cx="6858000" cy="12192000"/>
@@ -1047,7 +1048,7 @@
           <a:p>
             <a:r>
               <a:rPr lang="en-US" dirty="0"/>
-              <a:t>Chức năng thứ ba là trò chơi Thử thách. Màn hình có một tứ giác trên lưới ô vuông, đề yêu cầu tạo một hình, ví dụ hình thang. Người chơi kéo các đỉnh; mỗi lần thả chuột, toạ độ được đổi thành các tính chất như song song, bằng nhau, góc vuông, rồi đưa vào đúng bộ suy luận Neo4j. Nếu Neo4j kết luận đúng hình yêu cầu thì cộng điểm và sang thử thách tiếp theo, từ hình thang tới hình vuông. Nếu tạo ra trường hợp đặc biệt, ví dụ đề là hình thang vuông mà kéo ra hình chữ nhật, hệ thống báo gần đúng. Điểm được lưu vào Neo4j thành nút LuotChoi để làm bảng xếp hạng.</a:t>
+              <a:t>Trang đồ thị tri thức vẽ lại toàn bộ tri thức bằng hình ảnh. Mỗi ô là một nút Hinh, vẽ bằng chính hình đó. Mỗi mũi tên là quan hệ LA_MOT, đi từ hình tổng quát xuống hình đặc biệt hơn, và trên mũi tên ghi điều kiện cần thêm — chính là các dấu hiệu nhận biết lưu trong Neo4j, lấy ra bằng câu Cypher bên dưới. Ví dụ hình bình hành có thêm một góc vuông hoặc hai đường chéo bằng nhau thì là hình chữ nhật. Bấm vào một điều kiện sẽ mở trò chơi với đề tương ứng.</a:t>
             </a:r>
             <a:endParaRPr lang="en-US" dirty="0"/>
           </a:p>
@@ -1135,7 +1136,7 @@
           <a:p>
             <a:r>
               <a:rPr lang="en-US" dirty="0"/>
-              <a:t>Kết quả: hệ thống có 26 dấu hiệu nhận biết và 68 công thức. Toàn bộ 187 truy vấn mà ứng dụng gửi tới Neo4j, kể cả các truy vấn của trò chơi Thử thách, đều cho kết quả khớp với kết quả tính độc lập, và 45 ca kiểm thử tự động đều đạt. Nhóm hoàn thành 4 nhóm chức năng như bên dưới, trong đó có trò chơi Thử thách.</a:t>
+              <a:t>Chức năng thứ ba là trò chơi Thử thách. Có hai chế độ: theo vòng 8 thử thách từ hình thang tới hình vuông, hoặc tự chọn đề, ví dụ cho sẵn một hình bình hành và yêu cầu kéo thành hình vuông. Để kéo dễ, có thể kéo cả cạnh — cạnh giữ nguyên hướng nên vẫn song song — kéo cả hình, nhích từng ô bằng phím mũi tên, và khi chọn một đỉnh sẽ hiện đường gợi ý chỗ đặt đỉnh để có cạnh song song hoặc góc vuông. Màn hình có một tứ giác trên lưới ô vuông, đề yêu cầu tạo một hình, ví dụ hình thang. Người chơi kéo các đỉnh; mỗi lần thả chuột, toạ độ được đổi thành các tính chất như song song, bằng nhau, góc vuông, rồi đưa vào đúng bộ suy luận Neo4j. Nếu Neo4j kết luận đúng hình yêu cầu thì cộng điểm và sang thử thách tiếp theo, từ hình thang tới hình vuông. Nếu tạo ra trường hợp đặc biệt, ví dụ đề là hình thang vuông mà kéo ra hình chữ nhật, hệ thống báo gần đúng. Điểm được lưu vào Neo4j thành nút LuotChoi để làm bảng xếp hạng.</a:t>
             </a:r>
             <a:endParaRPr lang="en-US" dirty="0"/>
           </a:p>
@@ -1223,7 +1224,7 @@
           <a:p>
             <a:r>
               <a:rPr lang="en-US" dirty="0"/>
-              <a:t>Hạn chế hiện tại: nhận dạng từ toạ độ mới có ở trò chơi và chỉ với toạ độ nguyên; lời giải chưa chi tiết tới từng cạnh; chỉ xét tứ giác lồi. Hướng phát triển: dùng toạ độ để tính diện tích, chu vi, mở rộng sang tam giác, đa giác và dùng dữ liệu lượt chơi để gợi ý bài tập.</a:t>
+              <a:t>Kết quả: hệ thống có 26 dấu hiệu nhận biết và 68 công thức. Toàn bộ 187 truy vấn mà ứng dụng gửi tới Neo4j, kể cả các truy vấn của trò chơi Thử thách, đều cho kết quả khớp với kết quả tính độc lập, và 50 ca kiểm thử tự động đều đạt. Nhóm hoàn thành 4 nhóm chức năng như bên dưới, trong đó có trò chơi Thử thách.</a:t>
             </a:r>
             <a:endParaRPr lang="en-US" dirty="0"/>
           </a:p>
@@ -1311,7 +1312,7 @@
           <a:p>
             <a:r>
               <a:rPr lang="en-US" dirty="0"/>
-              <a:t>Nhóm em xin cảm ơn thầy và các bạn đã lắng nghe. Nhóm sẵn sàng trả lời câu hỏi.</a:t>
+              <a:t>Hạn chế hiện tại: nhận dạng từ toạ độ mới có ở trò chơi và chỉ với toạ độ nguyên; lời giải chưa chi tiết tới từng cạnh; chỉ xét tứ giác lồi. Hướng phát triển: dùng toạ độ để tính diện tích, chu vi, mở rộng sang tam giác, đa giác và dùng dữ liệu lượt chơi để gợi ý bài tập.</a:t>
             </a:r>
             <a:endParaRPr lang="en-US" dirty="0"/>
           </a:p>
@@ -1335,6 +1336,94 @@
             <a:fld id="{F7021451-1387-4CA6-816F-3879F97B5CBC}" type="slidenum">
               <a:rPr lang="en-US"/>
               <a:t>18</a:t>
+            </a:fld>
+            <a:endParaRPr lang="en-US"/>
+          </a:p>
+        </p:txBody>
+      </p:sp>
+    </p:spTree>
+    <p:extLst>
+      <p:ext uri="{BB962C8B-B14F-4D97-AF65-F5344CB8AC3E}">
+        <p14:creationId xmlns:p14="http://schemas.microsoft.com/office/powerpoint/2010/main" val="1024086991"/>
+      </p:ext>
+    </p:extLst>
+  </p:cSld>
+  <p:clrMapOvr>
+    <a:masterClrMapping/>
+  </p:clrMapOvr>
+</p:notes>
+</file>
+
+<file path=ppt/notesSlides/notesSlide19.xml><?xml version="1.0" encoding="utf-8"?>
+<p:notes xmlns:a="http://schemas.openxmlformats.org/drawingml/2006/main" xmlns:r="http://schemas.openxmlformats.org/officeDocument/2006/relationships" xmlns:p="http://schemas.openxmlformats.org/presentationml/2006/main">
+  <p:cSld>
+    <p:spTree>
+      <p:nvGrpSpPr>
+        <p:cNvPr id="1" name=""/>
+        <p:cNvGrpSpPr/>
+        <p:nvPr/>
+      </p:nvGrpSpPr>
+      <p:grpSpPr>
+        <a:xfrm>
+          <a:off x="0" y="0"/>
+          <a:ext cx="0" cy="0"/>
+          <a:chOff x="0" y="0"/>
+          <a:chExt cx="0" cy="0"/>
+        </a:xfrm>
+      </p:grpSpPr>
+      <p:sp>
+        <p:nvSpPr>
+          <p:cNvPr id="2" name="Slide Image Placeholder 1"/>
+          <p:cNvSpPr>
+            <a:spLocks noGrp="1" noRot="1" noChangeAspect="1"/>
+          </p:cNvSpPr>
+          <p:nvPr>
+            <p:ph type="sldImg"/>
+          </p:nvPr>
+        </p:nvSpPr>
+        <p:spPr/>
+      </p:sp>
+      <p:sp>
+        <p:nvSpPr>
+          <p:cNvPr id="3" name="Notes Placeholder 2"/>
+          <p:cNvSpPr>
+            <a:spLocks noGrp="1"/>
+          </p:cNvSpPr>
+          <p:nvPr>
+            <p:ph type="body" idx="1"/>
+          </p:nvPr>
+        </p:nvSpPr>
+        <p:spPr/>
+        <p:txBody>
+          <a:bodyPr/>
+          <a:lstStyle/>
+          <a:p>
+            <a:r>
+              <a:rPr lang="en-US" dirty="0"/>
+              <a:t>Nhóm em xin cảm ơn thầy và các bạn đã lắng nghe. Nhóm sẵn sàng trả lời câu hỏi.</a:t>
+            </a:r>
+            <a:endParaRPr lang="en-US" dirty="0"/>
+          </a:p>
+        </p:txBody>
+      </p:sp>
+      <p:sp>
+        <p:nvSpPr>
+          <p:cNvPr id="4" name="Slide Number Placeholder 3"/>
+          <p:cNvSpPr>
+            <a:spLocks noGrp="1"/>
+          </p:cNvSpPr>
+          <p:nvPr>
+            <p:ph type="sldNum" sz="quarter" idx="10"/>
+          </p:nvPr>
+        </p:nvSpPr>
+        <p:spPr/>
+        <p:txBody>
+          <a:bodyPr/>
+          <a:lstStyle/>
+          <a:p>
+            <a:fld id="{F7021451-1387-4CA6-816F-3879F97B5CBC}" type="slidenum">
+              <a:rPr lang="en-US"/>
+              <a:t>19</a:t>
             </a:fld>
             <a:endParaRPr lang="en-US"/>
           </a:p>
@@ -4149,7 +4238,7 @@
                 <a:ea typeface="Calibri" pitchFamily="34" charset="-122"/>
                 <a:cs typeface="Calibri" pitchFamily="34" charset="-120"/>
               </a:rPr>
-              <a:t>45 ca kiểm thử</a:t>
+              <a:t>50 ca kiểm thử</a:t>
             </a:r>
             <a:endParaRPr lang="en-US" sz="1200" dirty="0"/>
           </a:p>
@@ -9412,7 +9501,7 @@
                 <a:ea typeface="Cambria" pitchFamily="34" charset="-122"/>
                 <a:cs typeface="Cambria" pitchFamily="34" charset="-120"/>
               </a:rPr>
-              <a:t>Demo: trò chơi Thử thách</a:t>
+              <a:t>Demo: đồ thị tri thức — từ hình này suy ra hình kia</a:t>
             </a:r>
             <a:endParaRPr lang="en-US" sz="3200" dirty="0"/>
           </a:p>
@@ -9451,7 +9540,7 @@
                 <a:ea typeface="Calibri" pitchFamily="34" charset="-122"/>
                 <a:cs typeface="Calibri" pitchFamily="34" charset="-120"/>
               </a:rPr>
-              <a:t>Kéo 4 đỉnh để tạo ra hình được yêu cầu — Neo4j nhận dạng và chấm điểm</a:t>
+              <a:t>Toàn bộ sơ đồ được vẽ từ dữ liệu trong Neo4j</a:t>
             </a:r>
             <a:endParaRPr lang="en-US" sz="1500" dirty="0"/>
           </a:p>
@@ -9537,7 +9626,7 @@
       </p:sp>
       <p:pic>
         <p:nvPicPr>
-          <p:cNvPr id="8" name="Image 0" descr="/tmp/claude-0/-home-claude/98539f31-3192-5884-a81c-346bec00204d/scratchpad/ppt/g_chinhxac.png">    </p:cNvPr>
+          <p:cNvPr id="8" name="Image 0" descr="/tmp/claude-0/-home-claude/98539f31-3192-5884-a81c-346bec00204d/scratchpad/ppt/g_dothi.png">    </p:cNvPr>
           <p:cNvPicPr>
             <a:picLocks noChangeAspect="1"/>
           </p:cNvPicPr>
@@ -9551,8 +9640,8 @@
         </p:blipFill>
         <p:spPr>
           <a:xfrm>
-            <a:off x="548640" y="1463040"/>
-            <a:ext cx="4774019" cy="4800600"/>
+            <a:off x="548640" y="1417320"/>
+            <a:ext cx="5303280" cy="4892040"/>
           </a:xfrm>
           <a:prstGeom prst="rect">
             <a:avLst/>
@@ -9567,8 +9656,8 @@
         </p:nvSpPr>
         <p:spPr>
           <a:xfrm>
-            <a:off x="5688419" y="1481328"/>
-            <a:ext cx="457200" cy="457200"/>
+            <a:off x="6263400" y="1435608"/>
+            <a:ext cx="420624" cy="420624"/>
           </a:xfrm>
           <a:prstGeom prst="ellipse">
             <a:avLst/>
@@ -9592,8 +9681,8 @@
         </p:nvSpPr>
         <p:spPr>
           <a:xfrm>
-            <a:off x="5688419" y="1481328"/>
-            <a:ext cx="457200" cy="457200"/>
+            <a:off x="6263400" y="1435608"/>
+            <a:ext cx="420624" cy="420624"/>
           </a:xfrm>
           <a:prstGeom prst="rect">
             <a:avLst/>
@@ -9631,8 +9720,8 @@
         </p:nvSpPr>
         <p:spPr>
           <a:xfrm>
-            <a:off x="6328499" y="1463040"/>
-            <a:ext cx="5375821" cy="347472"/>
+            <a:off x="6830328" y="1417320"/>
+            <a:ext cx="4828272" cy="329184"/>
           </a:xfrm>
           <a:prstGeom prst="rect">
             <a:avLst/>
@@ -9648,7 +9737,7 @@
               <a:buNone/>
             </a:pPr>
             <a:r>
-              <a:rPr lang="en-US" sz="1700" b="1" dirty="0">
+              <a:rPr lang="en-US" sz="1550" b="1" dirty="0">
                 <a:solidFill>
                   <a:srgbClr val="1B2540"/>
                 </a:solidFill>
@@ -9656,9 +9745,9 @@
                 <a:ea typeface="Calibri" pitchFamily="34" charset="-122"/>
                 <a:cs typeface="Calibri" pitchFamily="34" charset="-120"/>
               </a:rPr>
-              <a:t>Kéo thả đỉnh</a:t>
-            </a:r>
-            <a:endParaRPr lang="en-US" sz="1700" dirty="0"/>
+              <a:t>Mỗi ô là một nút :Hinh</a:t>
+            </a:r>
+            <a:endParaRPr lang="en-US" sz="1550" dirty="0"/>
           </a:p>
         </p:txBody>
       </p:sp>
@@ -9670,8 +9759,8 @@
         </p:nvSpPr>
         <p:spPr>
           <a:xfrm>
-            <a:off x="6328499" y="1847088"/>
-            <a:ext cx="5375821" cy="566928"/>
+            <a:off x="6830328" y="1764792"/>
+            <a:ext cx="4828272" cy="502920"/>
           </a:xfrm>
           <a:prstGeom prst="rect">
             <a:avLst/>
@@ -9687,7 +9776,7 @@
               <a:buNone/>
             </a:pPr>
             <a:r>
-              <a:rPr lang="en-US" sz="1350" dirty="0">
+              <a:rPr lang="en-US" sz="1250" dirty="0">
                 <a:solidFill>
                   <a:srgbClr val="5B6478"/>
                 </a:solidFill>
@@ -9695,9 +9784,9 @@
                 <a:ea typeface="Calibri" pitchFamily="34" charset="-122"/>
                 <a:cs typeface="Calibri" pitchFamily="34" charset="-120"/>
               </a:rPr>
-              <a:t>Đỉnh dính vào lưới ô vuông ⇒ toạ độ nguyên</a:t>
-            </a:r>
-            <a:endParaRPr lang="en-US" sz="1350" dirty="0"/>
+              <a:t>Vẽ bằng chính hình đó, có ký hiệu cạnh bằng nhau, cạnh song song, góc vuông. Bấm vào để tra cứu.</a:t>
+            </a:r>
+            <a:endParaRPr lang="en-US" sz="1250" dirty="0"/>
           </a:p>
         </p:txBody>
       </p:sp>
@@ -9709,8 +9798,8 @@
         </p:nvSpPr>
         <p:spPr>
           <a:xfrm>
-            <a:off x="5688419" y="2459736"/>
-            <a:ext cx="457200" cy="457200"/>
+            <a:off x="6263400" y="2304288"/>
+            <a:ext cx="420624" cy="420624"/>
           </a:xfrm>
           <a:prstGeom prst="ellipse">
             <a:avLst/>
@@ -9734,8 +9823,8 @@
         </p:nvSpPr>
         <p:spPr>
           <a:xfrm>
-            <a:off x="5688419" y="2459736"/>
-            <a:ext cx="457200" cy="457200"/>
+            <a:off x="6263400" y="2304288"/>
+            <a:ext cx="420624" cy="420624"/>
           </a:xfrm>
           <a:prstGeom prst="rect">
             <a:avLst/>
@@ -9773,8 +9862,8 @@
         </p:nvSpPr>
         <p:spPr>
           <a:xfrm>
-            <a:off x="6328499" y="2441448"/>
-            <a:ext cx="5375821" cy="347472"/>
+            <a:off x="6830328" y="2286000"/>
+            <a:ext cx="4828272" cy="329184"/>
           </a:xfrm>
           <a:prstGeom prst="rect">
             <a:avLst/>
@@ -9790,7 +9879,7 @@
               <a:buNone/>
             </a:pPr>
             <a:r>
-              <a:rPr lang="en-US" sz="1700" b="1" dirty="0">
+              <a:rPr lang="en-US" sz="1550" b="1" dirty="0">
                 <a:solidFill>
                   <a:srgbClr val="1B2540"/>
                 </a:solidFill>
@@ -9798,9 +9887,9 @@
                 <a:ea typeface="Calibri" pitchFamily="34" charset="-122"/>
                 <a:cs typeface="Calibri" pitchFamily="34" charset="-120"/>
               </a:rPr>
-              <a:t>Toạ độ → tính chất</a:t>
-            </a:r>
-            <a:endParaRPr lang="en-US" sz="1700" dirty="0"/>
+              <a:t>Mỗi mũi tên là một quan hệ LA_MOT</a:t>
+            </a:r>
+            <a:endParaRPr lang="en-US" sz="1550" dirty="0"/>
           </a:p>
         </p:txBody>
       </p:sp>
@@ -9812,8 +9901,8 @@
         </p:nvSpPr>
         <p:spPr>
           <a:xfrm>
-            <a:off x="6328499" y="2825496"/>
-            <a:ext cx="5375821" cy="566928"/>
+            <a:off x="6830328" y="2633472"/>
+            <a:ext cx="4828272" cy="502920"/>
           </a:xfrm>
           <a:prstGeom prst="rect">
             <a:avLst/>
@@ -9829,7 +9918,7 @@
               <a:buNone/>
             </a:pPr>
             <a:r>
-              <a:rPr lang="en-US" sz="1350" dirty="0">
+              <a:rPr lang="en-US" sz="1250" dirty="0">
                 <a:solidFill>
                   <a:srgbClr val="5B6478"/>
                 </a:solidFill>
@@ -9837,9 +9926,9 @@
                 <a:ea typeface="Calibri" pitchFamily="34" charset="-122"/>
                 <a:cs typeface="Calibri" pitchFamily="34" charset="-120"/>
               </a:rPr>
-              <a:t>Song song ⇔ tích có hướng = 0; vuông góc ⇔ tích vô hướng = 0; bằng nhau ⇔ bình phương độ dài bằng nhau</a:t>
-            </a:r>
-            <a:endParaRPr lang="en-US" sz="1350" dirty="0"/>
+              <a:t>Đi từ hình tổng quát xuống hình đặc biệt hơn.</a:t>
+            </a:r>
+            <a:endParaRPr lang="en-US" sz="1250" dirty="0"/>
           </a:p>
         </p:txBody>
       </p:sp>
@@ -9851,8 +9940,8 @@
         </p:nvSpPr>
         <p:spPr>
           <a:xfrm>
-            <a:off x="5688419" y="3438144"/>
-            <a:ext cx="457200" cy="457200"/>
+            <a:off x="6263400" y="3172968"/>
+            <a:ext cx="420624" cy="420624"/>
           </a:xfrm>
           <a:prstGeom prst="ellipse">
             <a:avLst/>
@@ -9876,8 +9965,8 @@
         </p:nvSpPr>
         <p:spPr>
           <a:xfrm>
-            <a:off x="5688419" y="3438144"/>
-            <a:ext cx="457200" cy="457200"/>
+            <a:off x="6263400" y="3172968"/>
+            <a:ext cx="420624" cy="420624"/>
           </a:xfrm>
           <a:prstGeom prst="rect">
             <a:avLst/>
@@ -9915,8 +10004,8 @@
         </p:nvSpPr>
         <p:spPr>
           <a:xfrm>
-            <a:off x="6328499" y="3419856"/>
-            <a:ext cx="5375821" cy="347472"/>
+            <a:off x="6830328" y="3154680"/>
+            <a:ext cx="4828272" cy="329184"/>
           </a:xfrm>
           <a:prstGeom prst="rect">
             <a:avLst/>
@@ -9932,7 +10021,7 @@
               <a:buNone/>
             </a:pPr>
             <a:r>
-              <a:rPr lang="en-US" sz="1700" b="1" dirty="0">
+              <a:rPr lang="en-US" sz="1550" b="1" dirty="0">
                 <a:solidFill>
                   <a:srgbClr val="1B2540"/>
                 </a:solidFill>
@@ -9940,9 +10029,9 @@
                 <a:ea typeface="Calibri" pitchFamily="34" charset="-122"/>
                 <a:cs typeface="Calibri" pitchFamily="34" charset="-120"/>
               </a:rPr>
-              <a:t>Neo4j suy luận</a:t>
-            </a:r>
-            <a:endParaRPr lang="en-US" sz="1700" dirty="0"/>
+              <a:t>Điều kiện trên mũi tên là các nút :DauHieu</a:t>
+            </a:r>
+            <a:endParaRPr lang="en-US" sz="1550" dirty="0"/>
           </a:p>
         </p:txBody>
       </p:sp>
@@ -9954,8 +10043,8 @@
         </p:nvSpPr>
         <p:spPr>
           <a:xfrm>
-            <a:off x="6328499" y="3803904"/>
-            <a:ext cx="5375821" cy="566928"/>
+            <a:off x="6830328" y="3502152"/>
+            <a:ext cx="4828272" cy="502920"/>
           </a:xfrm>
           <a:prstGeom prst="rect">
             <a:avLst/>
@@ -9971,7 +10060,7 @@
               <a:buNone/>
             </a:pPr>
             <a:r>
-              <a:rPr lang="en-US" sz="1350" dirty="0">
+              <a:rPr lang="en-US" sz="1250" dirty="0">
                 <a:solidFill>
                   <a:srgbClr val="5B6478"/>
                 </a:solidFill>
@@ -9979,9 +10068,9 @@
                 <a:ea typeface="Calibri" pitchFamily="34" charset="-122"/>
                 <a:cs typeface="Calibri" pitchFamily="34" charset="-120"/>
               </a:rPr>
-              <a:t>Dùng chung bộ suy luận với trang Nhận dạng</a:t>
-            </a:r>
-            <a:endParaRPr lang="en-US" sz="1350" dirty="0"/>
+              <a:t>Hình bình hành + 1 góc vuông ⇒ hình chữ nhật. Mỗi dòng “+” là một cách.</a:t>
+            </a:r>
+            <a:endParaRPr lang="en-US" sz="1250" dirty="0"/>
           </a:p>
         </p:txBody>
       </p:sp>
@@ -9993,8 +10082,8 @@
         </p:nvSpPr>
         <p:spPr>
           <a:xfrm>
-            <a:off x="5688419" y="4416552"/>
-            <a:ext cx="457200" cy="457200"/>
+            <a:off x="6263400" y="4041648"/>
+            <a:ext cx="420624" cy="420624"/>
           </a:xfrm>
           <a:prstGeom prst="ellipse">
             <a:avLst/>
@@ -10018,8 +10107,8 @@
         </p:nvSpPr>
         <p:spPr>
           <a:xfrm>
-            <a:off x="5688419" y="4416552"/>
-            <a:ext cx="457200" cy="457200"/>
+            <a:off x="6263400" y="4041648"/>
+            <a:ext cx="420624" cy="420624"/>
           </a:xfrm>
           <a:prstGeom prst="rect">
             <a:avLst/>
@@ -10057,8 +10146,8 @@
         </p:nvSpPr>
         <p:spPr>
           <a:xfrm>
-            <a:off x="6328499" y="4398264"/>
-            <a:ext cx="5375821" cy="347472"/>
+            <a:off x="6830328" y="4023360"/>
+            <a:ext cx="4828272" cy="329184"/>
           </a:xfrm>
           <a:prstGeom prst="rect">
             <a:avLst/>
@@ -10074,7 +10163,7 @@
               <a:buNone/>
             </a:pPr>
             <a:r>
-              <a:rPr lang="en-US" sz="1700" b="1" dirty="0">
+              <a:rPr lang="en-US" sz="1550" b="1" dirty="0">
                 <a:solidFill>
                   <a:srgbClr val="1B2540"/>
                 </a:solidFill>
@@ -10082,9 +10171,9 @@
                 <a:ea typeface="Calibri" pitchFamily="34" charset="-122"/>
                 <a:cs typeface="Calibri" pitchFamily="34" charset="-120"/>
               </a:rPr>
-              <a:t>Chấm điểm</a:t>
-            </a:r>
-            <a:endParaRPr lang="en-US" sz="1700" dirty="0"/>
+              <a:t>Bấm vào điều kiện</a:t>
+            </a:r>
+            <a:endParaRPr lang="en-US" sz="1550" dirty="0"/>
           </a:p>
         </p:txBody>
       </p:sp>
@@ -10096,8 +10185,8 @@
         </p:nvSpPr>
         <p:spPr>
           <a:xfrm>
-            <a:off x="6328499" y="4782312"/>
-            <a:ext cx="5375821" cy="566928"/>
+            <a:off x="6830328" y="4370832"/>
+            <a:ext cx="4828272" cy="502920"/>
           </a:xfrm>
           <a:prstGeom prst="rect">
             <a:avLst/>
@@ -10113,7 +10202,7 @@
               <a:buNone/>
             </a:pPr>
             <a:r>
-              <a:rPr lang="en-US" sz="1350" dirty="0">
+              <a:rPr lang="en-US" sz="1250" dirty="0">
                 <a:solidFill>
                   <a:srgbClr val="5B6478"/>
                 </a:solidFill>
@@ -10121,9 +10210,9 @@
                 <a:ea typeface="Calibri" pitchFamily="34" charset="-122"/>
                 <a:cs typeface="Calibri" pitchFamily="34" charset="-120"/>
               </a:rPr>
-              <a:t>Đúng hình ⇒ +100 điểm + tốc độ + chuỗi; trường hợp đặc biệt (LA_MOT) ⇒ “Gần đúng”</a:t>
-            </a:r>
-            <a:endParaRPr lang="en-US" sz="1350" dirty="0"/>
+              <a:t>Mở trang Thử thách với đề tương ứng.</a:t>
+            </a:r>
+            <a:endParaRPr lang="en-US" sz="1250" dirty="0"/>
           </a:p>
         </p:txBody>
       </p:sp>
@@ -10135,18 +10224,20 @@
         </p:nvSpPr>
         <p:spPr>
           <a:xfrm>
-            <a:off x="5688419" y="5394960"/>
-            <a:ext cx="457200" cy="457200"/>
-          </a:xfrm>
-          <a:prstGeom prst="ellipse">
-            <a:avLst/>
+            <a:off x="6263400" y="4983480"/>
+            <a:ext cx="5395200" cy="1280160"/>
+          </a:xfrm>
+          <a:prstGeom prst="roundRect">
+            <a:avLst>
+              <a:gd name="adj" fmla="val 7143"/>
+            </a:avLst>
           </a:prstGeom>
           <a:solidFill>
-            <a:srgbClr val="0F8A5F"/>
+            <a:srgbClr val="0F1729"/>
           </a:solidFill>
           <a:ln w="12700">
             <a:solidFill>
-              <a:srgbClr val="0F8A5F"/>
+              <a:srgbClr val="0F1729"/>
             </a:solidFill>
             <a:prstDash val="solid"/>
           </a:ln>
@@ -10160,47 +10251,8 @@
         </p:nvSpPr>
         <p:spPr>
           <a:xfrm>
-            <a:off x="5688419" y="5394960"/>
-            <a:ext cx="457200" cy="457200"/>
-          </a:xfrm>
-          <a:prstGeom prst="rect">
-            <a:avLst/>
-          </a:prstGeom>
-          <a:noFill/>
-          <a:ln/>
-        </p:spPr>
-        <p:txBody>
-          <a:bodyPr wrap="square" lIns="0" tIns="0" rIns="0" bIns="0" rtlCol="0" anchor="ctr"/>
-          <a:lstStyle/>
-          <a:p>
-            <a:pPr algn="ctr" indent="0" marL="0">
-              <a:buNone/>
-            </a:pPr>
-            <a:r>
-              <a:rPr lang="en-US" sz="1600" b="1" dirty="0">
-                <a:solidFill>
-                  <a:srgbClr val="FFFFFF"/>
-                </a:solidFill>
-                <a:latin typeface="Calibri" pitchFamily="34" charset="0"/>
-                <a:ea typeface="Calibri" pitchFamily="34" charset="-122"/>
-                <a:cs typeface="Calibri" pitchFamily="34" charset="-120"/>
-              </a:rPr>
-              <a:t>5</a:t>
-            </a:r>
-            <a:endParaRPr lang="en-US" sz="1600" dirty="0"/>
-          </a:p>
-        </p:txBody>
-      </p:sp>
-      <p:sp>
-        <p:nvSpPr>
-          <p:cNvPr id="27" name="Text 24"/>
-          <p:cNvSpPr txBox="1"/>
-          <p:nvPr/>
-        </p:nvSpPr>
-        <p:spPr>
-          <a:xfrm>
-            <a:off x="6328499" y="5376672"/>
-            <a:ext cx="5375821" cy="347472"/>
+            <a:off x="6492000" y="5148072"/>
+            <a:ext cx="4938000" cy="950976"/>
           </a:xfrm>
           <a:prstGeom prst="rect">
             <a:avLst/>
@@ -10216,56 +10268,68 @@
               <a:buNone/>
             </a:pPr>
             <a:r>
-              <a:rPr lang="en-US" sz="1700" b="1" dirty="0">
-                <a:solidFill>
-                  <a:srgbClr val="1B2540"/>
-                </a:solidFill>
-                <a:latin typeface="Calibri" pitchFamily="34" charset="0"/>
-                <a:ea typeface="Calibri" pitchFamily="34" charset="-122"/>
-                <a:cs typeface="Calibri" pitchFamily="34" charset="-120"/>
-              </a:rPr>
-              <a:t>Bảng xếp hạng</a:t>
-            </a:r>
-            <a:endParaRPr lang="en-US" sz="1700" dirty="0"/>
-          </a:p>
-        </p:txBody>
-      </p:sp>
-      <p:sp>
-        <p:nvSpPr>
-          <p:cNvPr id="28" name="Text 25"/>
-          <p:cNvSpPr txBox="1"/>
-          <p:nvPr/>
-        </p:nvSpPr>
-        <p:spPr>
-          <a:xfrm>
-            <a:off x="6328499" y="5760720"/>
-            <a:ext cx="5375821" cy="566928"/>
-          </a:xfrm>
-          <a:prstGeom prst="rect">
-            <a:avLst/>
-          </a:prstGeom>
-          <a:noFill/>
-          <a:ln/>
-        </p:spPr>
-        <p:txBody>
-          <a:bodyPr wrap="square" lIns="0" tIns="0" rIns="0" bIns="0" rtlCol="0" anchor="t"/>
-          <a:lstStyle/>
+              <a:rPr lang="en-US" sz="1150" dirty="0">
+                <a:solidFill>
+                  <a:srgbClr val="D6E2FF"/>
+                </a:solidFill>
+                <a:latin typeface="Consolas" pitchFamily="34" charset="0"/>
+                <a:ea typeface="Consolas" pitchFamily="34" charset="-122"/>
+                <a:cs typeface="Consolas" pitchFamily="34" charset="-120"/>
+              </a:rPr>
+              <a:t>MATCH (d:DauHieu)-[:AP_DUNG_CHO]-&gt;(x:Hinh),</a:t>
+            </a:r>
+            <a:endParaRPr lang="en-US" sz="1150" dirty="0"/>
+          </a:p>
           <a:p>
             <a:pPr indent="0" marL="0">
               <a:buNone/>
             </a:pPr>
             <a:r>
-              <a:rPr lang="en-US" sz="1350" dirty="0">
-                <a:solidFill>
-                  <a:srgbClr val="5B6478"/>
-                </a:solidFill>
-                <a:latin typeface="Calibri" pitchFamily="34" charset="0"/>
-                <a:ea typeface="Calibri" pitchFamily="34" charset="-122"/>
-                <a:cs typeface="Calibri" pitchFamily="34" charset="-120"/>
-              </a:rPr>
-              <a:t>(:LuotChoi)-[:HOAN_THANH]-&gt;(:Hinh) lưu trong Neo4j</a:t>
-            </a:r>
-            <a:endParaRPr lang="en-US" sz="1350" dirty="0"/>
+              <a:rPr lang="en-US" sz="1150" dirty="0">
+                <a:solidFill>
+                  <a:srgbClr val="D6E2FF"/>
+                </a:solidFill>
+                <a:latin typeface="Consolas" pitchFamily="34" charset="0"/>
+                <a:ea typeface="Consolas" pitchFamily="34" charset="-122"/>
+                <a:cs typeface="Consolas" pitchFamily="34" charset="-120"/>
+              </a:rPr>
+              <a:t>      (d)-[:KET_LUAN]-&gt;(k:Hinh)</a:t>
+            </a:r>
+            <a:endParaRPr lang="en-US" sz="1150" dirty="0"/>
+          </a:p>
+          <a:p>
+            <a:pPr indent="0" marL="0">
+              <a:buNone/>
+            </a:pPr>
+            <a:r>
+              <a:rPr lang="en-US" sz="1150" dirty="0">
+                <a:solidFill>
+                  <a:srgbClr val="D6E2FF"/>
+                </a:solidFill>
+                <a:latin typeface="Consolas" pitchFamily="34" charset="0"/>
+                <a:ea typeface="Consolas" pitchFamily="34" charset="-122"/>
+                <a:cs typeface="Consolas" pitchFamily="34" charset="-120"/>
+              </a:rPr>
+              <a:t>RETURN x.ma AS tu, k.ma AS den,</a:t>
+            </a:r>
+            <a:endParaRPr lang="en-US" sz="1150" dirty="0"/>
+          </a:p>
+          <a:p>
+            <a:pPr indent="0" marL="0">
+              <a:buNone/>
+            </a:pPr>
+            <a:r>
+              <a:rPr lang="en-US" sz="1150" dirty="0">
+                <a:solidFill>
+                  <a:srgbClr val="D6E2FF"/>
+                </a:solidFill>
+                <a:latin typeface="Consolas" pitchFamily="34" charset="0"/>
+                <a:ea typeface="Consolas" pitchFamily="34" charset="-122"/>
+                <a:cs typeface="Consolas" pitchFamily="34" charset="-120"/>
+              </a:rPr>
+              <a:t>  [(d)-[:CAN]-&gt;(t:TinhChat) | t.ten_ngan] AS can</a:t>
+            </a:r>
+            <a:endParaRPr lang="en-US" sz="1150" dirty="0"/>
           </a:p>
         </p:txBody>
       </p:sp>
@@ -10361,7 +10425,7 @@
                 <a:ea typeface="Cambria" pitchFamily="34" charset="-122"/>
                 <a:cs typeface="Cambria" pitchFamily="34" charset="-120"/>
               </a:rPr>
-              <a:t>6</a:t>
+              <a:t>5</a:t>
             </a:r>
             <a:endParaRPr lang="en-US" sz="2000" dirty="0"/>
           </a:p>
@@ -10400,7 +10464,7 @@
                 <a:ea typeface="Cambria" pitchFamily="34" charset="-122"/>
                 <a:cs typeface="Cambria" pitchFamily="34" charset="-120"/>
               </a:rPr>
-              <a:t>Kết quả đạt được</a:t>
+              <a:t>Demo: trò chơi Thử thách</a:t>
             </a:r>
             <a:endParaRPr lang="en-US" sz="3200" dirty="0"/>
           </a:p>
@@ -10409,6 +10473,45 @@
       <p:sp>
         <p:nvSpPr>
           <p:cNvPr id="5" name="Text 3"/>
+          <p:cNvSpPr txBox="1"/>
+          <p:nvPr/>
+        </p:nvSpPr>
+        <p:spPr>
+          <a:xfrm>
+            <a:off x="1298448" y="960120"/>
+            <a:ext cx="10314432" cy="365760"/>
+          </a:xfrm>
+          <a:prstGeom prst="rect">
+            <a:avLst/>
+          </a:prstGeom>
+          <a:noFill/>
+          <a:ln/>
+        </p:spPr>
+        <p:txBody>
+          <a:bodyPr wrap="square" lIns="0" tIns="0" rIns="0" bIns="0" rtlCol="0" anchor="t"/>
+          <a:lstStyle/>
+          <a:p>
+            <a:pPr indent="0" marL="0">
+              <a:buNone/>
+            </a:pPr>
+            <a:r>
+              <a:rPr lang="en-US" sz="1500" dirty="0">
+                <a:solidFill>
+                  <a:srgbClr val="5B6478"/>
+                </a:solidFill>
+                <a:latin typeface="Calibri" pitchFamily="34" charset="0"/>
+                <a:ea typeface="Calibri" pitchFamily="34" charset="-122"/>
+                <a:cs typeface="Calibri" pitchFamily="34" charset="-120"/>
+              </a:rPr>
+              <a:t>Kéo 4 đỉnh để tạo ra hình được yêu cầu — Neo4j nhận dạng và chấm điểm</a:t>
+            </a:r>
+            <a:endParaRPr lang="en-US" sz="1500" dirty="0"/>
+          </a:p>
+        </p:txBody>
+      </p:sp>
+      <p:sp>
+        <p:nvSpPr>
+          <p:cNvPr id="6" name="Text 4"/>
           <p:cNvSpPr txBox="1"/>
           <p:nvPr/>
         </p:nvSpPr>
@@ -10447,7 +10550,7 @@
       </p:sp>
       <p:sp>
         <p:nvSpPr>
-          <p:cNvPr id="6" name="Text 4"/>
+          <p:cNvPr id="7" name="Text 5"/>
           <p:cNvSpPr txBox="1"/>
           <p:nvPr/>
         </p:nvSpPr>
@@ -10484,50 +10587,104 @@
           </a:p>
         </p:txBody>
       </p:sp>
-      <p:sp>
-        <p:nvSpPr>
-          <p:cNvPr id="7" name="Shape 5"/>
+      <p:pic>
+        <p:nvPicPr>
+          <p:cNvPr id="8" name="Image 0" descr="/tmp/claude-0/-home-claude/98539f31-3192-5884-a81c-346bec00204d/scratchpad/ppt/g_tuchon.png">    </p:cNvPr>
+          <p:cNvPicPr>
+            <a:picLocks noChangeAspect="1"/>
+          </p:cNvPicPr>
+          <p:nvPr/>
+        </p:nvPicPr>
+        <p:blipFill>
+          <a:blip r:embed="rId1"/>
+          <a:stretch>
+            <a:fillRect/>
+          </a:stretch>
+        </p:blipFill>
+        <p:spPr>
+          <a:xfrm>
+            <a:off x="548640" y="1417320"/>
+            <a:ext cx="3903223" cy="4892040"/>
+          </a:xfrm>
+          <a:prstGeom prst="rect">
+            <a:avLst/>
+          </a:prstGeom>
+        </p:spPr>
+      </p:pic>
+      <p:sp>
+        <p:nvSpPr>
+          <p:cNvPr id="9" name="Shape 6"/>
           <p:cNvSpPr/>
           <p:nvPr/>
         </p:nvSpPr>
         <p:spPr>
           <a:xfrm>
-            <a:off x="548640" y="1417320"/>
-            <a:ext cx="2606040" cy="1737360"/>
-          </a:xfrm>
-          <a:prstGeom prst="roundRect">
-            <a:avLst>
-              <a:gd name="adj" fmla="val 6316"/>
-            </a:avLst>
+            <a:off x="4817623" y="1481328"/>
+            <a:ext cx="457200" cy="457200"/>
+          </a:xfrm>
+          <a:prstGeom prst="ellipse">
+            <a:avLst/>
           </a:prstGeom>
           <a:solidFill>
-            <a:srgbClr val="FFFFFF"/>
+            <a:srgbClr val="2F5BEA"/>
           </a:solidFill>
-          <a:ln w="9525">
+          <a:ln w="12700">
             <a:solidFill>
-              <a:srgbClr val="DDE3EE"/>
+              <a:srgbClr val="2F5BEA"/>
             </a:solidFill>
             <a:prstDash val="solid"/>
           </a:ln>
-          <a:effectLst>
-            <a:outerShdw sx="100000" sy="100000" kx="0" ky="0" algn="bl" rotWithShape="0" blurRad="101600" dist="25400" dir="5400000">
-              <a:srgbClr val="1B2540">
-                <a:alpha val="12000"/>
-              </a:srgbClr>
-            </a:outerShdw>
-          </a:effectLst>
-        </p:spPr>
-      </p:sp>
-      <p:sp>
-        <p:nvSpPr>
-          <p:cNvPr id="8" name="Text 6"/>
-          <p:cNvSpPr txBox="1"/>
-          <p:nvPr/>
-        </p:nvSpPr>
-        <p:spPr>
-          <a:xfrm>
-            <a:off x="548640" y="1554480"/>
-            <a:ext cx="2606040" cy="868680"/>
+        </p:spPr>
+      </p:sp>
+      <p:sp>
+        <p:nvSpPr>
+          <p:cNvPr id="10" name="Text 7"/>
+          <p:cNvSpPr txBox="1"/>
+          <p:nvPr/>
+        </p:nvSpPr>
+        <p:spPr>
+          <a:xfrm>
+            <a:off x="4817623" y="1481328"/>
+            <a:ext cx="457200" cy="457200"/>
+          </a:xfrm>
+          <a:prstGeom prst="rect">
+            <a:avLst/>
+          </a:prstGeom>
+          <a:noFill/>
+          <a:ln/>
+        </p:spPr>
+        <p:txBody>
+          <a:bodyPr wrap="square" lIns="0" tIns="0" rIns="0" bIns="0" rtlCol="0" anchor="ctr"/>
+          <a:lstStyle/>
+          <a:p>
+            <a:pPr algn="ctr" indent="0" marL="0">
+              <a:buNone/>
+            </a:pPr>
+            <a:r>
+              <a:rPr lang="en-US" sz="1600" b="1" dirty="0">
+                <a:solidFill>
+                  <a:srgbClr val="FFFFFF"/>
+                </a:solidFill>
+                <a:latin typeface="Calibri" pitchFamily="34" charset="0"/>
+                <a:ea typeface="Calibri" pitchFamily="34" charset="-122"/>
+                <a:cs typeface="Calibri" pitchFamily="34" charset="-120"/>
+              </a:rPr>
+              <a:t>1</a:t>
+            </a:r>
+            <a:endParaRPr lang="en-US" sz="1600" dirty="0"/>
+          </a:p>
+        </p:txBody>
+      </p:sp>
+      <p:sp>
+        <p:nvSpPr>
+          <p:cNvPr id="11" name="Text 8"/>
+          <p:cNvSpPr txBox="1"/>
+          <p:nvPr/>
+        </p:nvSpPr>
+        <p:spPr>
+          <a:xfrm>
+            <a:off x="5457703" y="1463040"/>
+            <a:ext cx="6246617" cy="347472"/>
           </a:xfrm>
           <a:prstGeom prst="rect">
             <a:avLst/>
@@ -10539,34 +10696,34 @@
           <a:bodyPr wrap="square" lIns="0" tIns="0" rIns="0" bIns="0" rtlCol="0" anchor="t"/>
           <a:lstStyle/>
           <a:p>
-            <a:pPr algn="ctr" indent="0" marL="0">
-              <a:buNone/>
-            </a:pPr>
-            <a:r>
-              <a:rPr lang="en-US" sz="4400" b="1" dirty="0">
-                <a:solidFill>
-                  <a:srgbClr val="2F5BEA"/>
-                </a:solidFill>
-                <a:latin typeface="Cambria" pitchFamily="34" charset="0"/>
-                <a:ea typeface="Cambria" pitchFamily="34" charset="-122"/>
-                <a:cs typeface="Cambria" pitchFamily="34" charset="-120"/>
-              </a:rPr>
-              <a:t>26</a:t>
-            </a:r>
-            <a:endParaRPr lang="en-US" sz="4400" dirty="0"/>
-          </a:p>
-        </p:txBody>
-      </p:sp>
-      <p:sp>
-        <p:nvSpPr>
-          <p:cNvPr id="9" name="Text 7"/>
-          <p:cNvSpPr txBox="1"/>
-          <p:nvPr/>
-        </p:nvSpPr>
-        <p:spPr>
-          <a:xfrm>
-            <a:off x="731520" y="2423160"/>
-            <a:ext cx="2240280" cy="640080"/>
+            <a:pPr indent="0" marL="0">
+              <a:buNone/>
+            </a:pPr>
+            <a:r>
+              <a:rPr lang="en-US" sz="1700" b="1" dirty="0">
+                <a:solidFill>
+                  <a:srgbClr val="1B2540"/>
+                </a:solidFill>
+                <a:latin typeface="Calibri" pitchFamily="34" charset="0"/>
+                <a:ea typeface="Calibri" pitchFamily="34" charset="-122"/>
+                <a:cs typeface="Calibri" pitchFamily="34" charset="-120"/>
+              </a:rPr>
+              <a:t>Hai chế độ</a:t>
+            </a:r>
+            <a:endParaRPr lang="en-US" sz="1700" dirty="0"/>
+          </a:p>
+        </p:txBody>
+      </p:sp>
+      <p:sp>
+        <p:nvSpPr>
+          <p:cNvPr id="12" name="Text 9"/>
+          <p:cNvSpPr txBox="1"/>
+          <p:nvPr/>
+        </p:nvSpPr>
+        <p:spPr>
+          <a:xfrm>
+            <a:off x="5457703" y="1847088"/>
+            <a:ext cx="6246617" cy="566928"/>
           </a:xfrm>
           <a:prstGeom prst="rect">
             <a:avLst/>
@@ -10578,7 +10735,7 @@
           <a:bodyPr wrap="square" lIns="0" tIns="0" rIns="0" bIns="0" rtlCol="0" anchor="t"/>
           <a:lstStyle/>
           <a:p>
-            <a:pPr algn="ctr" indent="0" marL="0">
+            <a:pPr indent="0" marL="0">
               <a:buNone/>
             </a:pPr>
             <a:r>
@@ -10590,7 +10747,7 @@
                 <a:ea typeface="Calibri" pitchFamily="34" charset="-122"/>
                 <a:cs typeface="Calibri" pitchFamily="34" charset="-120"/>
               </a:rPr>
-              <a:t>dấu hiệu nhận biết</a:t>
+              <a:t>Theo vòng 8 thử thách, hoặc Tự chọn đề: chọn hình cho sẵn và hình cần tạo (vd. từ hình bình hành tạo hình vuông)</a:t>
             </a:r>
             <a:endParaRPr lang="en-US" sz="1350" dirty="0"/>
           </a:p>
@@ -10598,48 +10755,78 @@
       </p:sp>
       <p:sp>
         <p:nvSpPr>
-          <p:cNvPr id="10" name="Shape 8"/>
+          <p:cNvPr id="13" name="Shape 10"/>
           <p:cNvSpPr/>
           <p:nvPr/>
         </p:nvSpPr>
         <p:spPr>
           <a:xfrm>
-            <a:off x="3383280" y="1417320"/>
-            <a:ext cx="2606040" cy="1737360"/>
-          </a:xfrm>
-          <a:prstGeom prst="roundRect">
-            <a:avLst>
-              <a:gd name="adj" fmla="val 6316"/>
-            </a:avLst>
+            <a:off x="4817623" y="2459736"/>
+            <a:ext cx="457200" cy="457200"/>
+          </a:xfrm>
+          <a:prstGeom prst="ellipse">
+            <a:avLst/>
           </a:prstGeom>
           <a:solidFill>
-            <a:srgbClr val="FFFFFF"/>
+            <a:srgbClr val="2F5BEA"/>
           </a:solidFill>
-          <a:ln w="9525">
+          <a:ln w="12700">
             <a:solidFill>
-              <a:srgbClr val="DDE3EE"/>
+              <a:srgbClr val="2F5BEA"/>
             </a:solidFill>
             <a:prstDash val="solid"/>
           </a:ln>
-          <a:effectLst>
-            <a:outerShdw sx="100000" sy="100000" kx="0" ky="0" algn="bl" rotWithShape="0" blurRad="101600" dist="25400" dir="5400000">
-              <a:srgbClr val="1B2540">
-                <a:alpha val="12000"/>
-              </a:srgbClr>
-            </a:outerShdw>
-          </a:effectLst>
-        </p:spPr>
-      </p:sp>
-      <p:sp>
-        <p:nvSpPr>
-          <p:cNvPr id="11" name="Text 9"/>
-          <p:cNvSpPr txBox="1"/>
-          <p:nvPr/>
-        </p:nvSpPr>
-        <p:spPr>
-          <a:xfrm>
-            <a:off x="3383280" y="1554480"/>
-            <a:ext cx="2606040" cy="868680"/>
+        </p:spPr>
+      </p:sp>
+      <p:sp>
+        <p:nvSpPr>
+          <p:cNvPr id="14" name="Text 11"/>
+          <p:cNvSpPr txBox="1"/>
+          <p:nvPr/>
+        </p:nvSpPr>
+        <p:spPr>
+          <a:xfrm>
+            <a:off x="4817623" y="2459736"/>
+            <a:ext cx="457200" cy="457200"/>
+          </a:xfrm>
+          <a:prstGeom prst="rect">
+            <a:avLst/>
+          </a:prstGeom>
+          <a:noFill/>
+          <a:ln/>
+        </p:spPr>
+        <p:txBody>
+          <a:bodyPr wrap="square" lIns="0" tIns="0" rIns="0" bIns="0" rtlCol="0" anchor="ctr"/>
+          <a:lstStyle/>
+          <a:p>
+            <a:pPr algn="ctr" indent="0" marL="0">
+              <a:buNone/>
+            </a:pPr>
+            <a:r>
+              <a:rPr lang="en-US" sz="1600" b="1" dirty="0">
+                <a:solidFill>
+                  <a:srgbClr val="FFFFFF"/>
+                </a:solidFill>
+                <a:latin typeface="Calibri" pitchFamily="34" charset="0"/>
+                <a:ea typeface="Calibri" pitchFamily="34" charset="-122"/>
+                <a:cs typeface="Calibri" pitchFamily="34" charset="-120"/>
+              </a:rPr>
+              <a:t>2</a:t>
+            </a:r>
+            <a:endParaRPr lang="en-US" sz="1600" dirty="0"/>
+          </a:p>
+        </p:txBody>
+      </p:sp>
+      <p:sp>
+        <p:nvSpPr>
+          <p:cNvPr id="15" name="Text 12"/>
+          <p:cNvSpPr txBox="1"/>
+          <p:nvPr/>
+        </p:nvSpPr>
+        <p:spPr>
+          <a:xfrm>
+            <a:off x="5457703" y="2441448"/>
+            <a:ext cx="6246617" cy="347472"/>
           </a:xfrm>
           <a:prstGeom prst="rect">
             <a:avLst/>
@@ -10651,34 +10838,34 @@
           <a:bodyPr wrap="square" lIns="0" tIns="0" rIns="0" bIns="0" rtlCol="0" anchor="t"/>
           <a:lstStyle/>
           <a:p>
-            <a:pPr algn="ctr" indent="0" marL="0">
-              <a:buNone/>
-            </a:pPr>
-            <a:r>
-              <a:rPr lang="en-US" sz="4400" b="1" dirty="0">
-                <a:solidFill>
-                  <a:srgbClr val="2F5BEA"/>
-                </a:solidFill>
-                <a:latin typeface="Cambria" pitchFamily="34" charset="0"/>
-                <a:ea typeface="Cambria" pitchFamily="34" charset="-122"/>
-                <a:cs typeface="Cambria" pitchFamily="34" charset="-120"/>
-              </a:rPr>
-              <a:t>68</a:t>
-            </a:r>
-            <a:endParaRPr lang="en-US" sz="4400" dirty="0"/>
-          </a:p>
-        </p:txBody>
-      </p:sp>
-      <p:sp>
-        <p:nvSpPr>
-          <p:cNvPr id="12" name="Text 10"/>
-          <p:cNvSpPr txBox="1"/>
-          <p:nvPr/>
-        </p:nvSpPr>
-        <p:spPr>
-          <a:xfrm>
-            <a:off x="3566160" y="2423160"/>
-            <a:ext cx="2240280" cy="640080"/>
+            <a:pPr indent="0" marL="0">
+              <a:buNone/>
+            </a:pPr>
+            <a:r>
+              <a:rPr lang="en-US" sz="1700" b="1" dirty="0">
+                <a:solidFill>
+                  <a:srgbClr val="1B2540"/>
+                </a:solidFill>
+                <a:latin typeface="Calibri" pitchFamily="34" charset="0"/>
+                <a:ea typeface="Calibri" pitchFamily="34" charset="-122"/>
+                <a:cs typeface="Calibri" pitchFamily="34" charset="-120"/>
+              </a:rPr>
+              <a:t>Kéo cho dễ</a:t>
+            </a:r>
+            <a:endParaRPr lang="en-US" sz="1700" dirty="0"/>
+          </a:p>
+        </p:txBody>
+      </p:sp>
+      <p:sp>
+        <p:nvSpPr>
+          <p:cNvPr id="16" name="Text 13"/>
+          <p:cNvSpPr txBox="1"/>
+          <p:nvPr/>
+        </p:nvSpPr>
+        <p:spPr>
+          <a:xfrm>
+            <a:off x="5457703" y="2825496"/>
+            <a:ext cx="6246617" cy="566928"/>
           </a:xfrm>
           <a:prstGeom prst="rect">
             <a:avLst/>
@@ -10690,7 +10877,7 @@
           <a:bodyPr wrap="square" lIns="0" tIns="0" rIns="0" bIns="0" rtlCol="0" anchor="t"/>
           <a:lstStyle/>
           <a:p>
-            <a:pPr algn="ctr" indent="0" marL="0">
+            <a:pPr indent="0" marL="0">
               <a:buNone/>
             </a:pPr>
             <a:r>
@@ -10702,7 +10889,7 @@
                 <a:ea typeface="Calibri" pitchFamily="34" charset="-122"/>
                 <a:cs typeface="Calibri" pitchFamily="34" charset="-120"/>
               </a:rPr>
-              <a:t>công thức tính toán</a:t>
+              <a:t>Kéo đỉnh, kéo cả cạnh (giữ song song), kéo cả hình, nhích từng ô bằng phím mũi tên, đường gợi ý song song / góc vuông</a:t>
             </a:r>
             <a:endParaRPr lang="en-US" sz="1350" dirty="0"/>
           </a:p>
@@ -10710,48 +10897,78 @@
       </p:sp>
       <p:sp>
         <p:nvSpPr>
-          <p:cNvPr id="13" name="Shape 11"/>
+          <p:cNvPr id="17" name="Shape 14"/>
           <p:cNvSpPr/>
           <p:nvPr/>
         </p:nvSpPr>
         <p:spPr>
           <a:xfrm>
-            <a:off x="6217920" y="1417320"/>
-            <a:ext cx="2606040" cy="1737360"/>
-          </a:xfrm>
-          <a:prstGeom prst="roundRect">
-            <a:avLst>
-              <a:gd name="adj" fmla="val 6316"/>
-            </a:avLst>
+            <a:off x="4817623" y="3438144"/>
+            <a:ext cx="457200" cy="457200"/>
+          </a:xfrm>
+          <a:prstGeom prst="ellipse">
+            <a:avLst/>
           </a:prstGeom>
           <a:solidFill>
-            <a:srgbClr val="FFFFFF"/>
+            <a:srgbClr val="2F5BEA"/>
           </a:solidFill>
-          <a:ln w="9525">
+          <a:ln w="12700">
             <a:solidFill>
-              <a:srgbClr val="DDE3EE"/>
+              <a:srgbClr val="2F5BEA"/>
             </a:solidFill>
             <a:prstDash val="solid"/>
           </a:ln>
-          <a:effectLst>
-            <a:outerShdw sx="100000" sy="100000" kx="0" ky="0" algn="bl" rotWithShape="0" blurRad="101600" dist="25400" dir="5400000">
-              <a:srgbClr val="1B2540">
-                <a:alpha val="12000"/>
-              </a:srgbClr>
-            </a:outerShdw>
-          </a:effectLst>
-        </p:spPr>
-      </p:sp>
-      <p:sp>
-        <p:nvSpPr>
-          <p:cNvPr id="14" name="Text 12"/>
-          <p:cNvSpPr txBox="1"/>
-          <p:nvPr/>
-        </p:nvSpPr>
-        <p:spPr>
-          <a:xfrm>
-            <a:off x="6217920" y="1554480"/>
-            <a:ext cx="2606040" cy="868680"/>
+        </p:spPr>
+      </p:sp>
+      <p:sp>
+        <p:nvSpPr>
+          <p:cNvPr id="18" name="Text 15"/>
+          <p:cNvSpPr txBox="1"/>
+          <p:nvPr/>
+        </p:nvSpPr>
+        <p:spPr>
+          <a:xfrm>
+            <a:off x="4817623" y="3438144"/>
+            <a:ext cx="457200" cy="457200"/>
+          </a:xfrm>
+          <a:prstGeom prst="rect">
+            <a:avLst/>
+          </a:prstGeom>
+          <a:noFill/>
+          <a:ln/>
+        </p:spPr>
+        <p:txBody>
+          <a:bodyPr wrap="square" lIns="0" tIns="0" rIns="0" bIns="0" rtlCol="0" anchor="ctr"/>
+          <a:lstStyle/>
+          <a:p>
+            <a:pPr algn="ctr" indent="0" marL="0">
+              <a:buNone/>
+            </a:pPr>
+            <a:r>
+              <a:rPr lang="en-US" sz="1600" b="1" dirty="0">
+                <a:solidFill>
+                  <a:srgbClr val="FFFFFF"/>
+                </a:solidFill>
+                <a:latin typeface="Calibri" pitchFamily="34" charset="0"/>
+                <a:ea typeface="Calibri" pitchFamily="34" charset="-122"/>
+                <a:cs typeface="Calibri" pitchFamily="34" charset="-120"/>
+              </a:rPr>
+              <a:t>3</a:t>
+            </a:r>
+            <a:endParaRPr lang="en-US" sz="1600" dirty="0"/>
+          </a:p>
+        </p:txBody>
+      </p:sp>
+      <p:sp>
+        <p:nvSpPr>
+          <p:cNvPr id="19" name="Text 16"/>
+          <p:cNvSpPr txBox="1"/>
+          <p:nvPr/>
+        </p:nvSpPr>
+        <p:spPr>
+          <a:xfrm>
+            <a:off x="5457703" y="3419856"/>
+            <a:ext cx="6246617" cy="347472"/>
           </a:xfrm>
           <a:prstGeom prst="rect">
             <a:avLst/>
@@ -10763,34 +10980,34 @@
           <a:bodyPr wrap="square" lIns="0" tIns="0" rIns="0" bIns="0" rtlCol="0" anchor="t"/>
           <a:lstStyle/>
           <a:p>
-            <a:pPr algn="ctr" indent="0" marL="0">
-              <a:buNone/>
-            </a:pPr>
-            <a:r>
-              <a:rPr lang="en-US" sz="4400" b="1" dirty="0">
-                <a:solidFill>
-                  <a:srgbClr val="0F8A5F"/>
-                </a:solidFill>
-                <a:latin typeface="Cambria" pitchFamily="34" charset="0"/>
-                <a:ea typeface="Cambria" pitchFamily="34" charset="-122"/>
-                <a:cs typeface="Cambria" pitchFamily="34" charset="-120"/>
-              </a:rPr>
-              <a:t>187</a:t>
-            </a:r>
-            <a:endParaRPr lang="en-US" sz="4400" dirty="0"/>
-          </a:p>
-        </p:txBody>
-      </p:sp>
-      <p:sp>
-        <p:nvSpPr>
-          <p:cNvPr id="15" name="Text 13"/>
-          <p:cNvSpPr txBox="1"/>
-          <p:nvPr/>
-        </p:nvSpPr>
-        <p:spPr>
-          <a:xfrm>
-            <a:off x="6400800" y="2423160"/>
-            <a:ext cx="2240280" cy="640080"/>
+            <a:pPr indent="0" marL="0">
+              <a:buNone/>
+            </a:pPr>
+            <a:r>
+              <a:rPr lang="en-US" sz="1700" b="1" dirty="0">
+                <a:solidFill>
+                  <a:srgbClr val="1B2540"/>
+                </a:solidFill>
+                <a:latin typeface="Calibri" pitchFamily="34" charset="0"/>
+                <a:ea typeface="Calibri" pitchFamily="34" charset="-122"/>
+                <a:cs typeface="Calibri" pitchFamily="34" charset="-120"/>
+              </a:rPr>
+              <a:t>Toạ độ → tính chất → Neo4j</a:t>
+            </a:r>
+            <a:endParaRPr lang="en-US" sz="1700" dirty="0"/>
+          </a:p>
+        </p:txBody>
+      </p:sp>
+      <p:sp>
+        <p:nvSpPr>
+          <p:cNvPr id="20" name="Text 17"/>
+          <p:cNvSpPr txBox="1"/>
+          <p:nvPr/>
+        </p:nvSpPr>
+        <p:spPr>
+          <a:xfrm>
+            <a:off x="5457703" y="3803904"/>
+            <a:ext cx="6246617" cy="566928"/>
           </a:xfrm>
           <a:prstGeom prst="rect">
             <a:avLst/>
@@ -10802,7 +11019,7 @@
           <a:bodyPr wrap="square" lIns="0" tIns="0" rIns="0" bIns="0" rtlCol="0" anchor="t"/>
           <a:lstStyle/>
           <a:p>
-            <a:pPr algn="ctr" indent="0" marL="0">
+            <a:pPr indent="0" marL="0">
               <a:buNone/>
             </a:pPr>
             <a:r>
@@ -10814,7 +11031,7 @@
                 <a:ea typeface="Calibri" pitchFamily="34" charset="-122"/>
                 <a:cs typeface="Calibri" pitchFamily="34" charset="-120"/>
               </a:rPr>
-              <a:t>truy vấn khớp kết quả trên Neo4j thật</a:t>
+              <a:t>Song song ⇔ tích có hướng = 0; vuông góc ⇔ tích vô hướng = 0; rồi dùng chung bộ suy luận với trang Nhận dạng</a:t>
             </a:r>
             <a:endParaRPr lang="en-US" sz="1350" dirty="0"/>
           </a:p>
@@ -10822,48 +11039,78 @@
       </p:sp>
       <p:sp>
         <p:nvSpPr>
-          <p:cNvPr id="16" name="Shape 14"/>
+          <p:cNvPr id="21" name="Shape 18"/>
           <p:cNvSpPr/>
           <p:nvPr/>
         </p:nvSpPr>
         <p:spPr>
           <a:xfrm>
-            <a:off x="9052560" y="1417320"/>
-            <a:ext cx="2606040" cy="1737360"/>
-          </a:xfrm>
-          <a:prstGeom prst="roundRect">
-            <a:avLst>
-              <a:gd name="adj" fmla="val 6316"/>
-            </a:avLst>
+            <a:off x="4817623" y="4416552"/>
+            <a:ext cx="457200" cy="457200"/>
+          </a:xfrm>
+          <a:prstGeom prst="ellipse">
+            <a:avLst/>
           </a:prstGeom>
           <a:solidFill>
-            <a:srgbClr val="FFFFFF"/>
+            <a:srgbClr val="2F5BEA"/>
           </a:solidFill>
-          <a:ln w="9525">
+          <a:ln w="12700">
             <a:solidFill>
-              <a:srgbClr val="DDE3EE"/>
+              <a:srgbClr val="2F5BEA"/>
             </a:solidFill>
             <a:prstDash val="solid"/>
           </a:ln>
-          <a:effectLst>
-            <a:outerShdw sx="100000" sy="100000" kx="0" ky="0" algn="bl" rotWithShape="0" blurRad="101600" dist="25400" dir="5400000">
-              <a:srgbClr val="1B2540">
-                <a:alpha val="12000"/>
-              </a:srgbClr>
-            </a:outerShdw>
-          </a:effectLst>
-        </p:spPr>
-      </p:sp>
-      <p:sp>
-        <p:nvSpPr>
-          <p:cNvPr id="17" name="Text 15"/>
-          <p:cNvSpPr txBox="1"/>
-          <p:nvPr/>
-        </p:nvSpPr>
-        <p:spPr>
-          <a:xfrm>
-            <a:off x="9052560" y="1554480"/>
-            <a:ext cx="2606040" cy="868680"/>
+        </p:spPr>
+      </p:sp>
+      <p:sp>
+        <p:nvSpPr>
+          <p:cNvPr id="22" name="Text 19"/>
+          <p:cNvSpPr txBox="1"/>
+          <p:nvPr/>
+        </p:nvSpPr>
+        <p:spPr>
+          <a:xfrm>
+            <a:off x="4817623" y="4416552"/>
+            <a:ext cx="457200" cy="457200"/>
+          </a:xfrm>
+          <a:prstGeom prst="rect">
+            <a:avLst/>
+          </a:prstGeom>
+          <a:noFill/>
+          <a:ln/>
+        </p:spPr>
+        <p:txBody>
+          <a:bodyPr wrap="square" lIns="0" tIns="0" rIns="0" bIns="0" rtlCol="0" anchor="ctr"/>
+          <a:lstStyle/>
+          <a:p>
+            <a:pPr algn="ctr" indent="0" marL="0">
+              <a:buNone/>
+            </a:pPr>
+            <a:r>
+              <a:rPr lang="en-US" sz="1600" b="1" dirty="0">
+                <a:solidFill>
+                  <a:srgbClr val="FFFFFF"/>
+                </a:solidFill>
+                <a:latin typeface="Calibri" pitchFamily="34" charset="0"/>
+                <a:ea typeface="Calibri" pitchFamily="34" charset="-122"/>
+                <a:cs typeface="Calibri" pitchFamily="34" charset="-120"/>
+              </a:rPr>
+              <a:t>4</a:t>
+            </a:r>
+            <a:endParaRPr lang="en-US" sz="1600" dirty="0"/>
+          </a:p>
+        </p:txBody>
+      </p:sp>
+      <p:sp>
+        <p:nvSpPr>
+          <p:cNvPr id="23" name="Text 20"/>
+          <p:cNvSpPr txBox="1"/>
+          <p:nvPr/>
+        </p:nvSpPr>
+        <p:spPr>
+          <a:xfrm>
+            <a:off x="5457703" y="4398264"/>
+            <a:ext cx="6246617" cy="347472"/>
           </a:xfrm>
           <a:prstGeom prst="rect">
             <a:avLst/>
@@ -10875,34 +11122,34 @@
           <a:bodyPr wrap="square" lIns="0" tIns="0" rIns="0" bIns="0" rtlCol="0" anchor="t"/>
           <a:lstStyle/>
           <a:p>
-            <a:pPr algn="ctr" indent="0" marL="0">
-              <a:buNone/>
-            </a:pPr>
-            <a:r>
-              <a:rPr lang="en-US" sz="4400" b="1" dirty="0">
-                <a:solidFill>
-                  <a:srgbClr val="0F8A5F"/>
-                </a:solidFill>
-                <a:latin typeface="Cambria" pitchFamily="34" charset="0"/>
-                <a:ea typeface="Cambria" pitchFamily="34" charset="-122"/>
-                <a:cs typeface="Cambria" pitchFamily="34" charset="-120"/>
-              </a:rPr>
-              <a:t>45/45</a:t>
-            </a:r>
-            <a:endParaRPr lang="en-US" sz="4400" dirty="0"/>
-          </a:p>
-        </p:txBody>
-      </p:sp>
-      <p:sp>
-        <p:nvSpPr>
-          <p:cNvPr id="18" name="Text 16"/>
-          <p:cNvSpPr txBox="1"/>
-          <p:nvPr/>
-        </p:nvSpPr>
-        <p:spPr>
-          <a:xfrm>
-            <a:off x="9235440" y="2423160"/>
-            <a:ext cx="2240280" cy="640080"/>
+            <a:pPr indent="0" marL="0">
+              <a:buNone/>
+            </a:pPr>
+            <a:r>
+              <a:rPr lang="en-US" sz="1700" b="1" dirty="0">
+                <a:solidFill>
+                  <a:srgbClr val="1B2540"/>
+                </a:solidFill>
+                <a:latin typeface="Calibri" pitchFamily="34" charset="0"/>
+                <a:ea typeface="Calibri" pitchFamily="34" charset="-122"/>
+                <a:cs typeface="Calibri" pitchFamily="34" charset="-120"/>
+              </a:rPr>
+              <a:t>Chấm điểm</a:t>
+            </a:r>
+            <a:endParaRPr lang="en-US" sz="1700" dirty="0"/>
+          </a:p>
+        </p:txBody>
+      </p:sp>
+      <p:sp>
+        <p:nvSpPr>
+          <p:cNvPr id="24" name="Text 21"/>
+          <p:cNvSpPr txBox="1"/>
+          <p:nvPr/>
+        </p:nvSpPr>
+        <p:spPr>
+          <a:xfrm>
+            <a:off x="5457703" y="4782312"/>
+            <a:ext cx="6246617" cy="566928"/>
           </a:xfrm>
           <a:prstGeom prst="rect">
             <a:avLst/>
@@ -10914,7 +11161,7 @@
           <a:bodyPr wrap="square" lIns="0" tIns="0" rIns="0" bIns="0" rtlCol="0" anchor="t"/>
           <a:lstStyle/>
           <a:p>
-            <a:pPr algn="ctr" indent="0" marL="0">
+            <a:pPr indent="0" marL="0">
               <a:buNone/>
             </a:pPr>
             <a:r>
@@ -10926,7 +11173,7 @@
                 <a:ea typeface="Calibri" pitchFamily="34" charset="-122"/>
                 <a:cs typeface="Calibri" pitchFamily="34" charset="-120"/>
               </a:rPr>
-              <a:t>ca kiểm thử tự động đạt</a:t>
+              <a:t>Đúng hình ⇒ +100 điểm + tốc độ + chuỗi; trường hợp đặc biệt (LA_MOT) ⇒ “Gần đúng”</a:t>
             </a:r>
             <a:endParaRPr lang="en-US" sz="1350" dirty="0"/>
           </a:p>
@@ -10934,48 +11181,14 @@
       </p:sp>
       <p:sp>
         <p:nvSpPr>
-          <p:cNvPr id="19" name="Shape 17"/>
+          <p:cNvPr id="25" name="Shape 22"/>
           <p:cNvSpPr/>
           <p:nvPr/>
         </p:nvSpPr>
         <p:spPr>
           <a:xfrm>
-            <a:off x="548640" y="3520440"/>
-            <a:ext cx="5440680" cy="1188720"/>
-          </a:xfrm>
-          <a:prstGeom prst="roundRect">
-            <a:avLst>
-              <a:gd name="adj" fmla="val 9231"/>
-            </a:avLst>
-          </a:prstGeom>
-          <a:solidFill>
-            <a:srgbClr val="FFFFFF"/>
-          </a:solidFill>
-          <a:ln w="9525">
-            <a:solidFill>
-              <a:srgbClr val="DDE3EE"/>
-            </a:solidFill>
-            <a:prstDash val="solid"/>
-          </a:ln>
-          <a:effectLst>
-            <a:outerShdw sx="100000" sy="100000" kx="0" ky="0" algn="bl" rotWithShape="0" blurRad="101600" dist="25400" dir="5400000">
-              <a:srgbClr val="1B2540">
-                <a:alpha val="12000"/>
-              </a:srgbClr>
-            </a:outerShdw>
-          </a:effectLst>
-        </p:spPr>
-      </p:sp>
-      <p:sp>
-        <p:nvSpPr>
-          <p:cNvPr id="20" name="Shape 18"/>
-          <p:cNvSpPr/>
-          <p:nvPr/>
-        </p:nvSpPr>
-        <p:spPr>
-          <a:xfrm>
-            <a:off x="777240" y="3867912"/>
-            <a:ext cx="502920" cy="502920"/>
+            <a:off x="4817623" y="5394960"/>
+            <a:ext cx="457200" cy="457200"/>
           </a:xfrm>
           <a:prstGeom prst="ellipse">
             <a:avLst/>
@@ -10993,14 +11206,14 @@
       </p:sp>
       <p:sp>
         <p:nvSpPr>
-          <p:cNvPr id="21" name="Text 19"/>
-          <p:cNvSpPr txBox="1"/>
-          <p:nvPr/>
-        </p:nvSpPr>
-        <p:spPr>
-          <a:xfrm>
-            <a:off x="777240" y="3867912"/>
-            <a:ext cx="502920" cy="502920"/>
+          <p:cNvPr id="26" name="Text 23"/>
+          <p:cNvSpPr txBox="1"/>
+          <p:nvPr/>
+        </p:nvSpPr>
+        <p:spPr>
+          <a:xfrm>
+            <a:off x="4817623" y="5394960"/>
+            <a:ext cx="457200" cy="457200"/>
           </a:xfrm>
           <a:prstGeom prst="rect">
             <a:avLst/>
@@ -11024,7 +11237,7 @@
                 <a:ea typeface="Calibri" pitchFamily="34" charset="-122"/>
                 <a:cs typeface="Calibri" pitchFamily="34" charset="-120"/>
               </a:rPr>
-              <a:t>✓</a:t>
+              <a:t>5</a:t>
             </a:r>
             <a:endParaRPr lang="en-US" sz="1600" dirty="0"/>
           </a:p>
@@ -11032,14 +11245,14 @@
       </p:sp>
       <p:sp>
         <p:nvSpPr>
-          <p:cNvPr id="22" name="Text 20"/>
-          <p:cNvSpPr txBox="1"/>
-          <p:nvPr/>
-        </p:nvSpPr>
-        <p:spPr>
-          <a:xfrm>
-            <a:off x="1463040" y="3703320"/>
-            <a:ext cx="4389120" cy="411480"/>
+          <p:cNvPr id="27" name="Text 24"/>
+          <p:cNvSpPr txBox="1"/>
+          <p:nvPr/>
+        </p:nvSpPr>
+        <p:spPr>
+          <a:xfrm>
+            <a:off x="5457703" y="5376672"/>
+            <a:ext cx="6246617" cy="347472"/>
           </a:xfrm>
           <a:prstGeom prst="rect">
             <a:avLst/>
@@ -11063,7 +11276,7 @@
                 <a:ea typeface="Calibri" pitchFamily="34" charset="-122"/>
                 <a:cs typeface="Calibri" pitchFamily="34" charset="-120"/>
               </a:rPr>
-              <a:t>Nhận dạng tứ giác</a:t>
+              <a:t>Bảng xếp hạng</a:t>
             </a:r>
             <a:endParaRPr lang="en-US" sz="1700" dirty="0"/>
           </a:p>
@@ -11071,14 +11284,14 @@
       </p:sp>
       <p:sp>
         <p:nvSpPr>
-          <p:cNvPr id="23" name="Text 21"/>
-          <p:cNvSpPr txBox="1"/>
-          <p:nvPr/>
-        </p:nvSpPr>
-        <p:spPr>
-          <a:xfrm>
-            <a:off x="1463040" y="4114800"/>
-            <a:ext cx="4389120" cy="502920"/>
+          <p:cNvPr id="28" name="Text 25"/>
+          <p:cNvSpPr txBox="1"/>
+          <p:nvPr/>
+        </p:nvSpPr>
+        <p:spPr>
+          <a:xfrm>
+            <a:off x="5457703" y="5760720"/>
+            <a:ext cx="6246617" cy="566928"/>
           </a:xfrm>
           <a:prstGeom prst="rect">
             <a:avLst/>
@@ -11102,535 +11315,7 @@
                 <a:ea typeface="Calibri" pitchFamily="34" charset="-122"/>
                 <a:cs typeface="Calibri" pitchFamily="34" charset="-120"/>
               </a:rPr>
-              <a:t>Lời giải từng bước, phát hiện thiếu dữ kiện và mâu thuẫn</a:t>
-            </a:r>
-            <a:endParaRPr lang="en-US" sz="1350" dirty="0"/>
-          </a:p>
-        </p:txBody>
-      </p:sp>
-      <p:sp>
-        <p:nvSpPr>
-          <p:cNvPr id="24" name="Shape 22"/>
-          <p:cNvSpPr/>
-          <p:nvPr/>
-        </p:nvSpPr>
-        <p:spPr>
-          <a:xfrm>
-            <a:off x="6172200" y="3520440"/>
-            <a:ext cx="5440680" cy="1188720"/>
-          </a:xfrm>
-          <a:prstGeom prst="roundRect">
-            <a:avLst>
-              <a:gd name="adj" fmla="val 9231"/>
-            </a:avLst>
-          </a:prstGeom>
-          <a:solidFill>
-            <a:srgbClr val="FFFFFF"/>
-          </a:solidFill>
-          <a:ln w="9525">
-            <a:solidFill>
-              <a:srgbClr val="DDE3EE"/>
-            </a:solidFill>
-            <a:prstDash val="solid"/>
-          </a:ln>
-          <a:effectLst>
-            <a:outerShdw sx="100000" sy="100000" kx="0" ky="0" algn="bl" rotWithShape="0" blurRad="101600" dist="25400" dir="5400000">
-              <a:srgbClr val="1B2540">
-                <a:alpha val="12000"/>
-              </a:srgbClr>
-            </a:outerShdw>
-          </a:effectLst>
-        </p:spPr>
-      </p:sp>
-      <p:sp>
-        <p:nvSpPr>
-          <p:cNvPr id="25" name="Shape 23"/>
-          <p:cNvSpPr/>
-          <p:nvPr/>
-        </p:nvSpPr>
-        <p:spPr>
-          <a:xfrm>
-            <a:off x="6400800" y="3867912"/>
-            <a:ext cx="502920" cy="502920"/>
-          </a:xfrm>
-          <a:prstGeom prst="ellipse">
-            <a:avLst/>
-          </a:prstGeom>
-          <a:solidFill>
-            <a:srgbClr val="0F8A5F"/>
-          </a:solidFill>
-          <a:ln w="12700">
-            <a:solidFill>
-              <a:srgbClr val="0F8A5F"/>
-            </a:solidFill>
-            <a:prstDash val="solid"/>
-          </a:ln>
-        </p:spPr>
-      </p:sp>
-      <p:sp>
-        <p:nvSpPr>
-          <p:cNvPr id="26" name="Text 24"/>
-          <p:cNvSpPr txBox="1"/>
-          <p:nvPr/>
-        </p:nvSpPr>
-        <p:spPr>
-          <a:xfrm>
-            <a:off x="6400800" y="3867912"/>
-            <a:ext cx="502920" cy="502920"/>
-          </a:xfrm>
-          <a:prstGeom prst="rect">
-            <a:avLst/>
-          </a:prstGeom>
-          <a:noFill/>
-          <a:ln/>
-        </p:spPr>
-        <p:txBody>
-          <a:bodyPr wrap="square" lIns="0" tIns="0" rIns="0" bIns="0" rtlCol="0" anchor="ctr"/>
-          <a:lstStyle/>
-          <a:p>
-            <a:pPr algn="ctr" indent="0" marL="0">
-              <a:buNone/>
-            </a:pPr>
-            <a:r>
-              <a:rPr lang="en-US" sz="1600" b="1" dirty="0">
-                <a:solidFill>
-                  <a:srgbClr val="FFFFFF"/>
-                </a:solidFill>
-                <a:latin typeface="Calibri" pitchFamily="34" charset="0"/>
-                <a:ea typeface="Calibri" pitchFamily="34" charset="-122"/>
-                <a:cs typeface="Calibri" pitchFamily="34" charset="-120"/>
-              </a:rPr>
-              <a:t>✓</a:t>
-            </a:r>
-            <a:endParaRPr lang="en-US" sz="1600" dirty="0"/>
-          </a:p>
-        </p:txBody>
-      </p:sp>
-      <p:sp>
-        <p:nvSpPr>
-          <p:cNvPr id="27" name="Text 25"/>
-          <p:cNvSpPr txBox="1"/>
-          <p:nvPr/>
-        </p:nvSpPr>
-        <p:spPr>
-          <a:xfrm>
-            <a:off x="7086600" y="3703320"/>
-            <a:ext cx="4389120" cy="411480"/>
-          </a:xfrm>
-          <a:prstGeom prst="rect">
-            <a:avLst/>
-          </a:prstGeom>
-          <a:noFill/>
-          <a:ln/>
-        </p:spPr>
-        <p:txBody>
-          <a:bodyPr wrap="square" lIns="0" tIns="0" rIns="0" bIns="0" rtlCol="0" anchor="t"/>
-          <a:lstStyle/>
-          <a:p>
-            <a:pPr indent="0" marL="0">
-              <a:buNone/>
-            </a:pPr>
-            <a:r>
-              <a:rPr lang="en-US" sz="1700" b="1" dirty="0">
-                <a:solidFill>
-                  <a:srgbClr val="1B2540"/>
-                </a:solidFill>
-                <a:latin typeface="Calibri" pitchFamily="34" charset="0"/>
-                <a:ea typeface="Calibri" pitchFamily="34" charset="-122"/>
-                <a:cs typeface="Calibri" pitchFamily="34" charset="-120"/>
-              </a:rPr>
-              <a:t>Tính diện tích, chu vi</a:t>
-            </a:r>
-            <a:endParaRPr lang="en-US" sz="1700" dirty="0"/>
-          </a:p>
-        </p:txBody>
-      </p:sp>
-      <p:sp>
-        <p:nvSpPr>
-          <p:cNvPr id="28" name="Text 26"/>
-          <p:cNvSpPr txBox="1"/>
-          <p:nvPr/>
-        </p:nvSpPr>
-        <p:spPr>
-          <a:xfrm>
-            <a:off x="7086600" y="4114800"/>
-            <a:ext cx="4389120" cy="502920"/>
-          </a:xfrm>
-          <a:prstGeom prst="rect">
-            <a:avLst/>
-          </a:prstGeom>
-          <a:noFill/>
-          <a:ln/>
-        </p:spPr>
-        <p:txBody>
-          <a:bodyPr wrap="square" lIns="0" tIns="0" rIns="0" bIns="0" rtlCol="0" anchor="t"/>
-          <a:lstStyle/>
-          <a:p>
-            <a:pPr indent="0" marL="0">
-              <a:buNone/>
-            </a:pPr>
-            <a:r>
-              <a:rPr lang="en-US" sz="1350" dirty="0">
-                <a:solidFill>
-                  <a:srgbClr val="5B6478"/>
-                </a:solidFill>
-                <a:latin typeface="Calibri" pitchFamily="34" charset="0"/>
-                <a:ea typeface="Calibri" pitchFamily="34" charset="-122"/>
-                <a:cs typeface="Calibri" pitchFamily="34" charset="-120"/>
-              </a:rPr>
-              <a:t>Nhập số liệu bất kỳ, tính mọi đại lượng liên quan</a:t>
-            </a:r>
-            <a:endParaRPr lang="en-US" sz="1350" dirty="0"/>
-          </a:p>
-        </p:txBody>
-      </p:sp>
-      <p:sp>
-        <p:nvSpPr>
-          <p:cNvPr id="29" name="Shape 27"/>
-          <p:cNvSpPr/>
-          <p:nvPr/>
-        </p:nvSpPr>
-        <p:spPr>
-          <a:xfrm>
-            <a:off x="548640" y="4892040"/>
-            <a:ext cx="5440680" cy="1188720"/>
-          </a:xfrm>
-          <a:prstGeom prst="roundRect">
-            <a:avLst>
-              <a:gd name="adj" fmla="val 9231"/>
-            </a:avLst>
-          </a:prstGeom>
-          <a:solidFill>
-            <a:srgbClr val="FFFFFF"/>
-          </a:solidFill>
-          <a:ln w="9525">
-            <a:solidFill>
-              <a:srgbClr val="DDE3EE"/>
-            </a:solidFill>
-            <a:prstDash val="solid"/>
-          </a:ln>
-          <a:effectLst>
-            <a:outerShdw sx="100000" sy="100000" kx="0" ky="0" algn="bl" rotWithShape="0" blurRad="101600" dist="25400" dir="5400000">
-              <a:srgbClr val="1B2540">
-                <a:alpha val="12000"/>
-              </a:srgbClr>
-            </a:outerShdw>
-          </a:effectLst>
-        </p:spPr>
-      </p:sp>
-      <p:sp>
-        <p:nvSpPr>
-          <p:cNvPr id="30" name="Shape 28"/>
-          <p:cNvSpPr/>
-          <p:nvPr/>
-        </p:nvSpPr>
-        <p:spPr>
-          <a:xfrm>
-            <a:off x="777240" y="5239512"/>
-            <a:ext cx="502920" cy="502920"/>
-          </a:xfrm>
-          <a:prstGeom prst="ellipse">
-            <a:avLst/>
-          </a:prstGeom>
-          <a:solidFill>
-            <a:srgbClr val="0F8A5F"/>
-          </a:solidFill>
-          <a:ln w="12700">
-            <a:solidFill>
-              <a:srgbClr val="0F8A5F"/>
-            </a:solidFill>
-            <a:prstDash val="solid"/>
-          </a:ln>
-        </p:spPr>
-      </p:sp>
-      <p:sp>
-        <p:nvSpPr>
-          <p:cNvPr id="31" name="Text 29"/>
-          <p:cNvSpPr txBox="1"/>
-          <p:nvPr/>
-        </p:nvSpPr>
-        <p:spPr>
-          <a:xfrm>
-            <a:off x="777240" y="5239512"/>
-            <a:ext cx="502920" cy="502920"/>
-          </a:xfrm>
-          <a:prstGeom prst="rect">
-            <a:avLst/>
-          </a:prstGeom>
-          <a:noFill/>
-          <a:ln/>
-        </p:spPr>
-        <p:txBody>
-          <a:bodyPr wrap="square" lIns="0" tIns="0" rIns="0" bIns="0" rtlCol="0" anchor="ctr"/>
-          <a:lstStyle/>
-          <a:p>
-            <a:pPr algn="ctr" indent="0" marL="0">
-              <a:buNone/>
-            </a:pPr>
-            <a:r>
-              <a:rPr lang="en-US" sz="1600" b="1" dirty="0">
-                <a:solidFill>
-                  <a:srgbClr val="FFFFFF"/>
-                </a:solidFill>
-                <a:latin typeface="Calibri" pitchFamily="34" charset="0"/>
-                <a:ea typeface="Calibri" pitchFamily="34" charset="-122"/>
-                <a:cs typeface="Calibri" pitchFamily="34" charset="-120"/>
-              </a:rPr>
-              <a:t>✓</a:t>
-            </a:r>
-            <a:endParaRPr lang="en-US" sz="1600" dirty="0"/>
-          </a:p>
-        </p:txBody>
-      </p:sp>
-      <p:sp>
-        <p:nvSpPr>
-          <p:cNvPr id="32" name="Text 30"/>
-          <p:cNvSpPr txBox="1"/>
-          <p:nvPr/>
-        </p:nvSpPr>
-        <p:spPr>
-          <a:xfrm>
-            <a:off x="1463040" y="5074920"/>
-            <a:ext cx="4389120" cy="411480"/>
-          </a:xfrm>
-          <a:prstGeom prst="rect">
-            <a:avLst/>
-          </a:prstGeom>
-          <a:noFill/>
-          <a:ln/>
-        </p:spPr>
-        <p:txBody>
-          <a:bodyPr wrap="square" lIns="0" tIns="0" rIns="0" bIns="0" rtlCol="0" anchor="t"/>
-          <a:lstStyle/>
-          <a:p>
-            <a:pPr indent="0" marL="0">
-              <a:buNone/>
-            </a:pPr>
-            <a:r>
-              <a:rPr lang="en-US" sz="1700" b="1" dirty="0">
-                <a:solidFill>
-                  <a:srgbClr val="1B2540"/>
-                </a:solidFill>
-                <a:latin typeface="Calibri" pitchFamily="34" charset="0"/>
-                <a:ea typeface="Calibri" pitchFamily="34" charset="-122"/>
-                <a:cs typeface="Calibri" pitchFamily="34" charset="-120"/>
-              </a:rPr>
-              <a:t>Trò chơi Thử thách</a:t>
-            </a:r>
-            <a:endParaRPr lang="en-US" sz="1700" dirty="0"/>
-          </a:p>
-        </p:txBody>
-      </p:sp>
-      <p:sp>
-        <p:nvSpPr>
-          <p:cNvPr id="33" name="Text 31"/>
-          <p:cNvSpPr txBox="1"/>
-          <p:nvPr/>
-        </p:nvSpPr>
-        <p:spPr>
-          <a:xfrm>
-            <a:off x="1463040" y="5486400"/>
-            <a:ext cx="4389120" cy="502920"/>
-          </a:xfrm>
-          <a:prstGeom prst="rect">
-            <a:avLst/>
-          </a:prstGeom>
-          <a:noFill/>
-          <a:ln/>
-        </p:spPr>
-        <p:txBody>
-          <a:bodyPr wrap="square" lIns="0" tIns="0" rIns="0" bIns="0" rtlCol="0" anchor="t"/>
-          <a:lstStyle/>
-          <a:p>
-            <a:pPr indent="0" marL="0">
-              <a:buNone/>
-            </a:pPr>
-            <a:r>
-              <a:rPr lang="en-US" sz="1350" dirty="0">
-                <a:solidFill>
-                  <a:srgbClr val="5B6478"/>
-                </a:solidFill>
-                <a:latin typeface="Calibri" pitchFamily="34" charset="0"/>
-                <a:ea typeface="Calibri" pitchFamily="34" charset="-122"/>
-                <a:cs typeface="Calibri" pitchFamily="34" charset="-120"/>
-              </a:rPr>
-              <a:t>Kéo thả 4 đỉnh, Neo4j chấm điểm, bảng xếp hạng lưu trong Neo4j</a:t>
-            </a:r>
-            <a:endParaRPr lang="en-US" sz="1350" dirty="0"/>
-          </a:p>
-        </p:txBody>
-      </p:sp>
-      <p:sp>
-        <p:nvSpPr>
-          <p:cNvPr id="34" name="Shape 32"/>
-          <p:cNvSpPr/>
-          <p:nvPr/>
-        </p:nvSpPr>
-        <p:spPr>
-          <a:xfrm>
-            <a:off x="6172200" y="4892040"/>
-            <a:ext cx="5440680" cy="1188720"/>
-          </a:xfrm>
-          <a:prstGeom prst="roundRect">
-            <a:avLst>
-              <a:gd name="adj" fmla="val 9231"/>
-            </a:avLst>
-          </a:prstGeom>
-          <a:solidFill>
-            <a:srgbClr val="FFFFFF"/>
-          </a:solidFill>
-          <a:ln w="9525">
-            <a:solidFill>
-              <a:srgbClr val="DDE3EE"/>
-            </a:solidFill>
-            <a:prstDash val="solid"/>
-          </a:ln>
-          <a:effectLst>
-            <a:outerShdw sx="100000" sy="100000" kx="0" ky="0" algn="bl" rotWithShape="0" blurRad="101600" dist="25400" dir="5400000">
-              <a:srgbClr val="1B2540">
-                <a:alpha val="12000"/>
-              </a:srgbClr>
-            </a:outerShdw>
-          </a:effectLst>
-        </p:spPr>
-      </p:sp>
-      <p:sp>
-        <p:nvSpPr>
-          <p:cNvPr id="35" name="Shape 33"/>
-          <p:cNvSpPr/>
-          <p:nvPr/>
-        </p:nvSpPr>
-        <p:spPr>
-          <a:xfrm>
-            <a:off x="6400800" y="5239512"/>
-            <a:ext cx="502920" cy="502920"/>
-          </a:xfrm>
-          <a:prstGeom prst="ellipse">
-            <a:avLst/>
-          </a:prstGeom>
-          <a:solidFill>
-            <a:srgbClr val="0F8A5F"/>
-          </a:solidFill>
-          <a:ln w="12700">
-            <a:solidFill>
-              <a:srgbClr val="0F8A5F"/>
-            </a:solidFill>
-            <a:prstDash val="solid"/>
-          </a:ln>
-        </p:spPr>
-      </p:sp>
-      <p:sp>
-        <p:nvSpPr>
-          <p:cNvPr id="36" name="Text 34"/>
-          <p:cNvSpPr txBox="1"/>
-          <p:nvPr/>
-        </p:nvSpPr>
-        <p:spPr>
-          <a:xfrm>
-            <a:off x="6400800" y="5239512"/>
-            <a:ext cx="502920" cy="502920"/>
-          </a:xfrm>
-          <a:prstGeom prst="rect">
-            <a:avLst/>
-          </a:prstGeom>
-          <a:noFill/>
-          <a:ln/>
-        </p:spPr>
-        <p:txBody>
-          <a:bodyPr wrap="square" lIns="0" tIns="0" rIns="0" bIns="0" rtlCol="0" anchor="ctr"/>
-          <a:lstStyle/>
-          <a:p>
-            <a:pPr algn="ctr" indent="0" marL="0">
-              <a:buNone/>
-            </a:pPr>
-            <a:r>
-              <a:rPr lang="en-US" sz="1600" b="1" dirty="0">
-                <a:solidFill>
-                  <a:srgbClr val="FFFFFF"/>
-                </a:solidFill>
-                <a:latin typeface="Calibri" pitchFamily="34" charset="0"/>
-                <a:ea typeface="Calibri" pitchFamily="34" charset="-122"/>
-                <a:cs typeface="Calibri" pitchFamily="34" charset="-120"/>
-              </a:rPr>
-              <a:t>✓</a:t>
-            </a:r>
-            <a:endParaRPr lang="en-US" sz="1600" dirty="0"/>
-          </a:p>
-        </p:txBody>
-      </p:sp>
-      <p:sp>
-        <p:nvSpPr>
-          <p:cNvPr id="37" name="Text 35"/>
-          <p:cNvSpPr txBox="1"/>
-          <p:nvPr/>
-        </p:nvSpPr>
-        <p:spPr>
-          <a:xfrm>
-            <a:off x="7086600" y="5074920"/>
-            <a:ext cx="4389120" cy="411480"/>
-          </a:xfrm>
-          <a:prstGeom prst="rect">
-            <a:avLst/>
-          </a:prstGeom>
-          <a:noFill/>
-          <a:ln/>
-        </p:spPr>
-        <p:txBody>
-          <a:bodyPr wrap="square" lIns="0" tIns="0" rIns="0" bIns="0" rtlCol="0" anchor="t"/>
-          <a:lstStyle/>
-          <a:p>
-            <a:pPr indent="0" marL="0">
-              <a:buNone/>
-            </a:pPr>
-            <a:r>
-              <a:rPr lang="en-US" sz="1700" b="1" dirty="0">
-                <a:solidFill>
-                  <a:srgbClr val="1B2540"/>
-                </a:solidFill>
-                <a:latin typeface="Calibri" pitchFamily="34" charset="0"/>
-                <a:ea typeface="Calibri" pitchFamily="34" charset="-122"/>
-                <a:cs typeface="Calibri" pitchFamily="34" charset="-120"/>
-              </a:rPr>
-              <a:t>Tra cứu, tài liệu &amp; mã nguồn</a:t>
-            </a:r>
-            <a:endParaRPr lang="en-US" sz="1700" dirty="0"/>
-          </a:p>
-        </p:txBody>
-      </p:sp>
-      <p:sp>
-        <p:nvSpPr>
-          <p:cNvPr id="38" name="Text 36"/>
-          <p:cNvSpPr txBox="1"/>
-          <p:nvPr/>
-        </p:nvSpPr>
-        <p:spPr>
-          <a:xfrm>
-            <a:off x="7086600" y="5486400"/>
-            <a:ext cx="4389120" cy="502920"/>
-          </a:xfrm>
-          <a:prstGeom prst="rect">
-            <a:avLst/>
-          </a:prstGeom>
-          <a:noFill/>
-          <a:ln/>
-        </p:spPr>
-        <p:txBody>
-          <a:bodyPr wrap="square" lIns="0" tIns="0" rIns="0" bIns="0" rtlCol="0" anchor="t"/>
-          <a:lstStyle/>
-          <a:p>
-            <a:pPr indent="0" marL="0">
-              <a:buNone/>
-            </a:pPr>
-            <a:r>
-              <a:rPr lang="en-US" sz="1350" dirty="0">
-                <a:solidFill>
-                  <a:srgbClr val="5B6478"/>
-                </a:solidFill>
-                <a:latin typeface="Calibri" pitchFamily="34" charset="0"/>
-                <a:ea typeface="Calibri" pitchFamily="34" charset="-122"/>
-                <a:cs typeface="Calibri" pitchFamily="34" charset="-120"/>
-              </a:rPr>
-              <a:t>Đồ thị tri thức, báo cáo, hướng dẫn sử dụng, GitHub, API JSON</a:t>
+              <a:t>(:LuotChoi)-[:HOAN_THANH]-&gt;(:Hinh) lưu trong Neo4j</a:t>
             </a:r>
             <a:endParaRPr lang="en-US" sz="1350" dirty="0"/>
           </a:p>
@@ -11767,7 +11452,7 @@
                 <a:ea typeface="Cambria" pitchFamily="34" charset="-122"/>
                 <a:cs typeface="Cambria" pitchFamily="34" charset="-120"/>
               </a:rPr>
-              <a:t>Hạn chế &amp; hướng phát triển</a:t>
+              <a:t>Kết quả đạt được</a:t>
             </a:r>
             <a:endParaRPr lang="en-US" sz="3200" dirty="0"/>
           </a:p>
@@ -11860,22 +11545,29 @@
         <p:spPr>
           <a:xfrm>
             <a:off x="548640" y="1417320"/>
-            <a:ext cx="5440680" cy="4846320"/>
+            <a:ext cx="2606040" cy="1737360"/>
           </a:xfrm>
           <a:prstGeom prst="roundRect">
             <a:avLst>
-              <a:gd name="adj" fmla="val 2264"/>
+              <a:gd name="adj" fmla="val 6316"/>
             </a:avLst>
           </a:prstGeom>
           <a:solidFill>
-            <a:srgbClr val="F1F3F7"/>
+            <a:srgbClr val="FFFFFF"/>
           </a:solidFill>
           <a:ln w="9525">
             <a:solidFill>
-              <a:srgbClr val="F1F3F7"/>
+              <a:srgbClr val="DDE3EE"/>
             </a:solidFill>
             <a:prstDash val="solid"/>
           </a:ln>
+          <a:effectLst>
+            <a:outerShdw sx="100000" sy="100000" kx="0" ky="0" algn="bl" rotWithShape="0" blurRad="101600" dist="25400" dir="5400000">
+              <a:srgbClr val="1B2540">
+                <a:alpha val="12000"/>
+              </a:srgbClr>
+            </a:outerShdw>
+          </a:effectLst>
         </p:spPr>
       </p:sp>
       <p:sp>
@@ -11886,8 +11578,8 @@
         </p:nvSpPr>
         <p:spPr>
           <a:xfrm>
-            <a:off x="822960" y="1645920"/>
-            <a:ext cx="4846320" cy="457200"/>
+            <a:off x="548640" y="1554480"/>
+            <a:ext cx="2606040" cy="868680"/>
           </a:xfrm>
           <a:prstGeom prst="rect">
             <a:avLst/>
@@ -11899,21 +11591,21 @@
           <a:bodyPr wrap="square" lIns="0" tIns="0" rIns="0" bIns="0" rtlCol="0" anchor="t"/>
           <a:lstStyle/>
           <a:p>
-            <a:pPr indent="0" marL="0">
-              <a:buNone/>
-            </a:pPr>
-            <a:r>
-              <a:rPr lang="en-US" sz="2200" b="1" dirty="0">
-                <a:solidFill>
-                  <a:srgbClr val="5B6478"/>
+            <a:pPr algn="ctr" indent="0" marL="0">
+              <a:buNone/>
+            </a:pPr>
+            <a:r>
+              <a:rPr lang="en-US" sz="4400" b="1" dirty="0">
+                <a:solidFill>
+                  <a:srgbClr val="2F5BEA"/>
                 </a:solidFill>
                 <a:latin typeface="Cambria" pitchFamily="34" charset="0"/>
                 <a:ea typeface="Cambria" pitchFamily="34" charset="-122"/>
                 <a:cs typeface="Cambria" pitchFamily="34" charset="-120"/>
               </a:rPr>
-              <a:t>Hạn chế</a:t>
-            </a:r>
-            <a:endParaRPr lang="en-US" sz="2200" dirty="0"/>
+              <a:t>26</a:t>
+            </a:r>
+            <a:endParaRPr lang="en-US" sz="4400" dirty="0"/>
           </a:p>
         </p:txBody>
       </p:sp>
@@ -11925,8 +11617,8 @@
         </p:nvSpPr>
         <p:spPr>
           <a:xfrm>
-            <a:off x="822960" y="2240280"/>
-            <a:ext cx="4937760" cy="3840480"/>
+            <a:off x="731520" y="2423160"/>
+            <a:ext cx="2240280" cy="640080"/>
           </a:xfrm>
           <a:prstGeom prst="rect">
             <a:avLst/>
@@ -11938,67 +11630,21 @@
           <a:bodyPr wrap="square" lIns="0" tIns="0" rIns="0" bIns="0" rtlCol="0" anchor="t"/>
           <a:lstStyle/>
           <a:p>
-            <a:pPr marL="342900" indent="-342900">
-              <a:spcAft>
-                <a:spcPts val="1000"/>
-              </a:spcAft>
-              <a:buSzPct val="100000"/>
-              <a:buChar char="•"/>
-            </a:pPr>
-            <a:r>
-              <a:rPr lang="en-US" sz="1600" dirty="0">
-                <a:solidFill>
-                  <a:srgbClr val="1D2433"/>
-                </a:solidFill>
-                <a:latin typeface="Calibri" pitchFamily="34" charset="0"/>
-                <a:ea typeface="Calibri" pitchFamily="34" charset="-122"/>
-                <a:cs typeface="Calibri" pitchFamily="34" charset="-120"/>
-              </a:rPr>
-              <a:t>Nhận dạng từ toạ độ mới có ở trò chơi Thử thách và chỉ với toạ độ nguyên trên lưới.</a:t>
-            </a:r>
-            <a:endParaRPr lang="en-US" sz="1600" dirty="0"/>
-          </a:p>
-          <a:p>
-            <a:pPr marL="342900" indent="-342900">
-              <a:spcAft>
-                <a:spcPts val="1000"/>
-              </a:spcAft>
-              <a:buSzPct val="100000"/>
-              <a:buChar char="•"/>
-            </a:pPr>
-            <a:r>
-              <a:rPr lang="en-US" sz="1600" dirty="0">
-                <a:solidFill>
-                  <a:srgbClr val="1D2433"/>
-                </a:solidFill>
-                <a:latin typeface="Calibri" pitchFamily="34" charset="0"/>
-                <a:ea typeface="Calibri" pitchFamily="34" charset="-122"/>
-                <a:cs typeface="Calibri" pitchFamily="34" charset="-120"/>
-              </a:rPr>
-              <a:t>Chưa phân biệt từng cạnh cụ thể (AB, CD…) trong lời giải.</a:t>
-            </a:r>
-            <a:endParaRPr lang="en-US" sz="1600" dirty="0"/>
-          </a:p>
-          <a:p>
-            <a:pPr marL="342900" indent="-342900">
-              <a:spcAft>
-                <a:spcPts val="1000"/>
-              </a:spcAft>
-              <a:buSzPct val="100000"/>
-              <a:buChar char="•"/>
-            </a:pPr>
-            <a:r>
-              <a:rPr lang="en-US" sz="1600" dirty="0">
-                <a:solidFill>
-                  <a:srgbClr val="1D2433"/>
-                </a:solidFill>
-                <a:latin typeface="Calibri" pitchFamily="34" charset="0"/>
-                <a:ea typeface="Calibri" pitchFamily="34" charset="-122"/>
-                <a:cs typeface="Calibri" pitchFamily="34" charset="-120"/>
-              </a:rPr>
-              <a:t>Chỉ xét tứ giác lồi.</a:t>
-            </a:r>
-            <a:endParaRPr lang="en-US" sz="1600" dirty="0"/>
+            <a:pPr algn="ctr" indent="0" marL="0">
+              <a:buNone/>
+            </a:pPr>
+            <a:r>
+              <a:rPr lang="en-US" sz="1350" dirty="0">
+                <a:solidFill>
+                  <a:srgbClr val="5B6478"/>
+                </a:solidFill>
+                <a:latin typeface="Calibri" pitchFamily="34" charset="0"/>
+                <a:ea typeface="Calibri" pitchFamily="34" charset="-122"/>
+                <a:cs typeface="Calibri" pitchFamily="34" charset="-120"/>
+              </a:rPr>
+              <a:t>dấu hiệu nhận biết</a:t>
+            </a:r>
+            <a:endParaRPr lang="en-US" sz="1350" dirty="0"/>
           </a:p>
         </p:txBody>
       </p:sp>
@@ -12010,23 +11656,30 @@
         </p:nvSpPr>
         <p:spPr>
           <a:xfrm>
-            <a:off x="6217920" y="1417320"/>
-            <a:ext cx="5440680" cy="4846320"/>
+            <a:off x="3383280" y="1417320"/>
+            <a:ext cx="2606040" cy="1737360"/>
           </a:xfrm>
           <a:prstGeom prst="roundRect">
             <a:avLst>
-              <a:gd name="adj" fmla="val 2264"/>
+              <a:gd name="adj" fmla="val 6316"/>
             </a:avLst>
           </a:prstGeom>
           <a:solidFill>
-            <a:srgbClr val="E8EEFF"/>
+            <a:srgbClr val="FFFFFF"/>
           </a:solidFill>
           <a:ln w="9525">
             <a:solidFill>
-              <a:srgbClr val="E8EEFF"/>
+              <a:srgbClr val="DDE3EE"/>
             </a:solidFill>
             <a:prstDash val="solid"/>
           </a:ln>
+          <a:effectLst>
+            <a:outerShdw sx="100000" sy="100000" kx="0" ky="0" algn="bl" rotWithShape="0" blurRad="101600" dist="25400" dir="5400000">
+              <a:srgbClr val="1B2540">
+                <a:alpha val="12000"/>
+              </a:srgbClr>
+            </a:outerShdw>
+          </a:effectLst>
         </p:spPr>
       </p:sp>
       <p:sp>
@@ -12037,8 +11690,8 @@
         </p:nvSpPr>
         <p:spPr>
           <a:xfrm>
-            <a:off x="6492240" y="1645920"/>
-            <a:ext cx="4846320" cy="457200"/>
+            <a:off x="3383280" y="1554480"/>
+            <a:ext cx="2606040" cy="868680"/>
           </a:xfrm>
           <a:prstGeom prst="rect">
             <a:avLst/>
@@ -12050,11 +11703,11 @@
           <a:bodyPr wrap="square" lIns="0" tIns="0" rIns="0" bIns="0" rtlCol="0" anchor="t"/>
           <a:lstStyle/>
           <a:p>
-            <a:pPr indent="0" marL="0">
-              <a:buNone/>
-            </a:pPr>
-            <a:r>
-              <a:rPr lang="en-US" sz="2200" b="1" dirty="0">
+            <a:pPr algn="ctr" indent="0" marL="0">
+              <a:buNone/>
+            </a:pPr>
+            <a:r>
+              <a:rPr lang="en-US" sz="4400" b="1" dirty="0">
                 <a:solidFill>
                   <a:srgbClr val="2F5BEA"/>
                 </a:solidFill>
@@ -12062,9 +11715,9 @@
                 <a:ea typeface="Cambria" pitchFamily="34" charset="-122"/>
                 <a:cs typeface="Cambria" pitchFamily="34" charset="-120"/>
               </a:rPr>
-              <a:t>Hướng phát triển</a:t>
-            </a:r>
-            <a:endParaRPr lang="en-US" sz="2200" dirty="0"/>
+              <a:t>68</a:t>
+            </a:r>
+            <a:endParaRPr lang="en-US" sz="4400" dirty="0"/>
           </a:p>
         </p:txBody>
       </p:sp>
@@ -12076,8 +11729,8 @@
         </p:nvSpPr>
         <p:spPr>
           <a:xfrm>
-            <a:off x="6492240" y="2240280"/>
-            <a:ext cx="4937760" cy="3840480"/>
+            <a:off x="3566160" y="2423160"/>
+            <a:ext cx="2240280" cy="640080"/>
           </a:xfrm>
           <a:prstGeom prst="rect">
             <a:avLst/>
@@ -12089,88 +11742,949 @@
           <a:bodyPr wrap="square" lIns="0" tIns="0" rIns="0" bIns="0" rtlCol="0" anchor="t"/>
           <a:lstStyle/>
           <a:p>
-            <a:pPr marL="342900" indent="-342900">
-              <a:spcAft>
-                <a:spcPts val="1000"/>
-              </a:spcAft>
-              <a:buSzPct val="100000"/>
-              <a:buChar char="•"/>
-            </a:pPr>
-            <a:r>
-              <a:rPr lang="en-US" sz="1600" dirty="0">
-                <a:solidFill>
-                  <a:srgbClr val="1D2433"/>
-                </a:solidFill>
-                <a:latin typeface="Calibri" pitchFamily="34" charset="0"/>
-                <a:ea typeface="Calibri" pitchFamily="34" charset="-122"/>
-                <a:cs typeface="Calibri" pitchFamily="34" charset="-120"/>
-              </a:rPr>
-              <a:t>Dùng toạ độ 4 đỉnh để tính luôn diện tích, chu vi; cho nhập toạ độ số thực.</a:t>
+            <a:pPr algn="ctr" indent="0" marL="0">
+              <a:buNone/>
+            </a:pPr>
+            <a:r>
+              <a:rPr lang="en-US" sz="1350" dirty="0">
+                <a:solidFill>
+                  <a:srgbClr val="5B6478"/>
+                </a:solidFill>
+                <a:latin typeface="Calibri" pitchFamily="34" charset="0"/>
+                <a:ea typeface="Calibri" pitchFamily="34" charset="-122"/>
+                <a:cs typeface="Calibri" pitchFamily="34" charset="-120"/>
+              </a:rPr>
+              <a:t>công thức tính toán</a:t>
+            </a:r>
+            <a:endParaRPr lang="en-US" sz="1350" dirty="0"/>
+          </a:p>
+        </p:txBody>
+      </p:sp>
+      <p:sp>
+        <p:nvSpPr>
+          <p:cNvPr id="13" name="Shape 11"/>
+          <p:cNvSpPr/>
+          <p:nvPr/>
+        </p:nvSpPr>
+        <p:spPr>
+          <a:xfrm>
+            <a:off x="6217920" y="1417320"/>
+            <a:ext cx="2606040" cy="1737360"/>
+          </a:xfrm>
+          <a:prstGeom prst="roundRect">
+            <a:avLst>
+              <a:gd name="adj" fmla="val 6316"/>
+            </a:avLst>
+          </a:prstGeom>
+          <a:solidFill>
+            <a:srgbClr val="FFFFFF"/>
+          </a:solidFill>
+          <a:ln w="9525">
+            <a:solidFill>
+              <a:srgbClr val="DDE3EE"/>
+            </a:solidFill>
+            <a:prstDash val="solid"/>
+          </a:ln>
+          <a:effectLst>
+            <a:outerShdw sx="100000" sy="100000" kx="0" ky="0" algn="bl" rotWithShape="0" blurRad="101600" dist="25400" dir="5400000">
+              <a:srgbClr val="1B2540">
+                <a:alpha val="12000"/>
+              </a:srgbClr>
+            </a:outerShdw>
+          </a:effectLst>
+        </p:spPr>
+      </p:sp>
+      <p:sp>
+        <p:nvSpPr>
+          <p:cNvPr id="14" name="Text 12"/>
+          <p:cNvSpPr txBox="1"/>
+          <p:nvPr/>
+        </p:nvSpPr>
+        <p:spPr>
+          <a:xfrm>
+            <a:off x="6217920" y="1554480"/>
+            <a:ext cx="2606040" cy="868680"/>
+          </a:xfrm>
+          <a:prstGeom prst="rect">
+            <a:avLst/>
+          </a:prstGeom>
+          <a:noFill/>
+          <a:ln/>
+        </p:spPr>
+        <p:txBody>
+          <a:bodyPr wrap="square" lIns="0" tIns="0" rIns="0" bIns="0" rtlCol="0" anchor="t"/>
+          <a:lstStyle/>
+          <a:p>
+            <a:pPr algn="ctr" indent="0" marL="0">
+              <a:buNone/>
+            </a:pPr>
+            <a:r>
+              <a:rPr lang="en-US" sz="4400" b="1" dirty="0">
+                <a:solidFill>
+                  <a:srgbClr val="0F8A5F"/>
+                </a:solidFill>
+                <a:latin typeface="Cambria" pitchFamily="34" charset="0"/>
+                <a:ea typeface="Cambria" pitchFamily="34" charset="-122"/>
+                <a:cs typeface="Cambria" pitchFamily="34" charset="-120"/>
+              </a:rPr>
+              <a:t>187</a:t>
+            </a:r>
+            <a:endParaRPr lang="en-US" sz="4400" dirty="0"/>
+          </a:p>
+        </p:txBody>
+      </p:sp>
+      <p:sp>
+        <p:nvSpPr>
+          <p:cNvPr id="15" name="Text 13"/>
+          <p:cNvSpPr txBox="1"/>
+          <p:nvPr/>
+        </p:nvSpPr>
+        <p:spPr>
+          <a:xfrm>
+            <a:off x="6400800" y="2423160"/>
+            <a:ext cx="2240280" cy="640080"/>
+          </a:xfrm>
+          <a:prstGeom prst="rect">
+            <a:avLst/>
+          </a:prstGeom>
+          <a:noFill/>
+          <a:ln/>
+        </p:spPr>
+        <p:txBody>
+          <a:bodyPr wrap="square" lIns="0" tIns="0" rIns="0" bIns="0" rtlCol="0" anchor="t"/>
+          <a:lstStyle/>
+          <a:p>
+            <a:pPr algn="ctr" indent="0" marL="0">
+              <a:buNone/>
+            </a:pPr>
+            <a:r>
+              <a:rPr lang="en-US" sz="1350" dirty="0">
+                <a:solidFill>
+                  <a:srgbClr val="5B6478"/>
+                </a:solidFill>
+                <a:latin typeface="Calibri" pitchFamily="34" charset="0"/>
+                <a:ea typeface="Calibri" pitchFamily="34" charset="-122"/>
+                <a:cs typeface="Calibri" pitchFamily="34" charset="-120"/>
+              </a:rPr>
+              <a:t>truy vấn khớp kết quả trên Neo4j thật</a:t>
+            </a:r>
+            <a:endParaRPr lang="en-US" sz="1350" dirty="0"/>
+          </a:p>
+        </p:txBody>
+      </p:sp>
+      <p:sp>
+        <p:nvSpPr>
+          <p:cNvPr id="16" name="Shape 14"/>
+          <p:cNvSpPr/>
+          <p:nvPr/>
+        </p:nvSpPr>
+        <p:spPr>
+          <a:xfrm>
+            <a:off x="9052560" y="1417320"/>
+            <a:ext cx="2606040" cy="1737360"/>
+          </a:xfrm>
+          <a:prstGeom prst="roundRect">
+            <a:avLst>
+              <a:gd name="adj" fmla="val 6316"/>
+            </a:avLst>
+          </a:prstGeom>
+          <a:solidFill>
+            <a:srgbClr val="FFFFFF"/>
+          </a:solidFill>
+          <a:ln w="9525">
+            <a:solidFill>
+              <a:srgbClr val="DDE3EE"/>
+            </a:solidFill>
+            <a:prstDash val="solid"/>
+          </a:ln>
+          <a:effectLst>
+            <a:outerShdw sx="100000" sy="100000" kx="0" ky="0" algn="bl" rotWithShape="0" blurRad="101600" dist="25400" dir="5400000">
+              <a:srgbClr val="1B2540">
+                <a:alpha val="12000"/>
+              </a:srgbClr>
+            </a:outerShdw>
+          </a:effectLst>
+        </p:spPr>
+      </p:sp>
+      <p:sp>
+        <p:nvSpPr>
+          <p:cNvPr id="17" name="Text 15"/>
+          <p:cNvSpPr txBox="1"/>
+          <p:nvPr/>
+        </p:nvSpPr>
+        <p:spPr>
+          <a:xfrm>
+            <a:off x="9052560" y="1554480"/>
+            <a:ext cx="2606040" cy="868680"/>
+          </a:xfrm>
+          <a:prstGeom prst="rect">
+            <a:avLst/>
+          </a:prstGeom>
+          <a:noFill/>
+          <a:ln/>
+        </p:spPr>
+        <p:txBody>
+          <a:bodyPr wrap="square" lIns="0" tIns="0" rIns="0" bIns="0" rtlCol="0" anchor="t"/>
+          <a:lstStyle/>
+          <a:p>
+            <a:pPr algn="ctr" indent="0" marL="0">
+              <a:buNone/>
+            </a:pPr>
+            <a:r>
+              <a:rPr lang="en-US" sz="4400" b="1" dirty="0">
+                <a:solidFill>
+                  <a:srgbClr val="0F8A5F"/>
+                </a:solidFill>
+                <a:latin typeface="Cambria" pitchFamily="34" charset="0"/>
+                <a:ea typeface="Cambria" pitchFamily="34" charset="-122"/>
+                <a:cs typeface="Cambria" pitchFamily="34" charset="-120"/>
+              </a:rPr>
+              <a:t>50/50</a:t>
+            </a:r>
+            <a:endParaRPr lang="en-US" sz="4400" dirty="0"/>
+          </a:p>
+        </p:txBody>
+      </p:sp>
+      <p:sp>
+        <p:nvSpPr>
+          <p:cNvPr id="18" name="Text 16"/>
+          <p:cNvSpPr txBox="1"/>
+          <p:nvPr/>
+        </p:nvSpPr>
+        <p:spPr>
+          <a:xfrm>
+            <a:off x="9235440" y="2423160"/>
+            <a:ext cx="2240280" cy="640080"/>
+          </a:xfrm>
+          <a:prstGeom prst="rect">
+            <a:avLst/>
+          </a:prstGeom>
+          <a:noFill/>
+          <a:ln/>
+        </p:spPr>
+        <p:txBody>
+          <a:bodyPr wrap="square" lIns="0" tIns="0" rIns="0" bIns="0" rtlCol="0" anchor="t"/>
+          <a:lstStyle/>
+          <a:p>
+            <a:pPr algn="ctr" indent="0" marL="0">
+              <a:buNone/>
+            </a:pPr>
+            <a:r>
+              <a:rPr lang="en-US" sz="1350" dirty="0">
+                <a:solidFill>
+                  <a:srgbClr val="5B6478"/>
+                </a:solidFill>
+                <a:latin typeface="Calibri" pitchFamily="34" charset="0"/>
+                <a:ea typeface="Calibri" pitchFamily="34" charset="-122"/>
+                <a:cs typeface="Calibri" pitchFamily="34" charset="-120"/>
+              </a:rPr>
+              <a:t>ca kiểm thử tự động đạt</a:t>
+            </a:r>
+            <a:endParaRPr lang="en-US" sz="1350" dirty="0"/>
+          </a:p>
+        </p:txBody>
+      </p:sp>
+      <p:sp>
+        <p:nvSpPr>
+          <p:cNvPr id="19" name="Shape 17"/>
+          <p:cNvSpPr/>
+          <p:nvPr/>
+        </p:nvSpPr>
+        <p:spPr>
+          <a:xfrm>
+            <a:off x="548640" y="3520440"/>
+            <a:ext cx="5440680" cy="1188720"/>
+          </a:xfrm>
+          <a:prstGeom prst="roundRect">
+            <a:avLst>
+              <a:gd name="adj" fmla="val 9231"/>
+            </a:avLst>
+          </a:prstGeom>
+          <a:solidFill>
+            <a:srgbClr val="FFFFFF"/>
+          </a:solidFill>
+          <a:ln w="9525">
+            <a:solidFill>
+              <a:srgbClr val="DDE3EE"/>
+            </a:solidFill>
+            <a:prstDash val="solid"/>
+          </a:ln>
+          <a:effectLst>
+            <a:outerShdw sx="100000" sy="100000" kx="0" ky="0" algn="bl" rotWithShape="0" blurRad="101600" dist="25400" dir="5400000">
+              <a:srgbClr val="1B2540">
+                <a:alpha val="12000"/>
+              </a:srgbClr>
+            </a:outerShdw>
+          </a:effectLst>
+        </p:spPr>
+      </p:sp>
+      <p:sp>
+        <p:nvSpPr>
+          <p:cNvPr id="20" name="Shape 18"/>
+          <p:cNvSpPr/>
+          <p:nvPr/>
+        </p:nvSpPr>
+        <p:spPr>
+          <a:xfrm>
+            <a:off x="777240" y="3867912"/>
+            <a:ext cx="502920" cy="502920"/>
+          </a:xfrm>
+          <a:prstGeom prst="ellipse">
+            <a:avLst/>
+          </a:prstGeom>
+          <a:solidFill>
+            <a:srgbClr val="0F8A5F"/>
+          </a:solidFill>
+          <a:ln w="12700">
+            <a:solidFill>
+              <a:srgbClr val="0F8A5F"/>
+            </a:solidFill>
+            <a:prstDash val="solid"/>
+          </a:ln>
+        </p:spPr>
+      </p:sp>
+      <p:sp>
+        <p:nvSpPr>
+          <p:cNvPr id="21" name="Text 19"/>
+          <p:cNvSpPr txBox="1"/>
+          <p:nvPr/>
+        </p:nvSpPr>
+        <p:spPr>
+          <a:xfrm>
+            <a:off x="777240" y="3867912"/>
+            <a:ext cx="502920" cy="502920"/>
+          </a:xfrm>
+          <a:prstGeom prst="rect">
+            <a:avLst/>
+          </a:prstGeom>
+          <a:noFill/>
+          <a:ln/>
+        </p:spPr>
+        <p:txBody>
+          <a:bodyPr wrap="square" lIns="0" tIns="0" rIns="0" bIns="0" rtlCol="0" anchor="ctr"/>
+          <a:lstStyle/>
+          <a:p>
+            <a:pPr algn="ctr" indent="0" marL="0">
+              <a:buNone/>
+            </a:pPr>
+            <a:r>
+              <a:rPr lang="en-US" sz="1600" b="1" dirty="0">
+                <a:solidFill>
+                  <a:srgbClr val="FFFFFF"/>
+                </a:solidFill>
+                <a:latin typeface="Calibri" pitchFamily="34" charset="0"/>
+                <a:ea typeface="Calibri" pitchFamily="34" charset="-122"/>
+                <a:cs typeface="Calibri" pitchFamily="34" charset="-120"/>
+              </a:rPr>
+              <a:t>✓</a:t>
             </a:r>
             <a:endParaRPr lang="en-US" sz="1600" dirty="0"/>
           </a:p>
-          <a:p>
-            <a:pPr marL="342900" indent="-342900">
-              <a:spcAft>
-                <a:spcPts val="1000"/>
-              </a:spcAft>
-              <a:buSzPct val="100000"/>
-              <a:buChar char="•"/>
-            </a:pPr>
-            <a:r>
-              <a:rPr lang="en-US" sz="1600" dirty="0">
-                <a:solidFill>
-                  <a:srgbClr val="1D2433"/>
-                </a:solidFill>
-                <a:latin typeface="Calibri" pitchFamily="34" charset="0"/>
-                <a:ea typeface="Calibri" pitchFamily="34" charset="-122"/>
-                <a:cs typeface="Calibri" pitchFamily="34" charset="-120"/>
-              </a:rPr>
-              <a:t>Thêm nút :Canh, :Goc, :DuongCheo để lời giải chi tiết như bài làm của học sinh.</a:t>
+        </p:txBody>
+      </p:sp>
+      <p:sp>
+        <p:nvSpPr>
+          <p:cNvPr id="22" name="Text 20"/>
+          <p:cNvSpPr txBox="1"/>
+          <p:nvPr/>
+        </p:nvSpPr>
+        <p:spPr>
+          <a:xfrm>
+            <a:off x="1463040" y="3703320"/>
+            <a:ext cx="4389120" cy="411480"/>
+          </a:xfrm>
+          <a:prstGeom prst="rect">
+            <a:avLst/>
+          </a:prstGeom>
+          <a:noFill/>
+          <a:ln/>
+        </p:spPr>
+        <p:txBody>
+          <a:bodyPr wrap="square" lIns="0" tIns="0" rIns="0" bIns="0" rtlCol="0" anchor="t"/>
+          <a:lstStyle/>
+          <a:p>
+            <a:pPr indent="0" marL="0">
+              <a:buNone/>
+            </a:pPr>
+            <a:r>
+              <a:rPr lang="en-US" sz="1700" b="1" dirty="0">
+                <a:solidFill>
+                  <a:srgbClr val="1B2540"/>
+                </a:solidFill>
+                <a:latin typeface="Calibri" pitchFamily="34" charset="0"/>
+                <a:ea typeface="Calibri" pitchFamily="34" charset="-122"/>
+                <a:cs typeface="Calibri" pitchFamily="34" charset="-120"/>
+              </a:rPr>
+              <a:t>Nhận dạng tứ giác</a:t>
+            </a:r>
+            <a:endParaRPr lang="en-US" sz="1700" dirty="0"/>
+          </a:p>
+        </p:txBody>
+      </p:sp>
+      <p:sp>
+        <p:nvSpPr>
+          <p:cNvPr id="23" name="Text 21"/>
+          <p:cNvSpPr txBox="1"/>
+          <p:nvPr/>
+        </p:nvSpPr>
+        <p:spPr>
+          <a:xfrm>
+            <a:off x="1463040" y="4114800"/>
+            <a:ext cx="4389120" cy="502920"/>
+          </a:xfrm>
+          <a:prstGeom prst="rect">
+            <a:avLst/>
+          </a:prstGeom>
+          <a:noFill/>
+          <a:ln/>
+        </p:spPr>
+        <p:txBody>
+          <a:bodyPr wrap="square" lIns="0" tIns="0" rIns="0" bIns="0" rtlCol="0" anchor="t"/>
+          <a:lstStyle/>
+          <a:p>
+            <a:pPr indent="0" marL="0">
+              <a:buNone/>
+            </a:pPr>
+            <a:r>
+              <a:rPr lang="en-US" sz="1350" dirty="0">
+                <a:solidFill>
+                  <a:srgbClr val="5B6478"/>
+                </a:solidFill>
+                <a:latin typeface="Calibri" pitchFamily="34" charset="0"/>
+                <a:ea typeface="Calibri" pitchFamily="34" charset="-122"/>
+                <a:cs typeface="Calibri" pitchFamily="34" charset="-120"/>
+              </a:rPr>
+              <a:t>Lời giải từng bước, phát hiện thiếu dữ kiện và mâu thuẫn</a:t>
+            </a:r>
+            <a:endParaRPr lang="en-US" sz="1350" dirty="0"/>
+          </a:p>
+        </p:txBody>
+      </p:sp>
+      <p:sp>
+        <p:nvSpPr>
+          <p:cNvPr id="24" name="Shape 22"/>
+          <p:cNvSpPr/>
+          <p:nvPr/>
+        </p:nvSpPr>
+        <p:spPr>
+          <a:xfrm>
+            <a:off x="6172200" y="3520440"/>
+            <a:ext cx="5440680" cy="1188720"/>
+          </a:xfrm>
+          <a:prstGeom prst="roundRect">
+            <a:avLst>
+              <a:gd name="adj" fmla="val 9231"/>
+            </a:avLst>
+          </a:prstGeom>
+          <a:solidFill>
+            <a:srgbClr val="FFFFFF"/>
+          </a:solidFill>
+          <a:ln w="9525">
+            <a:solidFill>
+              <a:srgbClr val="DDE3EE"/>
+            </a:solidFill>
+            <a:prstDash val="solid"/>
+          </a:ln>
+          <a:effectLst>
+            <a:outerShdw sx="100000" sy="100000" kx="0" ky="0" algn="bl" rotWithShape="0" blurRad="101600" dist="25400" dir="5400000">
+              <a:srgbClr val="1B2540">
+                <a:alpha val="12000"/>
+              </a:srgbClr>
+            </a:outerShdw>
+          </a:effectLst>
+        </p:spPr>
+      </p:sp>
+      <p:sp>
+        <p:nvSpPr>
+          <p:cNvPr id="25" name="Shape 23"/>
+          <p:cNvSpPr/>
+          <p:nvPr/>
+        </p:nvSpPr>
+        <p:spPr>
+          <a:xfrm>
+            <a:off x="6400800" y="3867912"/>
+            <a:ext cx="502920" cy="502920"/>
+          </a:xfrm>
+          <a:prstGeom prst="ellipse">
+            <a:avLst/>
+          </a:prstGeom>
+          <a:solidFill>
+            <a:srgbClr val="0F8A5F"/>
+          </a:solidFill>
+          <a:ln w="12700">
+            <a:solidFill>
+              <a:srgbClr val="0F8A5F"/>
+            </a:solidFill>
+            <a:prstDash val="solid"/>
+          </a:ln>
+        </p:spPr>
+      </p:sp>
+      <p:sp>
+        <p:nvSpPr>
+          <p:cNvPr id="26" name="Text 24"/>
+          <p:cNvSpPr txBox="1"/>
+          <p:nvPr/>
+        </p:nvSpPr>
+        <p:spPr>
+          <a:xfrm>
+            <a:off x="6400800" y="3867912"/>
+            <a:ext cx="502920" cy="502920"/>
+          </a:xfrm>
+          <a:prstGeom prst="rect">
+            <a:avLst/>
+          </a:prstGeom>
+          <a:noFill/>
+          <a:ln/>
+        </p:spPr>
+        <p:txBody>
+          <a:bodyPr wrap="square" lIns="0" tIns="0" rIns="0" bIns="0" rtlCol="0" anchor="ctr"/>
+          <a:lstStyle/>
+          <a:p>
+            <a:pPr algn="ctr" indent="0" marL="0">
+              <a:buNone/>
+            </a:pPr>
+            <a:r>
+              <a:rPr lang="en-US" sz="1600" b="1" dirty="0">
+                <a:solidFill>
+                  <a:srgbClr val="FFFFFF"/>
+                </a:solidFill>
+                <a:latin typeface="Calibri" pitchFamily="34" charset="0"/>
+                <a:ea typeface="Calibri" pitchFamily="34" charset="-122"/>
+                <a:cs typeface="Calibri" pitchFamily="34" charset="-120"/>
+              </a:rPr>
+              <a:t>✓</a:t>
             </a:r>
             <a:endParaRPr lang="en-US" sz="1600" dirty="0"/>
           </a:p>
-          <a:p>
-            <a:pPr marL="342900" indent="-342900">
-              <a:spcAft>
-                <a:spcPts val="1000"/>
-              </a:spcAft>
-              <a:buSzPct val="100000"/>
-              <a:buChar char="•"/>
-            </a:pPr>
-            <a:r>
-              <a:rPr lang="en-US" sz="1600" dirty="0">
-                <a:solidFill>
-                  <a:srgbClr val="1D2433"/>
-                </a:solidFill>
-                <a:latin typeface="Calibri" pitchFamily="34" charset="0"/>
-                <a:ea typeface="Calibri" pitchFamily="34" charset="-122"/>
-                <a:cs typeface="Calibri" pitchFamily="34" charset="-120"/>
-              </a:rPr>
-              <a:t>Mở rộng sang tam giác, đa giác.</a:t>
+        </p:txBody>
+      </p:sp>
+      <p:sp>
+        <p:nvSpPr>
+          <p:cNvPr id="27" name="Text 25"/>
+          <p:cNvSpPr txBox="1"/>
+          <p:nvPr/>
+        </p:nvSpPr>
+        <p:spPr>
+          <a:xfrm>
+            <a:off x="7086600" y="3703320"/>
+            <a:ext cx="4389120" cy="411480"/>
+          </a:xfrm>
+          <a:prstGeom prst="rect">
+            <a:avLst/>
+          </a:prstGeom>
+          <a:noFill/>
+          <a:ln/>
+        </p:spPr>
+        <p:txBody>
+          <a:bodyPr wrap="square" lIns="0" tIns="0" rIns="0" bIns="0" rtlCol="0" anchor="t"/>
+          <a:lstStyle/>
+          <a:p>
+            <a:pPr indent="0" marL="0">
+              <a:buNone/>
+            </a:pPr>
+            <a:r>
+              <a:rPr lang="en-US" sz="1700" b="1" dirty="0">
+                <a:solidFill>
+                  <a:srgbClr val="1B2540"/>
+                </a:solidFill>
+                <a:latin typeface="Calibri" pitchFamily="34" charset="0"/>
+                <a:ea typeface="Calibri" pitchFamily="34" charset="-122"/>
+                <a:cs typeface="Calibri" pitchFamily="34" charset="-120"/>
+              </a:rPr>
+              <a:t>Tính diện tích, chu vi</a:t>
+            </a:r>
+            <a:endParaRPr lang="en-US" sz="1700" dirty="0"/>
+          </a:p>
+        </p:txBody>
+      </p:sp>
+      <p:sp>
+        <p:nvSpPr>
+          <p:cNvPr id="28" name="Text 26"/>
+          <p:cNvSpPr txBox="1"/>
+          <p:nvPr/>
+        </p:nvSpPr>
+        <p:spPr>
+          <a:xfrm>
+            <a:off x="7086600" y="4114800"/>
+            <a:ext cx="4389120" cy="502920"/>
+          </a:xfrm>
+          <a:prstGeom prst="rect">
+            <a:avLst/>
+          </a:prstGeom>
+          <a:noFill/>
+          <a:ln/>
+        </p:spPr>
+        <p:txBody>
+          <a:bodyPr wrap="square" lIns="0" tIns="0" rIns="0" bIns="0" rtlCol="0" anchor="t"/>
+          <a:lstStyle/>
+          <a:p>
+            <a:pPr indent="0" marL="0">
+              <a:buNone/>
+            </a:pPr>
+            <a:r>
+              <a:rPr lang="en-US" sz="1350" dirty="0">
+                <a:solidFill>
+                  <a:srgbClr val="5B6478"/>
+                </a:solidFill>
+                <a:latin typeface="Calibri" pitchFamily="34" charset="0"/>
+                <a:ea typeface="Calibri" pitchFamily="34" charset="-122"/>
+                <a:cs typeface="Calibri" pitchFamily="34" charset="-120"/>
+              </a:rPr>
+              <a:t>Nhập số liệu bất kỳ, tính mọi đại lượng liên quan</a:t>
+            </a:r>
+            <a:endParaRPr lang="en-US" sz="1350" dirty="0"/>
+          </a:p>
+        </p:txBody>
+      </p:sp>
+      <p:sp>
+        <p:nvSpPr>
+          <p:cNvPr id="29" name="Shape 27"/>
+          <p:cNvSpPr/>
+          <p:nvPr/>
+        </p:nvSpPr>
+        <p:spPr>
+          <a:xfrm>
+            <a:off x="548640" y="4892040"/>
+            <a:ext cx="5440680" cy="1188720"/>
+          </a:xfrm>
+          <a:prstGeom prst="roundRect">
+            <a:avLst>
+              <a:gd name="adj" fmla="val 9231"/>
+            </a:avLst>
+          </a:prstGeom>
+          <a:solidFill>
+            <a:srgbClr val="FFFFFF"/>
+          </a:solidFill>
+          <a:ln w="9525">
+            <a:solidFill>
+              <a:srgbClr val="DDE3EE"/>
+            </a:solidFill>
+            <a:prstDash val="solid"/>
+          </a:ln>
+          <a:effectLst>
+            <a:outerShdw sx="100000" sy="100000" kx="0" ky="0" algn="bl" rotWithShape="0" blurRad="101600" dist="25400" dir="5400000">
+              <a:srgbClr val="1B2540">
+                <a:alpha val="12000"/>
+              </a:srgbClr>
+            </a:outerShdw>
+          </a:effectLst>
+        </p:spPr>
+      </p:sp>
+      <p:sp>
+        <p:nvSpPr>
+          <p:cNvPr id="30" name="Shape 28"/>
+          <p:cNvSpPr/>
+          <p:nvPr/>
+        </p:nvSpPr>
+        <p:spPr>
+          <a:xfrm>
+            <a:off x="777240" y="5239512"/>
+            <a:ext cx="502920" cy="502920"/>
+          </a:xfrm>
+          <a:prstGeom prst="ellipse">
+            <a:avLst/>
+          </a:prstGeom>
+          <a:solidFill>
+            <a:srgbClr val="0F8A5F"/>
+          </a:solidFill>
+          <a:ln w="12700">
+            <a:solidFill>
+              <a:srgbClr val="0F8A5F"/>
+            </a:solidFill>
+            <a:prstDash val="solid"/>
+          </a:ln>
+        </p:spPr>
+      </p:sp>
+      <p:sp>
+        <p:nvSpPr>
+          <p:cNvPr id="31" name="Text 29"/>
+          <p:cNvSpPr txBox="1"/>
+          <p:nvPr/>
+        </p:nvSpPr>
+        <p:spPr>
+          <a:xfrm>
+            <a:off x="777240" y="5239512"/>
+            <a:ext cx="502920" cy="502920"/>
+          </a:xfrm>
+          <a:prstGeom prst="rect">
+            <a:avLst/>
+          </a:prstGeom>
+          <a:noFill/>
+          <a:ln/>
+        </p:spPr>
+        <p:txBody>
+          <a:bodyPr wrap="square" lIns="0" tIns="0" rIns="0" bIns="0" rtlCol="0" anchor="ctr"/>
+          <a:lstStyle/>
+          <a:p>
+            <a:pPr algn="ctr" indent="0" marL="0">
+              <a:buNone/>
+            </a:pPr>
+            <a:r>
+              <a:rPr lang="en-US" sz="1600" b="1" dirty="0">
+                <a:solidFill>
+                  <a:srgbClr val="FFFFFF"/>
+                </a:solidFill>
+                <a:latin typeface="Calibri" pitchFamily="34" charset="0"/>
+                <a:ea typeface="Calibri" pitchFamily="34" charset="-122"/>
+                <a:cs typeface="Calibri" pitchFamily="34" charset="-120"/>
+              </a:rPr>
+              <a:t>✓</a:t>
             </a:r>
             <a:endParaRPr lang="en-US" sz="1600" dirty="0"/>
           </a:p>
-          <a:p>
-            <a:pPr marL="342900" indent="-342900">
-              <a:spcAft>
-                <a:spcPts val="1000"/>
-              </a:spcAft>
-              <a:buSzPct val="100000"/>
-              <a:buChar char="•"/>
-            </a:pPr>
-            <a:r>
-              <a:rPr lang="en-US" sz="1600" dirty="0">
-                <a:solidFill>
-                  <a:srgbClr val="1D2433"/>
-                </a:solidFill>
-                <a:latin typeface="Calibri" pitchFamily="34" charset="0"/>
-                <a:ea typeface="Calibri" pitchFamily="34" charset="-122"/>
-                <a:cs typeface="Calibri" pitchFamily="34" charset="-120"/>
-              </a:rPr>
-              <a:t>Mở rộng lượt chơi (:LuotChoi) thành hồ sơ người học để gợi ý thử thách, bài tập.</a:t>
+        </p:txBody>
+      </p:sp>
+      <p:sp>
+        <p:nvSpPr>
+          <p:cNvPr id="32" name="Text 30"/>
+          <p:cNvSpPr txBox="1"/>
+          <p:nvPr/>
+        </p:nvSpPr>
+        <p:spPr>
+          <a:xfrm>
+            <a:off x="1463040" y="5074920"/>
+            <a:ext cx="4389120" cy="411480"/>
+          </a:xfrm>
+          <a:prstGeom prst="rect">
+            <a:avLst/>
+          </a:prstGeom>
+          <a:noFill/>
+          <a:ln/>
+        </p:spPr>
+        <p:txBody>
+          <a:bodyPr wrap="square" lIns="0" tIns="0" rIns="0" bIns="0" rtlCol="0" anchor="t"/>
+          <a:lstStyle/>
+          <a:p>
+            <a:pPr indent="0" marL="0">
+              <a:buNone/>
+            </a:pPr>
+            <a:r>
+              <a:rPr lang="en-US" sz="1700" b="1" dirty="0">
+                <a:solidFill>
+                  <a:srgbClr val="1B2540"/>
+                </a:solidFill>
+                <a:latin typeface="Calibri" pitchFamily="34" charset="0"/>
+                <a:ea typeface="Calibri" pitchFamily="34" charset="-122"/>
+                <a:cs typeface="Calibri" pitchFamily="34" charset="-120"/>
+              </a:rPr>
+              <a:t>Trò chơi Thử thách</a:t>
+            </a:r>
+            <a:endParaRPr lang="en-US" sz="1700" dirty="0"/>
+          </a:p>
+        </p:txBody>
+      </p:sp>
+      <p:sp>
+        <p:nvSpPr>
+          <p:cNvPr id="33" name="Text 31"/>
+          <p:cNvSpPr txBox="1"/>
+          <p:nvPr/>
+        </p:nvSpPr>
+        <p:spPr>
+          <a:xfrm>
+            <a:off x="1463040" y="5486400"/>
+            <a:ext cx="4389120" cy="502920"/>
+          </a:xfrm>
+          <a:prstGeom prst="rect">
+            <a:avLst/>
+          </a:prstGeom>
+          <a:noFill/>
+          <a:ln/>
+        </p:spPr>
+        <p:txBody>
+          <a:bodyPr wrap="square" lIns="0" tIns="0" rIns="0" bIns="0" rtlCol="0" anchor="t"/>
+          <a:lstStyle/>
+          <a:p>
+            <a:pPr indent="0" marL="0">
+              <a:buNone/>
+            </a:pPr>
+            <a:r>
+              <a:rPr lang="en-US" sz="1350" dirty="0">
+                <a:solidFill>
+                  <a:srgbClr val="5B6478"/>
+                </a:solidFill>
+                <a:latin typeface="Calibri" pitchFamily="34" charset="0"/>
+                <a:ea typeface="Calibri" pitchFamily="34" charset="-122"/>
+                <a:cs typeface="Calibri" pitchFamily="34" charset="-120"/>
+              </a:rPr>
+              <a:t>Kéo thả 4 đỉnh, Neo4j chấm điểm, bảng xếp hạng lưu trong Neo4j</a:t>
+            </a:r>
+            <a:endParaRPr lang="en-US" sz="1350" dirty="0"/>
+          </a:p>
+        </p:txBody>
+      </p:sp>
+      <p:sp>
+        <p:nvSpPr>
+          <p:cNvPr id="34" name="Shape 32"/>
+          <p:cNvSpPr/>
+          <p:nvPr/>
+        </p:nvSpPr>
+        <p:spPr>
+          <a:xfrm>
+            <a:off x="6172200" y="4892040"/>
+            <a:ext cx="5440680" cy="1188720"/>
+          </a:xfrm>
+          <a:prstGeom prst="roundRect">
+            <a:avLst>
+              <a:gd name="adj" fmla="val 9231"/>
+            </a:avLst>
+          </a:prstGeom>
+          <a:solidFill>
+            <a:srgbClr val="FFFFFF"/>
+          </a:solidFill>
+          <a:ln w="9525">
+            <a:solidFill>
+              <a:srgbClr val="DDE3EE"/>
+            </a:solidFill>
+            <a:prstDash val="solid"/>
+          </a:ln>
+          <a:effectLst>
+            <a:outerShdw sx="100000" sy="100000" kx="0" ky="0" algn="bl" rotWithShape="0" blurRad="101600" dist="25400" dir="5400000">
+              <a:srgbClr val="1B2540">
+                <a:alpha val="12000"/>
+              </a:srgbClr>
+            </a:outerShdw>
+          </a:effectLst>
+        </p:spPr>
+      </p:sp>
+      <p:sp>
+        <p:nvSpPr>
+          <p:cNvPr id="35" name="Shape 33"/>
+          <p:cNvSpPr/>
+          <p:nvPr/>
+        </p:nvSpPr>
+        <p:spPr>
+          <a:xfrm>
+            <a:off x="6400800" y="5239512"/>
+            <a:ext cx="502920" cy="502920"/>
+          </a:xfrm>
+          <a:prstGeom prst="ellipse">
+            <a:avLst/>
+          </a:prstGeom>
+          <a:solidFill>
+            <a:srgbClr val="0F8A5F"/>
+          </a:solidFill>
+          <a:ln w="12700">
+            <a:solidFill>
+              <a:srgbClr val="0F8A5F"/>
+            </a:solidFill>
+            <a:prstDash val="solid"/>
+          </a:ln>
+        </p:spPr>
+      </p:sp>
+      <p:sp>
+        <p:nvSpPr>
+          <p:cNvPr id="36" name="Text 34"/>
+          <p:cNvSpPr txBox="1"/>
+          <p:nvPr/>
+        </p:nvSpPr>
+        <p:spPr>
+          <a:xfrm>
+            <a:off x="6400800" y="5239512"/>
+            <a:ext cx="502920" cy="502920"/>
+          </a:xfrm>
+          <a:prstGeom prst="rect">
+            <a:avLst/>
+          </a:prstGeom>
+          <a:noFill/>
+          <a:ln/>
+        </p:spPr>
+        <p:txBody>
+          <a:bodyPr wrap="square" lIns="0" tIns="0" rIns="0" bIns="0" rtlCol="0" anchor="ctr"/>
+          <a:lstStyle/>
+          <a:p>
+            <a:pPr algn="ctr" indent="0" marL="0">
+              <a:buNone/>
+            </a:pPr>
+            <a:r>
+              <a:rPr lang="en-US" sz="1600" b="1" dirty="0">
+                <a:solidFill>
+                  <a:srgbClr val="FFFFFF"/>
+                </a:solidFill>
+                <a:latin typeface="Calibri" pitchFamily="34" charset="0"/>
+                <a:ea typeface="Calibri" pitchFamily="34" charset="-122"/>
+                <a:cs typeface="Calibri" pitchFamily="34" charset="-120"/>
+              </a:rPr>
+              <a:t>✓</a:t>
             </a:r>
             <a:endParaRPr lang="en-US" sz="1600" dirty="0"/>
+          </a:p>
+        </p:txBody>
+      </p:sp>
+      <p:sp>
+        <p:nvSpPr>
+          <p:cNvPr id="37" name="Text 35"/>
+          <p:cNvSpPr txBox="1"/>
+          <p:nvPr/>
+        </p:nvSpPr>
+        <p:spPr>
+          <a:xfrm>
+            <a:off x="7086600" y="5074920"/>
+            <a:ext cx="4389120" cy="411480"/>
+          </a:xfrm>
+          <a:prstGeom prst="rect">
+            <a:avLst/>
+          </a:prstGeom>
+          <a:noFill/>
+          <a:ln/>
+        </p:spPr>
+        <p:txBody>
+          <a:bodyPr wrap="square" lIns="0" tIns="0" rIns="0" bIns="0" rtlCol="0" anchor="t"/>
+          <a:lstStyle/>
+          <a:p>
+            <a:pPr indent="0" marL="0">
+              <a:buNone/>
+            </a:pPr>
+            <a:r>
+              <a:rPr lang="en-US" sz="1700" b="1" dirty="0">
+                <a:solidFill>
+                  <a:srgbClr val="1B2540"/>
+                </a:solidFill>
+                <a:latin typeface="Calibri" pitchFamily="34" charset="0"/>
+                <a:ea typeface="Calibri" pitchFamily="34" charset="-122"/>
+                <a:cs typeface="Calibri" pitchFamily="34" charset="-120"/>
+              </a:rPr>
+              <a:t>Tra cứu, tài liệu &amp; mã nguồn</a:t>
+            </a:r>
+            <a:endParaRPr lang="en-US" sz="1700" dirty="0"/>
+          </a:p>
+        </p:txBody>
+      </p:sp>
+      <p:sp>
+        <p:nvSpPr>
+          <p:cNvPr id="38" name="Text 36"/>
+          <p:cNvSpPr txBox="1"/>
+          <p:nvPr/>
+        </p:nvSpPr>
+        <p:spPr>
+          <a:xfrm>
+            <a:off x="7086600" y="5486400"/>
+            <a:ext cx="4389120" cy="502920"/>
+          </a:xfrm>
+          <a:prstGeom prst="rect">
+            <a:avLst/>
+          </a:prstGeom>
+          <a:noFill/>
+          <a:ln/>
+        </p:spPr>
+        <p:txBody>
+          <a:bodyPr wrap="square" lIns="0" tIns="0" rIns="0" bIns="0" rtlCol="0" anchor="t"/>
+          <a:lstStyle/>
+          <a:p>
+            <a:pPr indent="0" marL="0">
+              <a:buNone/>
+            </a:pPr>
+            <a:r>
+              <a:rPr lang="en-US" sz="1350" dirty="0">
+                <a:solidFill>
+                  <a:srgbClr val="5B6478"/>
+                </a:solidFill>
+                <a:latin typeface="Calibri" pitchFamily="34" charset="0"/>
+                <a:ea typeface="Calibri" pitchFamily="34" charset="-122"/>
+                <a:cs typeface="Calibri" pitchFamily="34" charset="-120"/>
+              </a:rPr>
+              <a:t>Đồ thị tri thức, báo cáo, hướng dẫn sử dụng, GitHub, API JSON</a:t>
+            </a:r>
+            <a:endParaRPr lang="en-US" sz="1350" dirty="0"/>
           </a:p>
         </p:txBody>
       </p:sp>
@@ -12185,6 +12699,544 @@
 <file path=ppt/slides/slide18.xml><?xml version="1.0" encoding="utf-8"?>
 <p:sld xmlns:a="http://schemas.openxmlformats.org/drawingml/2006/main" xmlns:r="http://schemas.openxmlformats.org/officeDocument/2006/relationships" xmlns:p="http://schemas.openxmlformats.org/presentationml/2006/main">
   <p:cSld name="Slide 18">
+    <p:bg>
+      <p:bgPr>
+        <a:solidFill>
+          <a:srgbClr val="F4F6FA"/>
+        </a:solidFill>
+      </p:bgPr>
+    </p:bg>
+    <p:spTree>
+      <p:nvGrpSpPr>
+        <p:cNvPr id="1" name=""/>
+        <p:cNvGrpSpPr/>
+        <p:nvPr/>
+      </p:nvGrpSpPr>
+      <p:grpSpPr>
+        <a:xfrm>
+          <a:off x="0" y="0"/>
+          <a:ext cx="0" cy="0"/>
+          <a:chOff x="0" y="0"/>
+          <a:chExt cx="0" cy="0"/>
+        </a:xfrm>
+      </p:grpSpPr>
+      <p:sp>
+        <p:nvSpPr>
+          <p:cNvPr id="2" name="Shape 0"/>
+          <p:cNvSpPr/>
+          <p:nvPr/>
+        </p:nvSpPr>
+        <p:spPr>
+          <a:xfrm>
+            <a:off x="548640" y="411480"/>
+            <a:ext cx="566928" cy="566928"/>
+          </a:xfrm>
+          <a:prstGeom prst="roundRect">
+            <a:avLst>
+              <a:gd name="adj" fmla="val 16129"/>
+            </a:avLst>
+          </a:prstGeom>
+          <a:solidFill>
+            <a:srgbClr val="2F5BEA"/>
+          </a:solidFill>
+          <a:ln w="12700">
+            <a:solidFill>
+              <a:srgbClr val="2F5BEA"/>
+            </a:solidFill>
+            <a:prstDash val="solid"/>
+          </a:ln>
+        </p:spPr>
+      </p:sp>
+      <p:sp>
+        <p:nvSpPr>
+          <p:cNvPr id="3" name="Text 1"/>
+          <p:cNvSpPr txBox="1"/>
+          <p:nvPr/>
+        </p:nvSpPr>
+        <p:spPr>
+          <a:xfrm>
+            <a:off x="548640" y="411480"/>
+            <a:ext cx="566928" cy="566928"/>
+          </a:xfrm>
+          <a:prstGeom prst="rect">
+            <a:avLst/>
+          </a:prstGeom>
+          <a:noFill/>
+          <a:ln/>
+        </p:spPr>
+        <p:txBody>
+          <a:bodyPr wrap="square" lIns="0" tIns="0" rIns="0" bIns="0" rtlCol="0" anchor="ctr"/>
+          <a:lstStyle/>
+          <a:p>
+            <a:pPr algn="ctr" indent="0" marL="0">
+              <a:buNone/>
+            </a:pPr>
+            <a:r>
+              <a:rPr lang="en-US" sz="2000" b="1" dirty="0">
+                <a:solidFill>
+                  <a:srgbClr val="FFFFFF"/>
+                </a:solidFill>
+                <a:latin typeface="Cambria" pitchFamily="34" charset="0"/>
+                <a:ea typeface="Cambria" pitchFamily="34" charset="-122"/>
+                <a:cs typeface="Cambria" pitchFamily="34" charset="-120"/>
+              </a:rPr>
+              <a:t>6</a:t>
+            </a:r>
+            <a:endParaRPr lang="en-US" sz="2000" dirty="0"/>
+          </a:p>
+        </p:txBody>
+      </p:sp>
+      <p:sp>
+        <p:nvSpPr>
+          <p:cNvPr id="4" name="Text 2"/>
+          <p:cNvSpPr txBox="1"/>
+          <p:nvPr/>
+        </p:nvSpPr>
+        <p:spPr>
+          <a:xfrm>
+            <a:off x="1298448" y="347472"/>
+            <a:ext cx="10314432" cy="640080"/>
+          </a:xfrm>
+          <a:prstGeom prst="rect">
+            <a:avLst/>
+          </a:prstGeom>
+          <a:noFill/>
+          <a:ln/>
+        </p:spPr>
+        <p:txBody>
+          <a:bodyPr wrap="square" lIns="0" tIns="0" rIns="0" bIns="0" rtlCol="0" anchor="ctr"/>
+          <a:lstStyle/>
+          <a:p>
+            <a:pPr indent="0" marL="0">
+              <a:buNone/>
+            </a:pPr>
+            <a:r>
+              <a:rPr lang="en-US" sz="3200" b="1" dirty="0">
+                <a:solidFill>
+                  <a:srgbClr val="1B2540"/>
+                </a:solidFill>
+                <a:latin typeface="Cambria" pitchFamily="34" charset="0"/>
+                <a:ea typeface="Cambria" pitchFamily="34" charset="-122"/>
+                <a:cs typeface="Cambria" pitchFamily="34" charset="-120"/>
+              </a:rPr>
+              <a:t>Hạn chế &amp; hướng phát triển</a:t>
+            </a:r>
+            <a:endParaRPr lang="en-US" sz="3200" dirty="0"/>
+          </a:p>
+        </p:txBody>
+      </p:sp>
+      <p:sp>
+        <p:nvSpPr>
+          <p:cNvPr id="5" name="Text 3"/>
+          <p:cNvSpPr txBox="1"/>
+          <p:nvPr/>
+        </p:nvSpPr>
+        <p:spPr>
+          <a:xfrm>
+            <a:off x="548640" y="6446520"/>
+            <a:ext cx="5486400" cy="274320"/>
+          </a:xfrm>
+          <a:prstGeom prst="rect">
+            <a:avLst/>
+          </a:prstGeom>
+          <a:noFill/>
+          <a:ln/>
+        </p:spPr>
+        <p:txBody>
+          <a:bodyPr wrap="square" lIns="0" tIns="0" rIns="0" bIns="0" rtlCol="0" anchor="t"/>
+          <a:lstStyle/>
+          <a:p>
+            <a:pPr indent="0" marL="0">
+              <a:buNone/>
+            </a:pPr>
+            <a:r>
+              <a:rPr lang="en-US" sz="1000" dirty="0">
+                <a:solidFill>
+                  <a:srgbClr val="8A93A8"/>
+                </a:solidFill>
+                <a:latin typeface="Calibri" pitchFamily="34" charset="0"/>
+                <a:ea typeface="Calibri" pitchFamily="34" charset="-122"/>
+                <a:cs typeface="Calibri" pitchFamily="34" charset="-120"/>
+              </a:rPr>
+              <a:t>Mô hình hoá tứ giác với Neo4j</a:t>
+            </a:r>
+            <a:endParaRPr lang="en-US" sz="1000" dirty="0"/>
+          </a:p>
+        </p:txBody>
+      </p:sp>
+      <p:sp>
+        <p:nvSpPr>
+          <p:cNvPr id="6" name="Text 4"/>
+          <p:cNvSpPr txBox="1"/>
+          <p:nvPr/>
+        </p:nvSpPr>
+        <p:spPr>
+          <a:xfrm>
+            <a:off x="11155680" y="6446520"/>
+            <a:ext cx="502920" cy="274320"/>
+          </a:xfrm>
+          <a:prstGeom prst="rect">
+            <a:avLst/>
+          </a:prstGeom>
+          <a:noFill/>
+          <a:ln/>
+        </p:spPr>
+        <p:txBody>
+          <a:bodyPr wrap="square" lIns="0" tIns="0" rIns="0" bIns="0" rtlCol="0" anchor="t"/>
+          <a:lstStyle/>
+          <a:p>
+            <a:pPr algn="r" indent="0" marL="0">
+              <a:buNone/>
+            </a:pPr>
+            <a:r>
+              <a:rPr lang="en-US" sz="1000" dirty="0">
+                <a:solidFill>
+                  <a:srgbClr val="8A93A8"/>
+                </a:solidFill>
+                <a:latin typeface="Calibri" pitchFamily="34" charset="0"/>
+                <a:ea typeface="Calibri" pitchFamily="34" charset="-122"/>
+                <a:cs typeface="Calibri" pitchFamily="34" charset="-120"/>
+              </a:rPr>
+              <a:t>18</a:t>
+            </a:r>
+            <a:endParaRPr lang="en-US" sz="1000" dirty="0"/>
+          </a:p>
+        </p:txBody>
+      </p:sp>
+      <p:sp>
+        <p:nvSpPr>
+          <p:cNvPr id="7" name="Shape 5"/>
+          <p:cNvSpPr/>
+          <p:nvPr/>
+        </p:nvSpPr>
+        <p:spPr>
+          <a:xfrm>
+            <a:off x="548640" y="1417320"/>
+            <a:ext cx="5440680" cy="4846320"/>
+          </a:xfrm>
+          <a:prstGeom prst="roundRect">
+            <a:avLst>
+              <a:gd name="adj" fmla="val 2264"/>
+            </a:avLst>
+          </a:prstGeom>
+          <a:solidFill>
+            <a:srgbClr val="F1F3F7"/>
+          </a:solidFill>
+          <a:ln w="9525">
+            <a:solidFill>
+              <a:srgbClr val="F1F3F7"/>
+            </a:solidFill>
+            <a:prstDash val="solid"/>
+          </a:ln>
+        </p:spPr>
+      </p:sp>
+      <p:sp>
+        <p:nvSpPr>
+          <p:cNvPr id="8" name="Text 6"/>
+          <p:cNvSpPr txBox="1"/>
+          <p:nvPr/>
+        </p:nvSpPr>
+        <p:spPr>
+          <a:xfrm>
+            <a:off x="822960" y="1645920"/>
+            <a:ext cx="4846320" cy="457200"/>
+          </a:xfrm>
+          <a:prstGeom prst="rect">
+            <a:avLst/>
+          </a:prstGeom>
+          <a:noFill/>
+          <a:ln/>
+        </p:spPr>
+        <p:txBody>
+          <a:bodyPr wrap="square" lIns="0" tIns="0" rIns="0" bIns="0" rtlCol="0" anchor="t"/>
+          <a:lstStyle/>
+          <a:p>
+            <a:pPr indent="0" marL="0">
+              <a:buNone/>
+            </a:pPr>
+            <a:r>
+              <a:rPr lang="en-US" sz="2200" b="1" dirty="0">
+                <a:solidFill>
+                  <a:srgbClr val="5B6478"/>
+                </a:solidFill>
+                <a:latin typeface="Cambria" pitchFamily="34" charset="0"/>
+                <a:ea typeface="Cambria" pitchFamily="34" charset="-122"/>
+                <a:cs typeface="Cambria" pitchFamily="34" charset="-120"/>
+              </a:rPr>
+              <a:t>Hạn chế</a:t>
+            </a:r>
+            <a:endParaRPr lang="en-US" sz="2200" dirty="0"/>
+          </a:p>
+        </p:txBody>
+      </p:sp>
+      <p:sp>
+        <p:nvSpPr>
+          <p:cNvPr id="9" name="Text 7"/>
+          <p:cNvSpPr txBox="1"/>
+          <p:nvPr/>
+        </p:nvSpPr>
+        <p:spPr>
+          <a:xfrm>
+            <a:off x="822960" y="2240280"/>
+            <a:ext cx="4937760" cy="3840480"/>
+          </a:xfrm>
+          <a:prstGeom prst="rect">
+            <a:avLst/>
+          </a:prstGeom>
+          <a:noFill/>
+          <a:ln/>
+        </p:spPr>
+        <p:txBody>
+          <a:bodyPr wrap="square" lIns="0" tIns="0" rIns="0" bIns="0" rtlCol="0" anchor="t"/>
+          <a:lstStyle/>
+          <a:p>
+            <a:pPr marL="342900" indent="-342900">
+              <a:spcAft>
+                <a:spcPts val="1000"/>
+              </a:spcAft>
+              <a:buSzPct val="100000"/>
+              <a:buChar char="•"/>
+            </a:pPr>
+            <a:r>
+              <a:rPr lang="en-US" sz="1600" dirty="0">
+                <a:solidFill>
+                  <a:srgbClr val="1D2433"/>
+                </a:solidFill>
+                <a:latin typeface="Calibri" pitchFamily="34" charset="0"/>
+                <a:ea typeface="Calibri" pitchFamily="34" charset="-122"/>
+                <a:cs typeface="Calibri" pitchFamily="34" charset="-120"/>
+              </a:rPr>
+              <a:t>Nhận dạng từ toạ độ mới có ở trò chơi Thử thách và chỉ với toạ độ nguyên trên lưới.</a:t>
+            </a:r>
+            <a:endParaRPr lang="en-US" sz="1600" dirty="0"/>
+          </a:p>
+          <a:p>
+            <a:pPr marL="342900" indent="-342900">
+              <a:spcAft>
+                <a:spcPts val="1000"/>
+              </a:spcAft>
+              <a:buSzPct val="100000"/>
+              <a:buChar char="•"/>
+            </a:pPr>
+            <a:r>
+              <a:rPr lang="en-US" sz="1600" dirty="0">
+                <a:solidFill>
+                  <a:srgbClr val="1D2433"/>
+                </a:solidFill>
+                <a:latin typeface="Calibri" pitchFamily="34" charset="0"/>
+                <a:ea typeface="Calibri" pitchFamily="34" charset="-122"/>
+                <a:cs typeface="Calibri" pitchFamily="34" charset="-120"/>
+              </a:rPr>
+              <a:t>Chưa phân biệt từng cạnh cụ thể (AB, CD…) trong lời giải.</a:t>
+            </a:r>
+            <a:endParaRPr lang="en-US" sz="1600" dirty="0"/>
+          </a:p>
+          <a:p>
+            <a:pPr marL="342900" indent="-342900">
+              <a:spcAft>
+                <a:spcPts val="1000"/>
+              </a:spcAft>
+              <a:buSzPct val="100000"/>
+              <a:buChar char="•"/>
+            </a:pPr>
+            <a:r>
+              <a:rPr lang="en-US" sz="1600" dirty="0">
+                <a:solidFill>
+                  <a:srgbClr val="1D2433"/>
+                </a:solidFill>
+                <a:latin typeface="Calibri" pitchFamily="34" charset="0"/>
+                <a:ea typeface="Calibri" pitchFamily="34" charset="-122"/>
+                <a:cs typeface="Calibri" pitchFamily="34" charset="-120"/>
+              </a:rPr>
+              <a:t>Chỉ xét tứ giác lồi.</a:t>
+            </a:r>
+            <a:endParaRPr lang="en-US" sz="1600" dirty="0"/>
+          </a:p>
+        </p:txBody>
+      </p:sp>
+      <p:sp>
+        <p:nvSpPr>
+          <p:cNvPr id="10" name="Shape 8"/>
+          <p:cNvSpPr/>
+          <p:nvPr/>
+        </p:nvSpPr>
+        <p:spPr>
+          <a:xfrm>
+            <a:off x="6217920" y="1417320"/>
+            <a:ext cx="5440680" cy="4846320"/>
+          </a:xfrm>
+          <a:prstGeom prst="roundRect">
+            <a:avLst>
+              <a:gd name="adj" fmla="val 2264"/>
+            </a:avLst>
+          </a:prstGeom>
+          <a:solidFill>
+            <a:srgbClr val="E8EEFF"/>
+          </a:solidFill>
+          <a:ln w="9525">
+            <a:solidFill>
+              <a:srgbClr val="E8EEFF"/>
+            </a:solidFill>
+            <a:prstDash val="solid"/>
+          </a:ln>
+        </p:spPr>
+      </p:sp>
+      <p:sp>
+        <p:nvSpPr>
+          <p:cNvPr id="11" name="Text 9"/>
+          <p:cNvSpPr txBox="1"/>
+          <p:nvPr/>
+        </p:nvSpPr>
+        <p:spPr>
+          <a:xfrm>
+            <a:off x="6492240" y="1645920"/>
+            <a:ext cx="4846320" cy="457200"/>
+          </a:xfrm>
+          <a:prstGeom prst="rect">
+            <a:avLst/>
+          </a:prstGeom>
+          <a:noFill/>
+          <a:ln/>
+        </p:spPr>
+        <p:txBody>
+          <a:bodyPr wrap="square" lIns="0" tIns="0" rIns="0" bIns="0" rtlCol="0" anchor="t"/>
+          <a:lstStyle/>
+          <a:p>
+            <a:pPr indent="0" marL="0">
+              <a:buNone/>
+            </a:pPr>
+            <a:r>
+              <a:rPr lang="en-US" sz="2200" b="1" dirty="0">
+                <a:solidFill>
+                  <a:srgbClr val="2F5BEA"/>
+                </a:solidFill>
+                <a:latin typeface="Cambria" pitchFamily="34" charset="0"/>
+                <a:ea typeface="Cambria" pitchFamily="34" charset="-122"/>
+                <a:cs typeface="Cambria" pitchFamily="34" charset="-120"/>
+              </a:rPr>
+              <a:t>Hướng phát triển</a:t>
+            </a:r>
+            <a:endParaRPr lang="en-US" sz="2200" dirty="0"/>
+          </a:p>
+        </p:txBody>
+      </p:sp>
+      <p:sp>
+        <p:nvSpPr>
+          <p:cNvPr id="12" name="Text 10"/>
+          <p:cNvSpPr txBox="1"/>
+          <p:nvPr/>
+        </p:nvSpPr>
+        <p:spPr>
+          <a:xfrm>
+            <a:off x="6492240" y="2240280"/>
+            <a:ext cx="4937760" cy="3840480"/>
+          </a:xfrm>
+          <a:prstGeom prst="rect">
+            <a:avLst/>
+          </a:prstGeom>
+          <a:noFill/>
+          <a:ln/>
+        </p:spPr>
+        <p:txBody>
+          <a:bodyPr wrap="square" lIns="0" tIns="0" rIns="0" bIns="0" rtlCol="0" anchor="t"/>
+          <a:lstStyle/>
+          <a:p>
+            <a:pPr marL="342900" indent="-342900">
+              <a:spcAft>
+                <a:spcPts val="1000"/>
+              </a:spcAft>
+              <a:buSzPct val="100000"/>
+              <a:buChar char="•"/>
+            </a:pPr>
+            <a:r>
+              <a:rPr lang="en-US" sz="1600" dirty="0">
+                <a:solidFill>
+                  <a:srgbClr val="1D2433"/>
+                </a:solidFill>
+                <a:latin typeface="Calibri" pitchFamily="34" charset="0"/>
+                <a:ea typeface="Calibri" pitchFamily="34" charset="-122"/>
+                <a:cs typeface="Calibri" pitchFamily="34" charset="-120"/>
+              </a:rPr>
+              <a:t>Dùng toạ độ 4 đỉnh để tính luôn diện tích, chu vi; cho nhập toạ độ số thực.</a:t>
+            </a:r>
+            <a:endParaRPr lang="en-US" sz="1600" dirty="0"/>
+          </a:p>
+          <a:p>
+            <a:pPr marL="342900" indent="-342900">
+              <a:spcAft>
+                <a:spcPts val="1000"/>
+              </a:spcAft>
+              <a:buSzPct val="100000"/>
+              <a:buChar char="•"/>
+            </a:pPr>
+            <a:r>
+              <a:rPr lang="en-US" sz="1600" dirty="0">
+                <a:solidFill>
+                  <a:srgbClr val="1D2433"/>
+                </a:solidFill>
+                <a:latin typeface="Calibri" pitchFamily="34" charset="0"/>
+                <a:ea typeface="Calibri" pitchFamily="34" charset="-122"/>
+                <a:cs typeface="Calibri" pitchFamily="34" charset="-120"/>
+              </a:rPr>
+              <a:t>Thêm nút :Canh, :Goc, :DuongCheo để lời giải chi tiết như bài làm của học sinh.</a:t>
+            </a:r>
+            <a:endParaRPr lang="en-US" sz="1600" dirty="0"/>
+          </a:p>
+          <a:p>
+            <a:pPr marL="342900" indent="-342900">
+              <a:spcAft>
+                <a:spcPts val="1000"/>
+              </a:spcAft>
+              <a:buSzPct val="100000"/>
+              <a:buChar char="•"/>
+            </a:pPr>
+            <a:r>
+              <a:rPr lang="en-US" sz="1600" dirty="0">
+                <a:solidFill>
+                  <a:srgbClr val="1D2433"/>
+                </a:solidFill>
+                <a:latin typeface="Calibri" pitchFamily="34" charset="0"/>
+                <a:ea typeface="Calibri" pitchFamily="34" charset="-122"/>
+                <a:cs typeface="Calibri" pitchFamily="34" charset="-120"/>
+              </a:rPr>
+              <a:t>Mở rộng sang tam giác, đa giác.</a:t>
+            </a:r>
+            <a:endParaRPr lang="en-US" sz="1600" dirty="0"/>
+          </a:p>
+          <a:p>
+            <a:pPr marL="342900" indent="-342900">
+              <a:spcAft>
+                <a:spcPts val="1000"/>
+              </a:spcAft>
+              <a:buSzPct val="100000"/>
+              <a:buChar char="•"/>
+            </a:pPr>
+            <a:r>
+              <a:rPr lang="en-US" sz="1600" dirty="0">
+                <a:solidFill>
+                  <a:srgbClr val="1D2433"/>
+                </a:solidFill>
+                <a:latin typeface="Calibri" pitchFamily="34" charset="0"/>
+                <a:ea typeface="Calibri" pitchFamily="34" charset="-122"/>
+                <a:cs typeface="Calibri" pitchFamily="34" charset="-120"/>
+              </a:rPr>
+              <a:t>Mở rộng lượt chơi (:LuotChoi) thành hồ sơ người học để gợi ý thử thách, bài tập.</a:t>
+            </a:r>
+            <a:endParaRPr lang="en-US" sz="1600" dirty="0"/>
+          </a:p>
+        </p:txBody>
+      </p:sp>
+    </p:spTree>
+  </p:cSld>
+  <p:clrMapOvr>
+    <a:masterClrMapping/>
+  </p:clrMapOvr>
+</p:sld>
+</file>
+
+<file path=ppt/slides/slide19.xml><?xml version="1.0" encoding="utf-8"?>
+<p:sld xmlns:a="http://schemas.openxmlformats.org/drawingml/2006/main" xmlns:r="http://schemas.openxmlformats.org/officeDocument/2006/relationships" xmlns:p="http://schemas.openxmlformats.org/presentationml/2006/main">
+  <p:cSld name="Slide 19">
     <p:bg>
       <p:bgPr>
         <a:solidFill>

</xml_diff>

<commit_message>
Sua so do phan cap
</commit_message>
<xml_diff>
--- a/docs/3_Thuyet_trinh.pptx
+++ b/docs/3_Thuyet_trinh.pptx
@@ -2801,8 +2801,8 @@
         </p:blipFill>
         <p:spPr>
           <a:xfrm>
-            <a:off x="7726680" y="1737360"/>
-            <a:ext cx="3840480" cy="2203039"/>
+            <a:off x="8083296" y="1627632"/>
+            <a:ext cx="3123801" cy="2651760"/>
           </a:xfrm>
           <a:prstGeom prst="rect">
             <a:avLst/>
@@ -16033,8 +16033,8 @@
         </p:blipFill>
         <p:spPr>
           <a:xfrm>
-            <a:off x="685800" y="1828800"/>
-            <a:ext cx="6675120" cy="3829092"/>
+            <a:off x="1371600" y="1645920"/>
+            <a:ext cx="5278147" cy="4480560"/>
           </a:xfrm>
           <a:prstGeom prst="rect">
             <a:avLst/>
@@ -16337,7 +16337,7 @@
                 <a:ea typeface="Calibri" pitchFamily="34" charset="-122"/>
                 <a:cs typeface="Calibri" pitchFamily="34" charset="-120"/>
               </a:rPr>
-              <a:t>Mũi tên đi từ hình đặc biệt lên hình tổng quát hơn</a:t>
+              <a:t>Hình con là trường hợp đặc biệt của hình cha; trên sơ đồ mũi tên đi từ cha xuống con</a:t>
             </a:r>
             <a:endParaRPr lang="en-US" sz="1250" dirty="0"/>
           </a:p>
@@ -22445,8 +22445,8 @@
         </p:blipFill>
         <p:spPr>
           <a:xfrm>
-            <a:off x="6492240" y="4023360"/>
-            <a:ext cx="3657600" cy="2098132"/>
+            <a:off x="7040880" y="4005072"/>
+            <a:ext cx="2585215" cy="2194560"/>
           </a:xfrm>
           <a:prstGeom prst="rect">
             <a:avLst/>

</xml_diff>